<commit_message>
Project2 fix and improvement in ppt and pdf
</commit_message>
<xml_diff>
--- a/presentation/Proj2-Observability-Deep-Dive.pptx
+++ b/presentation/Proj2-Observability-Deep-Dive.pptx
@@ -143,7 +143,7 @@
       </p:grpSpPr>
       <p:sp>
         <p:nvSpPr>
-          <p:cNvPr id="366534093" name="Header Placeholder 1"/>
+          <p:cNvPr id="1065201538" name="Header Placeholder 1"/>
           <p:cNvSpPr>
             <a:spLocks noGrp="1"/>
           </p:cNvSpPr>
@@ -177,7 +177,7 @@
       </p:sp>
       <p:sp>
         <p:nvSpPr>
-          <p:cNvPr id="53357265" name="Date Placeholder 2"/>
+          <p:cNvPr id="568215508" name="Date Placeholder 2"/>
           <p:cNvSpPr>
             <a:spLocks noGrp="1"/>
           </p:cNvSpPr>
@@ -215,7 +215,7 @@
       </p:sp>
       <p:sp>
         <p:nvSpPr>
-          <p:cNvPr id="1816915361" name="Slide Image Placeholder 3"/>
+          <p:cNvPr id="374535639" name="Slide Image Placeholder 3"/>
           <p:cNvSpPr>
             <a:spLocks noChangeAspect="1" noGrp="1" noRot="1"/>
           </p:cNvSpPr>
@@ -251,7 +251,7 @@
       </p:sp>
       <p:sp>
         <p:nvSpPr>
-          <p:cNvPr id="2049032323" name="Notes Placeholder 4"/>
+          <p:cNvPr id="1127903957" name="Notes Placeholder 4"/>
           <p:cNvSpPr>
             <a:spLocks noGrp="1"/>
           </p:cNvSpPr>
@@ -325,7 +325,7 @@
       </p:sp>
       <p:sp>
         <p:nvSpPr>
-          <p:cNvPr id="394554608" name="Footer Placeholder 5"/>
+          <p:cNvPr id="1754574714" name="Footer Placeholder 5"/>
           <p:cNvSpPr>
             <a:spLocks noGrp="1"/>
           </p:cNvSpPr>
@@ -359,7 +359,7 @@
       </p:sp>
       <p:sp>
         <p:nvSpPr>
-          <p:cNvPr id="2021472685" name="Slide Number Placeholder 6"/>
+          <p:cNvPr id="1296659396" name="Slide Number Placeholder 6"/>
           <p:cNvSpPr>
             <a:spLocks noGrp="1"/>
           </p:cNvSpPr>
@@ -512,7 +512,7 @@
       </p:grpSpPr>
       <p:sp>
         <p:nvSpPr>
-          <p:cNvPr id="2098241769" name="Slide Image Placeholder 1"/>
+          <p:cNvPr id="742712706" name="Slide Image Placeholder 1"/>
           <p:cNvSpPr>
             <a:spLocks noChangeAspect="1" noGrp="1" noRot="1"/>
           </p:cNvSpPr>
@@ -524,7 +524,7 @@
       </p:sp>
       <p:sp>
         <p:nvSpPr>
-          <p:cNvPr id="517362181" name="Notes Placeholder 2"/>
+          <p:cNvPr id="130051816" name="Notes Placeholder 2"/>
           <p:cNvSpPr>
             <a:spLocks noGrp="1"/>
           </p:cNvSpPr>
@@ -546,7 +546,7 @@
       </p:sp>
       <p:sp>
         <p:nvSpPr>
-          <p:cNvPr id="715849743" name="Slide Number Placeholder 3"/>
+          <p:cNvPr id="1928438998" name="Slide Number Placeholder 3"/>
           <p:cNvSpPr>
             <a:spLocks noGrp="1"/>
           </p:cNvSpPr>
@@ -597,7 +597,7 @@
       </p:grpSpPr>
       <p:sp>
         <p:nvSpPr>
-          <p:cNvPr id="373939133" name="Slide Image Placeholder 1"/>
+          <p:cNvPr id="556692178" name="Slide Image Placeholder 1"/>
           <p:cNvSpPr>
             <a:spLocks noChangeAspect="1" noGrp="1" noRot="1"/>
           </p:cNvSpPr>
@@ -609,7 +609,7 @@
       </p:sp>
       <p:sp>
         <p:nvSpPr>
-          <p:cNvPr id="2119214283" name="Notes Placeholder 2"/>
+          <p:cNvPr id="995417998" name="Notes Placeholder 2"/>
           <p:cNvSpPr>
             <a:spLocks noGrp="1"/>
           </p:cNvSpPr>
@@ -631,7 +631,7 @@
       </p:sp>
       <p:sp>
         <p:nvSpPr>
-          <p:cNvPr id="1401669230" name="Slide Number Placeholder 3"/>
+          <p:cNvPr id="182972796" name="Slide Number Placeholder 3"/>
           <p:cNvSpPr>
             <a:spLocks noGrp="1"/>
           </p:cNvSpPr>
@@ -682,7 +682,7 @@
       </p:grpSpPr>
       <p:sp>
         <p:nvSpPr>
-          <p:cNvPr id="2100875830" name="Slide Image Placeholder 1"/>
+          <p:cNvPr id="2128804161" name="Slide Image Placeholder 1"/>
           <p:cNvSpPr>
             <a:spLocks noChangeAspect="1" noGrp="1" noRot="1"/>
           </p:cNvSpPr>
@@ -694,7 +694,7 @@
       </p:sp>
       <p:sp>
         <p:nvSpPr>
-          <p:cNvPr id="331586207" name="Notes Placeholder 2"/>
+          <p:cNvPr id="1787438369" name="Notes Placeholder 2"/>
           <p:cNvSpPr>
             <a:spLocks noGrp="1"/>
           </p:cNvSpPr>
@@ -716,7 +716,7 @@
       </p:sp>
       <p:sp>
         <p:nvSpPr>
-          <p:cNvPr id="245057780" name="Slide Number Placeholder 3"/>
+          <p:cNvPr id="2033750410" name="Slide Number Placeholder 3"/>
           <p:cNvSpPr>
             <a:spLocks noGrp="1"/>
           </p:cNvSpPr>
@@ -767,7 +767,7 @@
       </p:grpSpPr>
       <p:sp>
         <p:nvSpPr>
-          <p:cNvPr id="1240106986" name="Slide Image Placeholder 1"/>
+          <p:cNvPr id="842463104" name="Slide Image Placeholder 1"/>
           <p:cNvSpPr>
             <a:spLocks noChangeAspect="1" noGrp="1" noRot="1"/>
           </p:cNvSpPr>
@@ -779,7 +779,7 @@
       </p:sp>
       <p:sp>
         <p:nvSpPr>
-          <p:cNvPr id="760396962" name="Notes Placeholder 2"/>
+          <p:cNvPr id="486765285" name="Notes Placeholder 2"/>
           <p:cNvSpPr>
             <a:spLocks noGrp="1"/>
           </p:cNvSpPr>
@@ -801,7 +801,7 @@
       </p:sp>
       <p:sp>
         <p:nvSpPr>
-          <p:cNvPr id="1791239599" name="Slide Number Placeholder 3"/>
+          <p:cNvPr id="1708859877" name="Slide Number Placeholder 3"/>
           <p:cNvSpPr>
             <a:spLocks noGrp="1"/>
           </p:cNvSpPr>
@@ -852,7 +852,7 @@
       </p:grpSpPr>
       <p:sp>
         <p:nvSpPr>
-          <p:cNvPr id="360357792" name="Slide Image Placeholder 1"/>
+          <p:cNvPr id="554393411" name="Slide Image Placeholder 1"/>
           <p:cNvSpPr>
             <a:spLocks noChangeAspect="1" noGrp="1" noRot="1"/>
           </p:cNvSpPr>
@@ -864,7 +864,7 @@
       </p:sp>
       <p:sp>
         <p:nvSpPr>
-          <p:cNvPr id="1941399395" name="Notes Placeholder 2"/>
+          <p:cNvPr id="489971003" name="Notes Placeholder 2"/>
           <p:cNvSpPr>
             <a:spLocks noGrp="1"/>
           </p:cNvSpPr>
@@ -886,7 +886,7 @@
       </p:sp>
       <p:sp>
         <p:nvSpPr>
-          <p:cNvPr id="1150171400" name="Slide Number Placeholder 3"/>
+          <p:cNvPr id="1152813147" name="Slide Number Placeholder 3"/>
           <p:cNvSpPr>
             <a:spLocks noGrp="1"/>
           </p:cNvSpPr>
@@ -937,7 +937,7 @@
       </p:grpSpPr>
       <p:sp>
         <p:nvSpPr>
-          <p:cNvPr id="707252263" name="Slide Image Placeholder 1"/>
+          <p:cNvPr id="1156018777" name="Slide Image Placeholder 1"/>
           <p:cNvSpPr>
             <a:spLocks noChangeAspect="1" noGrp="1" noRot="1"/>
           </p:cNvSpPr>
@@ -949,7 +949,7 @@
       </p:sp>
       <p:sp>
         <p:nvSpPr>
-          <p:cNvPr id="1585403835" name="Notes Placeholder 2"/>
+          <p:cNvPr id="1960867237" name="Notes Placeholder 2"/>
           <p:cNvSpPr>
             <a:spLocks noGrp="1"/>
           </p:cNvSpPr>
@@ -971,7 +971,7 @@
       </p:sp>
       <p:sp>
         <p:nvSpPr>
-          <p:cNvPr id="322491387" name="Slide Number Placeholder 3"/>
+          <p:cNvPr id="1201468277" name="Slide Number Placeholder 3"/>
           <p:cNvSpPr>
             <a:spLocks noGrp="1"/>
           </p:cNvSpPr>
@@ -1022,7 +1022,7 @@
       </p:grpSpPr>
       <p:sp>
         <p:nvSpPr>
-          <p:cNvPr id="694721402" name="Slide Image Placeholder 1"/>
+          <p:cNvPr id="103268517" name="Slide Image Placeholder 1"/>
           <p:cNvSpPr>
             <a:spLocks noChangeAspect="1" noGrp="1" noRot="1"/>
           </p:cNvSpPr>
@@ -1034,7 +1034,7 @@
       </p:sp>
       <p:sp>
         <p:nvSpPr>
-          <p:cNvPr id="1641222684" name="Notes Placeholder 2"/>
+          <p:cNvPr id="1629116461" name="Notes Placeholder 2"/>
           <p:cNvSpPr>
             <a:spLocks noGrp="1"/>
           </p:cNvSpPr>
@@ -1060,7 +1060,7 @@
       </p:sp>
       <p:sp>
         <p:nvSpPr>
-          <p:cNvPr id="1861294867" name="Slide Number Placeholder 3"/>
+          <p:cNvPr id="159646275" name="Slide Number Placeholder 3"/>
           <p:cNvSpPr>
             <a:spLocks noGrp="1"/>
           </p:cNvSpPr>
@@ -1111,7 +1111,7 @@
       </p:grpSpPr>
       <p:sp>
         <p:nvSpPr>
-          <p:cNvPr id="1292032057" name="Slide Image Placeholder 1"/>
+          <p:cNvPr id="1854619510" name="Slide Image Placeholder 1"/>
           <p:cNvSpPr>
             <a:spLocks noChangeAspect="1" noGrp="1" noRot="1"/>
           </p:cNvSpPr>
@@ -1123,7 +1123,7 @@
       </p:sp>
       <p:sp>
         <p:nvSpPr>
-          <p:cNvPr id="279814042" name="Notes Placeholder 2"/>
+          <p:cNvPr id="1740728359" name="Notes Placeholder 2"/>
           <p:cNvSpPr>
             <a:spLocks noGrp="1"/>
           </p:cNvSpPr>
@@ -1145,7 +1145,7 @@
       </p:sp>
       <p:sp>
         <p:nvSpPr>
-          <p:cNvPr id="586737118" name="Slide Number Placeholder 3"/>
+          <p:cNvPr id="473170661" name="Slide Number Placeholder 3"/>
           <p:cNvSpPr>
             <a:spLocks noGrp="1"/>
           </p:cNvSpPr>
@@ -1196,7 +1196,7 @@
       </p:grpSpPr>
       <p:sp>
         <p:nvSpPr>
-          <p:cNvPr id="1022602509" name="Slide Image Placeholder 1"/>
+          <p:cNvPr id="117706251" name="Slide Image Placeholder 1"/>
           <p:cNvSpPr>
             <a:spLocks noChangeAspect="1" noGrp="1" noRot="1"/>
           </p:cNvSpPr>
@@ -1208,7 +1208,7 @@
       </p:sp>
       <p:sp>
         <p:nvSpPr>
-          <p:cNvPr id="1655749474" name="Notes Placeholder 2"/>
+          <p:cNvPr id="1084642136" name="Notes Placeholder 2"/>
           <p:cNvSpPr>
             <a:spLocks noGrp="1"/>
           </p:cNvSpPr>
@@ -1230,7 +1230,7 @@
       </p:sp>
       <p:sp>
         <p:nvSpPr>
-          <p:cNvPr id="2133734440" name="Slide Number Placeholder 3"/>
+          <p:cNvPr id="804899876" name="Slide Number Placeholder 3"/>
           <p:cNvSpPr>
             <a:spLocks noGrp="1"/>
           </p:cNvSpPr>
@@ -1281,7 +1281,7 @@
       </p:grpSpPr>
       <p:sp>
         <p:nvSpPr>
-          <p:cNvPr id="469180860" name="Slide Image Placeholder 1"/>
+          <p:cNvPr id="1674434707" name="Slide Image Placeholder 1"/>
           <p:cNvSpPr>
             <a:spLocks noChangeAspect="1" noGrp="1" noRot="1"/>
           </p:cNvSpPr>
@@ -1293,7 +1293,7 @@
       </p:sp>
       <p:sp>
         <p:nvSpPr>
-          <p:cNvPr id="1524697517" name="Notes Placeholder 2"/>
+          <p:cNvPr id="237739029" name="Notes Placeholder 2"/>
           <p:cNvSpPr>
             <a:spLocks noGrp="1"/>
           </p:cNvSpPr>
@@ -1315,7 +1315,7 @@
       </p:sp>
       <p:sp>
         <p:nvSpPr>
-          <p:cNvPr id="2036122532" name="Slide Number Placeholder 3"/>
+          <p:cNvPr id="982418031" name="Slide Number Placeholder 3"/>
           <p:cNvSpPr>
             <a:spLocks noGrp="1"/>
           </p:cNvSpPr>
@@ -1366,7 +1366,7 @@
       </p:grpSpPr>
       <p:sp>
         <p:nvSpPr>
-          <p:cNvPr id="1511820742" name="Slide Image Placeholder 1"/>
+          <p:cNvPr id="313600353" name="Slide Image Placeholder 1"/>
           <p:cNvSpPr>
             <a:spLocks noChangeAspect="1" noGrp="1" noRot="1"/>
           </p:cNvSpPr>
@@ -1378,7 +1378,7 @@
       </p:sp>
       <p:sp>
         <p:nvSpPr>
-          <p:cNvPr id="417425398" name="Notes Placeholder 2"/>
+          <p:cNvPr id="685217000" name="Notes Placeholder 2"/>
           <p:cNvSpPr>
             <a:spLocks noGrp="1"/>
           </p:cNvSpPr>
@@ -1400,7 +1400,7 @@
       </p:sp>
       <p:sp>
         <p:nvSpPr>
-          <p:cNvPr id="1429500407" name="Slide Number Placeholder 3"/>
+          <p:cNvPr id="436868919" name="Slide Number Placeholder 3"/>
           <p:cNvSpPr>
             <a:spLocks noGrp="1"/>
           </p:cNvSpPr>
@@ -1451,7 +1451,7 @@
       </p:grpSpPr>
       <p:sp>
         <p:nvSpPr>
-          <p:cNvPr id="274473739" name="Slide Image Placeholder 1"/>
+          <p:cNvPr id="902034954" name="Slide Image Placeholder 1"/>
           <p:cNvSpPr>
             <a:spLocks noChangeAspect="1" noGrp="1" noRot="1"/>
           </p:cNvSpPr>
@@ -1463,7 +1463,7 @@
       </p:sp>
       <p:sp>
         <p:nvSpPr>
-          <p:cNvPr id="977083349" name="Notes Placeholder 2"/>
+          <p:cNvPr id="153593657" name="Notes Placeholder 2"/>
           <p:cNvSpPr>
             <a:spLocks noGrp="1"/>
           </p:cNvSpPr>
@@ -1485,7 +1485,7 @@
       </p:sp>
       <p:sp>
         <p:nvSpPr>
-          <p:cNvPr id="1321316173" name="Slide Number Placeholder 3"/>
+          <p:cNvPr id="1161571662" name="Slide Number Placeholder 3"/>
           <p:cNvSpPr>
             <a:spLocks noGrp="1"/>
           </p:cNvSpPr>
@@ -1536,7 +1536,7 @@
       </p:grpSpPr>
       <p:sp>
         <p:nvSpPr>
-          <p:cNvPr id="233855565" name="Slide Image Placeholder 1"/>
+          <p:cNvPr id="527043288" name="Slide Image Placeholder 1"/>
           <p:cNvSpPr>
             <a:spLocks noChangeAspect="1" noGrp="1" noRot="1"/>
           </p:cNvSpPr>
@@ -1548,7 +1548,7 @@
       </p:sp>
       <p:sp>
         <p:nvSpPr>
-          <p:cNvPr id="917369319" name="Notes Placeholder 2"/>
+          <p:cNvPr id="994032670" name="Notes Placeholder 2"/>
           <p:cNvSpPr>
             <a:spLocks noGrp="1"/>
           </p:cNvSpPr>
@@ -1570,7 +1570,7 @@
       </p:sp>
       <p:sp>
         <p:nvSpPr>
-          <p:cNvPr id="1361139064" name="Slide Number Placeholder 3"/>
+          <p:cNvPr id="1474114137" name="Slide Number Placeholder 3"/>
           <p:cNvSpPr>
             <a:spLocks noGrp="1"/>
           </p:cNvSpPr>
@@ -1935,7 +1935,7 @@
       </p:grpSpPr>
       <p:pic>
         <p:nvPicPr>
-          <p:cNvPr id="325716637" name="Image 0" descr="preencoded.png"/>
+          <p:cNvPr id="1240609177" name="Image 0" descr="preencoded.png"/>
           <p:cNvPicPr>
             <a:picLocks noChangeAspect="1"/>
           </p:cNvPicPr>
@@ -1957,7 +1957,7 @@
       </p:pic>
       <p:sp>
         <p:nvSpPr>
-          <p:cNvPr id="1884454679" name="Text 0"/>
+          <p:cNvPr id="1134853824" name="Text 0"/>
           <p:cNvSpPr txBox="1"/>
           <p:nvPr/>
         </p:nvSpPr>
@@ -1988,7 +1988,7 @@
       </p:sp>
       <p:sp>
         <p:nvSpPr>
-          <p:cNvPr id="1384620847" name="Shape 1"/>
+          <p:cNvPr id="1528874424" name="Shape 1"/>
           <p:cNvSpPr/>
           <p:nvPr/>
         </p:nvSpPr>
@@ -2008,7 +2008,7 @@
       </p:sp>
       <p:sp>
         <p:nvSpPr>
-          <p:cNvPr id="880115422" name="Text 2"/>
+          <p:cNvPr id="1971675587" name="Text 2"/>
           <p:cNvSpPr txBox="1"/>
           <p:nvPr/>
         </p:nvSpPr>
@@ -2078,7 +2078,7 @@
       </p:sp>
       <p:sp>
         <p:nvSpPr>
-          <p:cNvPr id="985687689" name="Text 3"/>
+          <p:cNvPr id="922077354" name="Text 3"/>
           <p:cNvSpPr txBox="1"/>
           <p:nvPr/>
         </p:nvSpPr>
@@ -2141,7 +2141,7 @@
       </p:sp>
       <p:pic>
         <p:nvPicPr>
-          <p:cNvPr id="1304266084" name="Image 1" descr="preencoded.png"/>
+          <p:cNvPr id="904051130" name="Image 1" descr="preencoded.png"/>
           <p:cNvPicPr>
             <a:picLocks noChangeAspect="1"/>
           </p:cNvPicPr>
@@ -2163,7 +2163,7 @@
       </p:pic>
       <p:sp>
         <p:nvSpPr>
-          <p:cNvPr id="1243463838" name="Text 4"/>
+          <p:cNvPr id="220938188" name="Text 4"/>
           <p:cNvSpPr txBox="1"/>
           <p:nvPr/>
         </p:nvSpPr>
@@ -2224,7 +2224,7 @@
       </p:sp>
       <p:pic>
         <p:nvPicPr>
-          <p:cNvPr id="906755850" name="Image 2" descr="preencoded.png"/>
+          <p:cNvPr id="1240002917" name="Image 2" descr="preencoded.png"/>
           <p:cNvPicPr>
             <a:picLocks noChangeAspect="1"/>
           </p:cNvPicPr>
@@ -2246,7 +2246,7 @@
       </p:pic>
       <p:sp>
         <p:nvSpPr>
-          <p:cNvPr id="995597439" name="Text 5"/>
+          <p:cNvPr id="1264234310" name="Text 5"/>
           <p:cNvSpPr txBox="1"/>
           <p:nvPr/>
         </p:nvSpPr>
@@ -2328,7 +2328,7 @@
       </p:grpSpPr>
       <p:sp>
         <p:nvSpPr>
-          <p:cNvPr id="37179006" name="Text 0"/>
+          <p:cNvPr id="557609916" name="Text 0"/>
           <p:cNvSpPr txBox="1"/>
           <p:nvPr/>
         </p:nvSpPr>
@@ -2378,7 +2378,7 @@
       </p:sp>
       <p:pic>
         <p:nvPicPr>
-          <p:cNvPr id="1891712705" name="Image 0" descr="preencoded.png"/>
+          <p:cNvPr id="1390598263" name="Image 0" descr="preencoded.png"/>
           <p:cNvPicPr>
             <a:picLocks noChangeAspect="1"/>
           </p:cNvPicPr>
@@ -2400,7 +2400,7 @@
       </p:pic>
       <p:sp>
         <p:nvSpPr>
-          <p:cNvPr id="292167856" name="Text 1"/>
+          <p:cNvPr id="648570426" name="Text 1"/>
           <p:cNvSpPr txBox="1"/>
           <p:nvPr/>
         </p:nvSpPr>
@@ -2445,7 +2445,7 @@
       </p:sp>
       <p:sp>
         <p:nvSpPr>
-          <p:cNvPr id="556874629" name="Text 2"/>
+          <p:cNvPr id="456140690" name="Text 2"/>
           <p:cNvSpPr txBox="1"/>
           <p:nvPr/>
         </p:nvSpPr>
@@ -2497,7 +2497,7 @@
       </p:sp>
       <p:pic>
         <p:nvPicPr>
-          <p:cNvPr id="472900280" name="Image 1" descr="preencoded.png"/>
+          <p:cNvPr id="1853586511" name="Image 1" descr="preencoded.png"/>
           <p:cNvPicPr>
             <a:picLocks noChangeAspect="1"/>
           </p:cNvPicPr>
@@ -2519,7 +2519,7 @@
       </p:pic>
       <p:sp>
         <p:nvSpPr>
-          <p:cNvPr id="1929457719" name="Text 3"/>
+          <p:cNvPr id="1966536712" name="Text 3"/>
           <p:cNvSpPr txBox="1"/>
           <p:nvPr/>
         </p:nvSpPr>
@@ -2564,7 +2564,7 @@
       </p:sp>
       <p:sp>
         <p:nvSpPr>
-          <p:cNvPr id="1091122813" name="Text 4"/>
+          <p:cNvPr id="1081191372" name="Text 4"/>
           <p:cNvSpPr txBox="1"/>
           <p:nvPr/>
         </p:nvSpPr>
@@ -2608,7 +2608,7 @@
       </p:sp>
       <p:pic>
         <p:nvPicPr>
-          <p:cNvPr id="595467186" name="Image 3" descr="preencoded.png"/>
+          <p:cNvPr id="559204969" name="Image 3" descr="preencoded.png"/>
           <p:cNvPicPr>
             <a:picLocks noChangeAspect="1"/>
           </p:cNvPicPr>
@@ -2630,7 +2630,7 @@
       </p:pic>
       <p:sp>
         <p:nvSpPr>
-          <p:cNvPr id="1283486187" name="Text 7"/>
+          <p:cNvPr id="1129246059" name="Text 7"/>
           <p:cNvSpPr txBox="1"/>
           <p:nvPr/>
         </p:nvSpPr>
@@ -2661,7 +2661,7 @@
       </p:sp>
       <p:sp>
         <p:nvSpPr>
-          <p:cNvPr id="2119201055" name="Text 8"/>
+          <p:cNvPr id="1696275484" name="Text 8"/>
           <p:cNvSpPr txBox="1"/>
           <p:nvPr/>
         </p:nvSpPr>
@@ -2706,7 +2706,7 @@
       </p:sp>
       <p:sp>
         <p:nvSpPr>
-          <p:cNvPr id="975719635" name="Text 9"/>
+          <p:cNvPr id="1526972033" name="Text 9"/>
           <p:cNvSpPr txBox="1"/>
           <p:nvPr/>
         </p:nvSpPr>
@@ -2751,7 +2751,7 @@
       </p:sp>
       <p:sp>
         <p:nvSpPr>
-          <p:cNvPr id="1223919339" name="Text 10"/>
+          <p:cNvPr id="1556235889" name="Text 10"/>
           <p:cNvSpPr txBox="1"/>
           <p:nvPr/>
         </p:nvSpPr>
@@ -2795,7 +2795,7 @@
       </p:sp>
       <p:pic>
         <p:nvPicPr>
-          <p:cNvPr id="457318115" name="Image 4" descr="preencoded.png"/>
+          <p:cNvPr id="790683732" name="Image 4" descr="preencoded.png"/>
           <p:cNvPicPr>
             <a:picLocks noChangeAspect="1"/>
           </p:cNvPicPr>
@@ -2817,7 +2817,7 @@
       </p:pic>
       <p:sp>
         <p:nvSpPr>
-          <p:cNvPr id="1386262369" name="Text 11"/>
+          <p:cNvPr id="1702203045" name="Text 11"/>
           <p:cNvSpPr txBox="1"/>
           <p:nvPr/>
         </p:nvSpPr>
@@ -2861,7 +2861,7 @@
       </p:sp>
       <p:pic>
         <p:nvPicPr>
-          <p:cNvPr id="1648922159" name="Image 5" descr="preencoded.png"/>
+          <p:cNvPr id="1771771698" name="Image 5" descr="preencoded.png"/>
           <p:cNvPicPr>
             <a:picLocks noChangeAspect="1"/>
           </p:cNvPicPr>
@@ -2883,7 +2883,7 @@
       </p:pic>
       <p:sp>
         <p:nvSpPr>
-          <p:cNvPr id="392180301" name="Text 12"/>
+          <p:cNvPr id="1634651189" name="Text 12"/>
           <p:cNvSpPr txBox="1"/>
           <p:nvPr/>
         </p:nvSpPr>
@@ -2927,7 +2927,7 @@
       </p:sp>
       <p:pic>
         <p:nvPicPr>
-          <p:cNvPr id="1978264488" name="Image 6" descr="preencoded.png"/>
+          <p:cNvPr id="1995109989" name="Image 6" descr="preencoded.png"/>
           <p:cNvPicPr>
             <a:picLocks noChangeAspect="1"/>
           </p:cNvPicPr>
@@ -2949,7 +2949,7 @@
       </p:pic>
       <p:sp>
         <p:nvSpPr>
-          <p:cNvPr id="2049441948" name="Text 13"/>
+          <p:cNvPr id="788729658" name="Text 13"/>
           <p:cNvSpPr txBox="1"/>
           <p:nvPr/>
         </p:nvSpPr>
@@ -2993,7 +2993,7 @@
       </p:sp>
       <p:pic>
         <p:nvPicPr>
-          <p:cNvPr id="1083175447" name="Image 7" descr="preencoded.png"/>
+          <p:cNvPr id="1530304340" name="Image 7" descr="preencoded.png"/>
           <p:cNvPicPr>
             <a:picLocks noChangeAspect="1"/>
           </p:cNvPicPr>
@@ -3015,7 +3015,7 @@
       </p:pic>
       <p:sp>
         <p:nvSpPr>
-          <p:cNvPr id="680083754" name="Text 14"/>
+          <p:cNvPr id="1383311611" name="Text 14"/>
           <p:cNvSpPr txBox="1"/>
           <p:nvPr/>
         </p:nvSpPr>
@@ -3059,7 +3059,7 @@
       </p:sp>
       <p:pic>
         <p:nvPicPr>
-          <p:cNvPr id="710454915" name="Image 8" descr="preencoded.png"/>
+          <p:cNvPr id="925506961" name="Image 8" descr="preencoded.png"/>
           <p:cNvPicPr>
             <a:picLocks noChangeAspect="1"/>
           </p:cNvPicPr>
@@ -3081,7 +3081,7 @@
       </p:pic>
       <p:sp>
         <p:nvSpPr>
-          <p:cNvPr id="448480150" name="Text 15"/>
+          <p:cNvPr id="2143844412" name="Text 15"/>
           <p:cNvSpPr txBox="1"/>
           <p:nvPr/>
         </p:nvSpPr>
@@ -3112,7 +3112,7 @@
       </p:sp>
       <p:sp>
         <p:nvSpPr>
-          <p:cNvPr id="1461337025" name="Text 16"/>
+          <p:cNvPr id="795766197" name="Text 16"/>
           <p:cNvSpPr txBox="1"/>
           <p:nvPr/>
         </p:nvSpPr>
@@ -3157,7 +3157,7 @@
       </p:sp>
       <p:sp>
         <p:nvSpPr>
-          <p:cNvPr id="1540631370" name="Text 17"/>
+          <p:cNvPr id="719952926" name="Text 17"/>
           <p:cNvSpPr txBox="1"/>
           <p:nvPr/>
         </p:nvSpPr>
@@ -3202,7 +3202,7 @@
       </p:sp>
       <p:sp>
         <p:nvSpPr>
-          <p:cNvPr id="1794853249" name="Text 18"/>
+          <p:cNvPr id="1723277994" name="Text 18"/>
           <p:cNvSpPr txBox="1"/>
           <p:nvPr/>
         </p:nvSpPr>
@@ -3246,7 +3246,7 @@
       </p:sp>
       <p:pic>
         <p:nvPicPr>
-          <p:cNvPr id="1528533999" name="Image 9" descr="preencoded.png"/>
+          <p:cNvPr id="1660952114" name="Image 9" descr="preencoded.png"/>
           <p:cNvPicPr>
             <a:picLocks noChangeAspect="1"/>
           </p:cNvPicPr>
@@ -3268,7 +3268,7 @@
       </p:pic>
       <p:sp>
         <p:nvSpPr>
-          <p:cNvPr id="1321563589" name="Text 19"/>
+          <p:cNvPr id="1818341125" name="Text 19"/>
           <p:cNvSpPr txBox="1"/>
           <p:nvPr/>
         </p:nvSpPr>
@@ -3312,7 +3312,7 @@
       </p:sp>
       <p:pic>
         <p:nvPicPr>
-          <p:cNvPr id="1441051214" name="Image 10" descr="preencoded.png"/>
+          <p:cNvPr id="1480440501" name="Image 10" descr="preencoded.png"/>
           <p:cNvPicPr>
             <a:picLocks noChangeAspect="1"/>
           </p:cNvPicPr>
@@ -3334,7 +3334,7 @@
       </p:pic>
       <p:sp>
         <p:nvSpPr>
-          <p:cNvPr id="397752642" name="Text 20"/>
+          <p:cNvPr id="540680581" name="Text 20"/>
           <p:cNvSpPr txBox="1"/>
           <p:nvPr/>
         </p:nvSpPr>
@@ -3378,7 +3378,7 @@
       </p:sp>
       <p:pic>
         <p:nvPicPr>
-          <p:cNvPr id="121864097" name="Image 11" descr="preencoded.png"/>
+          <p:cNvPr id="137730957" name="Image 11" descr="preencoded.png"/>
           <p:cNvPicPr>
             <a:picLocks noChangeAspect="1"/>
           </p:cNvPicPr>
@@ -3400,7 +3400,7 @@
       </p:pic>
       <p:sp>
         <p:nvSpPr>
-          <p:cNvPr id="733717491" name="Text 21"/>
+          <p:cNvPr id="637566281" name="Text 21"/>
           <p:cNvSpPr txBox="1"/>
           <p:nvPr/>
         </p:nvSpPr>
@@ -3444,7 +3444,7 @@
       </p:sp>
       <p:pic>
         <p:nvPicPr>
-          <p:cNvPr id="850724257" name="Image 12" descr="preencoded.png"/>
+          <p:cNvPr id="704671311" name="Image 12" descr="preencoded.png"/>
           <p:cNvPicPr>
             <a:picLocks noChangeAspect="1"/>
           </p:cNvPicPr>
@@ -3466,7 +3466,7 @@
       </p:pic>
       <p:sp>
         <p:nvSpPr>
-          <p:cNvPr id="650431944" name="Text 22"/>
+          <p:cNvPr id="1236320841" name="Text 22"/>
           <p:cNvSpPr txBox="1"/>
           <p:nvPr/>
         </p:nvSpPr>
@@ -3510,7 +3510,7 @@
       </p:sp>
       <p:pic>
         <p:nvPicPr>
-          <p:cNvPr id="1740979989" name="Image 13" descr="preencoded.png"/>
+          <p:cNvPr id="55828787" name="Image 13" descr="preencoded.png"/>
           <p:cNvPicPr>
             <a:picLocks noChangeAspect="1"/>
           </p:cNvPicPr>
@@ -3532,7 +3532,7 @@
       </p:pic>
       <p:sp>
         <p:nvSpPr>
-          <p:cNvPr id="683314344" name="Text 23"/>
+          <p:cNvPr id="175594133" name="Text 23"/>
           <p:cNvSpPr txBox="1"/>
           <p:nvPr/>
         </p:nvSpPr>
@@ -3563,7 +3563,7 @@
       </p:sp>
       <p:sp>
         <p:nvSpPr>
-          <p:cNvPr id="304851579" name="Text 24"/>
+          <p:cNvPr id="867690964" name="Text 24"/>
           <p:cNvSpPr txBox="1"/>
           <p:nvPr/>
         </p:nvSpPr>
@@ -3608,7 +3608,7 @@
       </p:sp>
       <p:sp>
         <p:nvSpPr>
-          <p:cNvPr id="679600229" name="Text 25"/>
+          <p:cNvPr id="1636123672" name="Text 25"/>
           <p:cNvSpPr txBox="1"/>
           <p:nvPr/>
         </p:nvSpPr>
@@ -3653,7 +3653,7 @@
       </p:sp>
       <p:sp>
         <p:nvSpPr>
-          <p:cNvPr id="781632173" name="Text 26"/>
+          <p:cNvPr id="1019456574" name="Text 26"/>
           <p:cNvSpPr txBox="1"/>
           <p:nvPr/>
         </p:nvSpPr>
@@ -3697,7 +3697,7 @@
       </p:sp>
       <p:pic>
         <p:nvPicPr>
-          <p:cNvPr id="1926275563" name="Image 14" descr="preencoded.png"/>
+          <p:cNvPr id="252573919" name="Image 14" descr="preencoded.png"/>
           <p:cNvPicPr>
             <a:picLocks noChangeAspect="1"/>
           </p:cNvPicPr>
@@ -3719,7 +3719,7 @@
       </p:pic>
       <p:sp>
         <p:nvSpPr>
-          <p:cNvPr id="1569622519" name="Text 27"/>
+          <p:cNvPr id="107503232" name="Text 27"/>
           <p:cNvSpPr txBox="1"/>
           <p:nvPr/>
         </p:nvSpPr>
@@ -3763,7 +3763,7 @@
       </p:sp>
       <p:pic>
         <p:nvPicPr>
-          <p:cNvPr id="26618853" name="Image 15" descr="preencoded.png"/>
+          <p:cNvPr id="1301512041" name="Image 15" descr="preencoded.png"/>
           <p:cNvPicPr>
             <a:picLocks noChangeAspect="1"/>
           </p:cNvPicPr>
@@ -3785,7 +3785,7 @@
       </p:pic>
       <p:sp>
         <p:nvSpPr>
-          <p:cNvPr id="1737447359" name="Text 28"/>
+          <p:cNvPr id="917201493" name="Text 28"/>
           <p:cNvSpPr txBox="1"/>
           <p:nvPr/>
         </p:nvSpPr>
@@ -3829,7 +3829,7 @@
       </p:sp>
       <p:pic>
         <p:nvPicPr>
-          <p:cNvPr id="2040892461" name="Image 16" descr="preencoded.png"/>
+          <p:cNvPr id="1713930604" name="Image 16" descr="preencoded.png"/>
           <p:cNvPicPr>
             <a:picLocks noChangeAspect="1"/>
           </p:cNvPicPr>
@@ -3851,7 +3851,7 @@
       </p:pic>
       <p:sp>
         <p:nvSpPr>
-          <p:cNvPr id="1447647494" name="Text 29"/>
+          <p:cNvPr id="1453463441" name="Text 29"/>
           <p:cNvSpPr txBox="1"/>
           <p:nvPr/>
         </p:nvSpPr>
@@ -3895,7 +3895,7 @@
       </p:sp>
       <p:pic>
         <p:nvPicPr>
-          <p:cNvPr id="1522059353" name="Image 17" descr="preencoded.png"/>
+          <p:cNvPr id="57112402" name="Image 17" descr="preencoded.png"/>
           <p:cNvPicPr>
             <a:picLocks noChangeAspect="1"/>
           </p:cNvPicPr>
@@ -3917,7 +3917,7 @@
       </p:pic>
       <p:sp>
         <p:nvSpPr>
-          <p:cNvPr id="1806694202" name="Text 30"/>
+          <p:cNvPr id="1366294901" name="Text 30"/>
           <p:cNvSpPr txBox="1"/>
           <p:nvPr/>
         </p:nvSpPr>
@@ -3961,7 +3961,7 @@
       </p:sp>
       <p:pic>
         <p:nvPicPr>
-          <p:cNvPr id="1515208384" name="Image 18" descr="preencoded.png"/>
+          <p:cNvPr id="1246296385" name="Image 18" descr="preencoded.png"/>
           <p:cNvPicPr>
             <a:picLocks noChangeAspect="1"/>
           </p:cNvPicPr>
@@ -3983,7 +3983,7 @@
       </p:pic>
       <p:sp>
         <p:nvSpPr>
-          <p:cNvPr id="1823288274" name="Text 31"/>
+          <p:cNvPr id="1469898975" name="Text 31"/>
           <p:cNvSpPr txBox="1"/>
           <p:nvPr/>
         </p:nvSpPr>
@@ -4014,7 +4014,7 @@
       </p:sp>
       <p:sp>
         <p:nvSpPr>
-          <p:cNvPr id="631962053" name="Text 32"/>
+          <p:cNvPr id="1031767205" name="Text 32"/>
           <p:cNvSpPr txBox="1"/>
           <p:nvPr/>
         </p:nvSpPr>
@@ -4059,7 +4059,7 @@
       </p:sp>
       <p:sp>
         <p:nvSpPr>
-          <p:cNvPr id="2100455923" name="Text 33"/>
+          <p:cNvPr id="1693099272" name="Text 33"/>
           <p:cNvSpPr txBox="1"/>
           <p:nvPr/>
         </p:nvSpPr>
@@ -4104,7 +4104,7 @@
       </p:sp>
       <p:sp>
         <p:nvSpPr>
-          <p:cNvPr id="110748498" name="Text 34"/>
+          <p:cNvPr id="259205536" name="Text 34"/>
           <p:cNvSpPr txBox="1"/>
           <p:nvPr/>
         </p:nvSpPr>
@@ -4148,7 +4148,7 @@
       </p:sp>
       <p:pic>
         <p:nvPicPr>
-          <p:cNvPr id="1430767126" name="Image 19" descr="preencoded.png"/>
+          <p:cNvPr id="35687348" name="Image 19" descr="preencoded.png"/>
           <p:cNvPicPr>
             <a:picLocks noChangeAspect="1"/>
           </p:cNvPicPr>
@@ -4170,7 +4170,7 @@
       </p:pic>
       <p:sp>
         <p:nvSpPr>
-          <p:cNvPr id="1743862419" name="Text 35"/>
+          <p:cNvPr id="1896967291" name="Text 35"/>
           <p:cNvSpPr txBox="1"/>
           <p:nvPr/>
         </p:nvSpPr>
@@ -4214,7 +4214,7 @@
       </p:sp>
       <p:pic>
         <p:nvPicPr>
-          <p:cNvPr id="747258964" name="Image 20" descr="preencoded.png"/>
+          <p:cNvPr id="626358222" name="Image 20" descr="preencoded.png"/>
           <p:cNvPicPr>
             <a:picLocks noChangeAspect="1"/>
           </p:cNvPicPr>
@@ -4236,7 +4236,7 @@
       </p:pic>
       <p:sp>
         <p:nvSpPr>
-          <p:cNvPr id="148207405" name="Text 36"/>
+          <p:cNvPr id="386428427" name="Text 36"/>
           <p:cNvSpPr txBox="1"/>
           <p:nvPr/>
         </p:nvSpPr>
@@ -4280,7 +4280,7 @@
       </p:sp>
       <p:pic>
         <p:nvPicPr>
-          <p:cNvPr id="2142436019" name="Image 21" descr="preencoded.png"/>
+          <p:cNvPr id="1172735460" name="Image 21" descr="preencoded.png"/>
           <p:cNvPicPr>
             <a:picLocks noChangeAspect="1"/>
           </p:cNvPicPr>
@@ -4302,7 +4302,7 @@
       </p:pic>
       <p:sp>
         <p:nvSpPr>
-          <p:cNvPr id="681707958" name="Text 37"/>
+          <p:cNvPr id="1325843956" name="Text 37"/>
           <p:cNvSpPr txBox="1"/>
           <p:nvPr/>
         </p:nvSpPr>
@@ -4346,7 +4346,7 @@
       </p:sp>
       <p:pic>
         <p:nvPicPr>
-          <p:cNvPr id="1596447050" name="Image 22" descr="preencoded.png"/>
+          <p:cNvPr id="1034277073" name="Image 22" descr="preencoded.png"/>
           <p:cNvPicPr>
             <a:picLocks noChangeAspect="1"/>
           </p:cNvPicPr>
@@ -4368,7 +4368,7 @@
       </p:pic>
       <p:sp>
         <p:nvSpPr>
-          <p:cNvPr id="1961879411" name="Text 38"/>
+          <p:cNvPr id="1448388133" name="Text 38"/>
           <p:cNvSpPr txBox="1"/>
           <p:nvPr/>
         </p:nvSpPr>
@@ -4452,7 +4452,7 @@
       </p:grpSpPr>
       <p:sp>
         <p:nvSpPr>
-          <p:cNvPr id="100506568" name="Text 0"/>
+          <p:cNvPr id="351446875" name="Text 0"/>
           <p:cNvSpPr txBox="1"/>
           <p:nvPr/>
         </p:nvSpPr>
@@ -4502,7 +4502,7 @@
       </p:sp>
       <p:pic>
         <p:nvPicPr>
-          <p:cNvPr id="762156230" name="Image 0" descr="preencoded.png"/>
+          <p:cNvPr id="767385955" name="Image 0" descr="preencoded.png"/>
           <p:cNvPicPr>
             <a:picLocks noChangeAspect="1"/>
           </p:cNvPicPr>
@@ -4524,7 +4524,7 @@
       </p:pic>
       <p:pic>
         <p:nvPicPr>
-          <p:cNvPr id="1747423749" name="Image 1" descr="preencoded.png"/>
+          <p:cNvPr id="1641921998" name="Image 1" descr="preencoded.png"/>
           <p:cNvPicPr>
             <a:picLocks noChangeAspect="1"/>
           </p:cNvPicPr>
@@ -4546,7 +4546,7 @@
       </p:pic>
       <p:sp>
         <p:nvSpPr>
-          <p:cNvPr id="271028162" name="Text 1"/>
+          <p:cNvPr id="1286062993" name="Text 1"/>
           <p:cNvSpPr txBox="1"/>
           <p:nvPr/>
         </p:nvSpPr>
@@ -4588,7 +4588,7 @@
       </p:sp>
       <p:sp>
         <p:nvSpPr>
-          <p:cNvPr id="1595793843" name="Text 2"/>
+          <p:cNvPr id="190044859" name="Text 2"/>
           <p:cNvSpPr txBox="1"/>
           <p:nvPr/>
         </p:nvSpPr>
@@ -4633,7 +4633,7 @@
       </p:sp>
       <p:sp>
         <p:nvSpPr>
-          <p:cNvPr id="1653165853" name="Text 3"/>
+          <p:cNvPr id="1416058898" name="Text 3"/>
           <p:cNvSpPr txBox="1"/>
           <p:nvPr/>
         </p:nvSpPr>
@@ -4772,7 +4772,7 @@
       </p:sp>
       <p:pic>
         <p:nvPicPr>
-          <p:cNvPr id="1021744352" name="Image 6" descr="preencoded.png"/>
+          <p:cNvPr id="65403245" name="Image 6" descr="preencoded.png"/>
           <p:cNvPicPr>
             <a:picLocks noChangeAspect="1"/>
           </p:cNvPicPr>
@@ -4794,7 +4794,7 @@
       </p:pic>
       <p:pic>
         <p:nvPicPr>
-          <p:cNvPr id="138554795" name="Image 7" descr="preencoded.png"/>
+          <p:cNvPr id="896267642" name="Image 7" descr="preencoded.png"/>
           <p:cNvPicPr>
             <a:picLocks noChangeAspect="1"/>
           </p:cNvPicPr>
@@ -4816,7 +4816,7 @@
       </p:pic>
       <p:sp>
         <p:nvSpPr>
-          <p:cNvPr id="1549017094" name="Text 10"/>
+          <p:cNvPr id="220042725" name="Text 10"/>
           <p:cNvSpPr txBox="1"/>
           <p:nvPr/>
         </p:nvSpPr>
@@ -4869,7 +4869,7 @@
       </p:sp>
       <p:sp>
         <p:nvSpPr>
-          <p:cNvPr id="952876413" name="Text 11"/>
+          <p:cNvPr id="310257843" name="Text 11"/>
           <p:cNvSpPr txBox="1"/>
           <p:nvPr/>
         </p:nvSpPr>
@@ -4914,7 +4914,7 @@
       </p:sp>
       <p:sp>
         <p:nvSpPr>
-          <p:cNvPr id="2054748881" name="Text 12"/>
+          <p:cNvPr id="1792687075" name="Text 12"/>
           <p:cNvSpPr txBox="1"/>
           <p:nvPr/>
         </p:nvSpPr>
@@ -4966,7 +4966,7 @@
       </p:sp>
       <p:pic>
         <p:nvPicPr>
-          <p:cNvPr id="809438734" name="Image 8" descr="preencoded.png"/>
+          <p:cNvPr id="759827195" name="Image 8" descr="preencoded.png"/>
           <p:cNvPicPr>
             <a:picLocks noChangeAspect="1"/>
           </p:cNvPicPr>
@@ -4988,7 +4988,7 @@
       </p:pic>
       <p:pic>
         <p:nvPicPr>
-          <p:cNvPr id="441130701" name="Image 9" descr="preencoded.png"/>
+          <p:cNvPr id="95930989" name="Image 9" descr="preencoded.png"/>
           <p:cNvPicPr>
             <a:picLocks noChangeAspect="1"/>
           </p:cNvPicPr>
@@ -5010,7 +5010,7 @@
       </p:pic>
       <p:sp>
         <p:nvSpPr>
-          <p:cNvPr id="737708261" name="Text 13"/>
+          <p:cNvPr id="1628991008" name="Text 13"/>
           <p:cNvSpPr txBox="1"/>
           <p:nvPr/>
         </p:nvSpPr>
@@ -5063,7 +5063,7 @@
       </p:sp>
       <p:sp>
         <p:nvSpPr>
-          <p:cNvPr id="302308025" name="Text 14"/>
+          <p:cNvPr id="1726739959" name="Text 14"/>
           <p:cNvSpPr txBox="1"/>
           <p:nvPr/>
         </p:nvSpPr>
@@ -5108,7 +5108,7 @@
       </p:sp>
       <p:sp>
         <p:nvSpPr>
-          <p:cNvPr id="991159331" name="Text 15"/>
+          <p:cNvPr id="1085237909" name="Text 15"/>
           <p:cNvSpPr txBox="1"/>
           <p:nvPr/>
         </p:nvSpPr>
@@ -5221,7 +5221,7 @@
       </p:sp>
       <p:pic>
         <p:nvPicPr>
-          <p:cNvPr id="420986989" name="Image 10" descr="preencoded.png"/>
+          <p:cNvPr id="1144901885" name="Image 10" descr="preencoded.png"/>
           <p:cNvPicPr>
             <a:picLocks noChangeAspect="1"/>
           </p:cNvPicPr>
@@ -5243,7 +5243,7 @@
       </p:pic>
       <p:pic>
         <p:nvPicPr>
-          <p:cNvPr id="1298759790" name="Image 11" descr="preencoded.png"/>
+          <p:cNvPr id="743493388" name="Image 11" descr="preencoded.png"/>
           <p:cNvPicPr>
             <a:picLocks noChangeAspect="1"/>
           </p:cNvPicPr>
@@ -5305,7 +5305,7 @@
       </p:grpSpPr>
       <p:sp>
         <p:nvSpPr>
-          <p:cNvPr id="1439142829" name="Text 0"/>
+          <p:cNvPr id="801545282" name="Text 0"/>
           <p:cNvSpPr txBox="1"/>
           <p:nvPr/>
         </p:nvSpPr>
@@ -5355,7 +5355,7 @@
       </p:sp>
       <p:pic>
         <p:nvPicPr>
-          <p:cNvPr id="248157223" name="Image 0" descr="preencoded.png"/>
+          <p:cNvPr id="247137435" name="Image 0" descr="preencoded.png"/>
           <p:cNvPicPr>
             <a:picLocks noChangeAspect="1"/>
           </p:cNvPicPr>
@@ -5377,7 +5377,7 @@
       </p:pic>
       <p:sp>
         <p:nvSpPr>
-          <p:cNvPr id="1041541578" name="Text 1"/>
+          <p:cNvPr id="546801990" name="Text 1"/>
           <p:cNvSpPr txBox="1"/>
           <p:nvPr/>
         </p:nvSpPr>
@@ -5419,7 +5419,7 @@
       </p:sp>
       <p:sp>
         <p:nvSpPr>
-          <p:cNvPr id="711491210" name="Text 2"/>
+          <p:cNvPr id="970953378" name="Text 2"/>
           <p:cNvSpPr txBox="1"/>
           <p:nvPr/>
         </p:nvSpPr>
@@ -5461,7 +5461,7 @@
       </p:sp>
       <p:sp>
         <p:nvSpPr>
-          <p:cNvPr id="1313056614" name="Text 3"/>
+          <p:cNvPr id="868492357" name="Text 3"/>
           <p:cNvSpPr txBox="1"/>
           <p:nvPr/>
         </p:nvSpPr>
@@ -5505,7 +5505,7 @@
       </p:sp>
       <p:pic>
         <p:nvPicPr>
-          <p:cNvPr id="1452051950" name="Image 2" descr="preencoded.png"/>
+          <p:cNvPr id="2052153875" name="Image 2" descr="preencoded.png"/>
           <p:cNvPicPr>
             <a:picLocks noChangeAspect="1"/>
           </p:cNvPicPr>
@@ -5527,7 +5527,7 @@
       </p:pic>
       <p:sp>
         <p:nvSpPr>
-          <p:cNvPr id="1043547750" name="Text 5"/>
+          <p:cNvPr id="742247931" name="Text 5"/>
           <p:cNvSpPr txBox="1"/>
           <p:nvPr/>
         </p:nvSpPr>
@@ -5580,7 +5580,7 @@
       </p:sp>
       <p:sp>
         <p:nvSpPr>
-          <p:cNvPr id="301536887" name="Text 6"/>
+          <p:cNvPr id="1392265242" name="Text 6"/>
           <p:cNvSpPr txBox="1"/>
           <p:nvPr/>
         </p:nvSpPr>
@@ -5622,7 +5622,7 @@
       </p:sp>
       <p:sp>
         <p:nvSpPr>
-          <p:cNvPr id="1956537930" name="Text 7"/>
+          <p:cNvPr id="1738280646" name="Text 7"/>
           <p:cNvSpPr txBox="1"/>
           <p:nvPr/>
         </p:nvSpPr>
@@ -5706,7 +5706,7 @@
       </p:grpSpPr>
       <p:sp>
         <p:nvSpPr>
-          <p:cNvPr id="319767702" name="Text 0"/>
+          <p:cNvPr id="455831210" name="Text 0"/>
           <p:cNvSpPr txBox="1"/>
           <p:nvPr/>
         </p:nvSpPr>
@@ -5788,7 +5788,7 @@
       </p:sp>
       <p:sp>
         <p:nvSpPr>
-          <p:cNvPr id="359305169" name="Shape 11"/>
+          <p:cNvPr id="375310395" name="Shape 11"/>
           <p:cNvSpPr/>
           <p:nvPr/>
         </p:nvSpPr>
@@ -5850,7 +5850,7 @@
       </p:grpSpPr>
       <p:sp>
         <p:nvSpPr>
-          <p:cNvPr id="737513728" name="Text 0"/>
+          <p:cNvPr id="1301777318" name="Text 0"/>
           <p:cNvSpPr txBox="1"/>
           <p:nvPr/>
         </p:nvSpPr>
@@ -5892,7 +5892,7 @@
       </p:sp>
       <p:pic>
         <p:nvPicPr>
-          <p:cNvPr id="502854354" name="Image 0" descr="preencoded.png"/>
+          <p:cNvPr id="1293155738" name="Image 0" descr="preencoded.png"/>
           <p:cNvPicPr>
             <a:picLocks noChangeAspect="1"/>
           </p:cNvPicPr>
@@ -5914,7 +5914,7 @@
       </p:pic>
       <p:sp>
         <p:nvSpPr>
-          <p:cNvPr id="50129896" name="Text 1"/>
+          <p:cNvPr id="669683775" name="Text 1"/>
           <p:cNvSpPr txBox="1"/>
           <p:nvPr/>
         </p:nvSpPr>
@@ -5956,7 +5956,7 @@
       </p:sp>
       <p:sp>
         <p:nvSpPr>
-          <p:cNvPr id="1833978809" name="Text 2"/>
+          <p:cNvPr id="2040363220" name="Text 2"/>
           <p:cNvSpPr txBox="1"/>
           <p:nvPr/>
         </p:nvSpPr>
@@ -5998,7 +5998,7 @@
       </p:sp>
       <p:pic>
         <p:nvPicPr>
-          <p:cNvPr id="1474298653" name="Image 1" descr="preencoded.png"/>
+          <p:cNvPr id="427377579" name="Image 1" descr="preencoded.png"/>
           <p:cNvPicPr>
             <a:picLocks noChangeAspect="1"/>
           </p:cNvPicPr>
@@ -6020,7 +6020,7 @@
       </p:pic>
       <p:sp>
         <p:nvSpPr>
-          <p:cNvPr id="866566303" name="Text 4"/>
+          <p:cNvPr id="732643015" name="Text 4"/>
           <p:cNvSpPr txBox="1"/>
           <p:nvPr/>
         </p:nvSpPr>
@@ -6062,7 +6062,7 @@
       </p:sp>
       <p:sp>
         <p:nvSpPr>
-          <p:cNvPr id="232616302" name="Text 5"/>
+          <p:cNvPr id="1022434688" name="Text 5"/>
           <p:cNvSpPr txBox="1"/>
           <p:nvPr/>
         </p:nvSpPr>
@@ -6104,7 +6104,7 @@
       </p:sp>
       <p:pic>
         <p:nvPicPr>
-          <p:cNvPr id="552510333" name="Image 2" descr="preencoded.png"/>
+          <p:cNvPr id="1935035060" name="Image 2" descr="preencoded.png"/>
           <p:cNvPicPr>
             <a:picLocks noChangeAspect="1"/>
           </p:cNvPicPr>
@@ -6126,7 +6126,7 @@
       </p:pic>
       <p:sp>
         <p:nvSpPr>
-          <p:cNvPr id="316972362" name="Text 7"/>
+          <p:cNvPr id="1795962726" name="Text 7"/>
           <p:cNvSpPr txBox="1"/>
           <p:nvPr/>
         </p:nvSpPr>
@@ -6168,7 +6168,7 @@
       </p:sp>
       <p:sp>
         <p:nvSpPr>
-          <p:cNvPr id="1319380061" name="Text 8"/>
+          <p:cNvPr id="1538559007" name="Text 8"/>
           <p:cNvSpPr txBox="1"/>
           <p:nvPr/>
         </p:nvSpPr>
@@ -6210,7 +6210,7 @@
       </p:sp>
       <p:pic>
         <p:nvPicPr>
-          <p:cNvPr id="198281196" name="Image 3" descr="preencoded.png"/>
+          <p:cNvPr id="1360490664" name="Image 3" descr="preencoded.png"/>
           <p:cNvPicPr>
             <a:picLocks noChangeAspect="1"/>
           </p:cNvPicPr>
@@ -6232,7 +6232,7 @@
       </p:pic>
       <p:sp>
         <p:nvSpPr>
-          <p:cNvPr id="370665076" name="Text 10"/>
+          <p:cNvPr id="536519832" name="Text 10"/>
           <p:cNvSpPr txBox="1"/>
           <p:nvPr/>
         </p:nvSpPr>
@@ -6274,7 +6274,7 @@
       </p:sp>
       <p:sp>
         <p:nvSpPr>
-          <p:cNvPr id="1947745616" name="Text 11"/>
+          <p:cNvPr id="1221080377" name="Text 11"/>
           <p:cNvSpPr txBox="1"/>
           <p:nvPr/>
         </p:nvSpPr>
@@ -6316,7 +6316,7 @@
       </p:sp>
       <p:pic>
         <p:nvPicPr>
-          <p:cNvPr id="1276734480" name="Image 4" descr="preencoded.png"/>
+          <p:cNvPr id="631723080" name="Image 4" descr="preencoded.png"/>
           <p:cNvPicPr>
             <a:picLocks noChangeAspect="1"/>
           </p:cNvPicPr>
@@ -6338,7 +6338,7 @@
       </p:pic>
       <p:sp>
         <p:nvSpPr>
-          <p:cNvPr id="323815798" name="Text 13"/>
+          <p:cNvPr id="957608786" name="Text 13"/>
           <p:cNvSpPr txBox="1"/>
           <p:nvPr/>
         </p:nvSpPr>
@@ -6380,7 +6380,7 @@
       </p:sp>
       <p:sp>
         <p:nvSpPr>
-          <p:cNvPr id="1077992739" name="Text 14"/>
+          <p:cNvPr id="1674017214" name="Text 14"/>
           <p:cNvSpPr txBox="1"/>
           <p:nvPr/>
         </p:nvSpPr>
@@ -6422,7 +6422,7 @@
       </p:sp>
       <p:pic>
         <p:nvPicPr>
-          <p:cNvPr id="313269153" name="Image 5" descr="preencoded.png"/>
+          <p:cNvPr id="1280587436" name="Image 5" descr="preencoded.png"/>
           <p:cNvPicPr>
             <a:picLocks noChangeAspect="1"/>
           </p:cNvPicPr>
@@ -6444,7 +6444,7 @@
       </p:pic>
       <p:sp>
         <p:nvSpPr>
-          <p:cNvPr id="475285302" name="Text 16"/>
+          <p:cNvPr id="1890351242" name="Text 16"/>
           <p:cNvSpPr txBox="1"/>
           <p:nvPr/>
         </p:nvSpPr>
@@ -6486,7 +6486,7 @@
       </p:sp>
       <p:sp>
         <p:nvSpPr>
-          <p:cNvPr id="41657231" name="Text 17"/>
+          <p:cNvPr id="347211888" name="Text 17"/>
           <p:cNvSpPr txBox="1"/>
           <p:nvPr/>
         </p:nvSpPr>
@@ -6528,7 +6528,7 @@
       </p:sp>
       <p:pic>
         <p:nvPicPr>
-          <p:cNvPr id="38309387" name="Image 6" descr="preencoded.png"/>
+          <p:cNvPr id="1371037183" name="Image 6" descr="preencoded.png"/>
           <p:cNvPicPr>
             <a:picLocks noChangeAspect="1"/>
           </p:cNvPicPr>
@@ -6550,7 +6550,7 @@
       </p:pic>
       <p:sp>
         <p:nvSpPr>
-          <p:cNvPr id="1664274875" name="Text 19"/>
+          <p:cNvPr id="1928805483" name="Text 19"/>
           <p:cNvSpPr txBox="1"/>
           <p:nvPr/>
         </p:nvSpPr>
@@ -6614,7 +6614,7 @@
       </p:sp>
       <p:sp>
         <p:nvSpPr>
-          <p:cNvPr id="922352921" name="Text 20"/>
+          <p:cNvPr id="1193191485" name="Text 20"/>
           <p:cNvSpPr txBox="1"/>
           <p:nvPr/>
         </p:nvSpPr>
@@ -6658,7 +6658,7 @@
       </p:sp>
       <p:sp>
         <p:nvSpPr>
-          <p:cNvPr id="247380962" name="Shape 21"/>
+          <p:cNvPr id="586170989" name="Shape 21"/>
           <p:cNvSpPr/>
           <p:nvPr/>
         </p:nvSpPr>
@@ -6680,7 +6680,7 @@
       </p:sp>
       <p:sp>
         <p:nvSpPr>
-          <p:cNvPr id="684761674" name="Text 22"/>
+          <p:cNvPr id="597226851" name="Text 22"/>
           <p:cNvSpPr txBox="1"/>
           <p:nvPr/>
         </p:nvSpPr>
@@ -6733,7 +6733,7 @@
       </p:sp>
       <p:sp>
         <p:nvSpPr>
-          <p:cNvPr id="264675042" name="Text 23"/>
+          <p:cNvPr id="1865411080" name="Text 23"/>
           <p:cNvSpPr txBox="1"/>
           <p:nvPr/>
         </p:nvSpPr>
@@ -6777,7 +6777,7 @@
       </p:sp>
       <p:sp>
         <p:nvSpPr>
-          <p:cNvPr id="1687398607" name="Shape 24"/>
+          <p:cNvPr id="295484740" name="Shape 24"/>
           <p:cNvSpPr/>
           <p:nvPr/>
         </p:nvSpPr>
@@ -6848,7 +6848,7 @@
                                           </p:stCondLst>
                                         </p:cTn>
                                         <p:tgtEl>
-                                          <p:spTgt spid="502854354"/>
+                                          <p:spTgt spid="1293155738"/>
                                         </p:tgtEl>
                                         <p:attrNameLst>
                                           <p:attrName>style.visibility</p:attrName>
@@ -6875,7 +6875,7 @@
                                           </p:stCondLst>
                                         </p:cTn>
                                         <p:tgtEl>
-                                          <p:spTgt spid="50129896"/>
+                                          <p:spTgt spid="669683775"/>
                                         </p:tgtEl>
                                         <p:attrNameLst>
                                           <p:attrName>style.visibility</p:attrName>
@@ -6902,7 +6902,7 @@
                                           </p:stCondLst>
                                         </p:cTn>
                                         <p:tgtEl>
-                                          <p:spTgt spid="1833978809"/>
+                                          <p:spTgt spid="2040363220"/>
                                         </p:tgtEl>
                                         <p:attrNameLst>
                                           <p:attrName>style.visibility</p:attrName>
@@ -6947,7 +6947,7 @@
                                           </p:stCondLst>
                                         </p:cTn>
                                         <p:tgtEl>
-                                          <p:spTgt spid="1474298653"/>
+                                          <p:spTgt spid="427377579"/>
                                         </p:tgtEl>
                                         <p:attrNameLst>
                                           <p:attrName>style.visibility</p:attrName>
@@ -6974,7 +6974,7 @@
                                           </p:stCondLst>
                                         </p:cTn>
                                         <p:tgtEl>
-                                          <p:spTgt spid="866566303"/>
+                                          <p:spTgt spid="732643015"/>
                                         </p:tgtEl>
                                         <p:attrNameLst>
                                           <p:attrName>style.visibility</p:attrName>
@@ -7001,7 +7001,7 @@
                                           </p:stCondLst>
                                         </p:cTn>
                                         <p:tgtEl>
-                                          <p:spTgt spid="232616302"/>
+                                          <p:spTgt spid="1022434688"/>
                                         </p:tgtEl>
                                         <p:attrNameLst>
                                           <p:attrName>style.visibility</p:attrName>
@@ -7046,7 +7046,7 @@
                                           </p:stCondLst>
                                         </p:cTn>
                                         <p:tgtEl>
-                                          <p:spTgt spid="552510333"/>
+                                          <p:spTgt spid="1935035060"/>
                                         </p:tgtEl>
                                         <p:attrNameLst>
                                           <p:attrName>style.visibility</p:attrName>
@@ -7073,7 +7073,7 @@
                                           </p:stCondLst>
                                         </p:cTn>
                                         <p:tgtEl>
-                                          <p:spTgt spid="316972362"/>
+                                          <p:spTgt spid="1795962726"/>
                                         </p:tgtEl>
                                         <p:attrNameLst>
                                           <p:attrName>style.visibility</p:attrName>
@@ -7100,7 +7100,7 @@
                                           </p:stCondLst>
                                         </p:cTn>
                                         <p:tgtEl>
-                                          <p:spTgt spid="1319380061"/>
+                                          <p:spTgt spid="1538559007"/>
                                         </p:tgtEl>
                                         <p:attrNameLst>
                                           <p:attrName>style.visibility</p:attrName>
@@ -7145,7 +7145,7 @@
                                           </p:stCondLst>
                                         </p:cTn>
                                         <p:tgtEl>
-                                          <p:spTgt spid="198281196"/>
+                                          <p:spTgt spid="1360490664"/>
                                         </p:tgtEl>
                                         <p:attrNameLst>
                                           <p:attrName>style.visibility</p:attrName>
@@ -7172,7 +7172,7 @@
                                           </p:stCondLst>
                                         </p:cTn>
                                         <p:tgtEl>
-                                          <p:spTgt spid="370665076"/>
+                                          <p:spTgt spid="536519832"/>
                                         </p:tgtEl>
                                         <p:attrNameLst>
                                           <p:attrName>style.visibility</p:attrName>
@@ -7199,7 +7199,7 @@
                                           </p:stCondLst>
                                         </p:cTn>
                                         <p:tgtEl>
-                                          <p:spTgt spid="1947745616"/>
+                                          <p:spTgt spid="1221080377"/>
                                         </p:tgtEl>
                                         <p:attrNameLst>
                                           <p:attrName>style.visibility</p:attrName>
@@ -7244,7 +7244,7 @@
                                           </p:stCondLst>
                                         </p:cTn>
                                         <p:tgtEl>
-                                          <p:spTgt spid="1276734480"/>
+                                          <p:spTgt spid="631723080"/>
                                         </p:tgtEl>
                                         <p:attrNameLst>
                                           <p:attrName>style.visibility</p:attrName>
@@ -7271,7 +7271,7 @@
                                           </p:stCondLst>
                                         </p:cTn>
                                         <p:tgtEl>
-                                          <p:spTgt spid="323815798"/>
+                                          <p:spTgt spid="957608786"/>
                                         </p:tgtEl>
                                         <p:attrNameLst>
                                           <p:attrName>style.visibility</p:attrName>
@@ -7298,7 +7298,7 @@
                                           </p:stCondLst>
                                         </p:cTn>
                                         <p:tgtEl>
-                                          <p:spTgt spid="1077992739"/>
+                                          <p:spTgt spid="1674017214"/>
                                         </p:tgtEl>
                                         <p:attrNameLst>
                                           <p:attrName>style.visibility</p:attrName>
@@ -7343,7 +7343,7 @@
                                           </p:stCondLst>
                                         </p:cTn>
                                         <p:tgtEl>
-                                          <p:spTgt spid="313269153"/>
+                                          <p:spTgt spid="1280587436"/>
                                         </p:tgtEl>
                                         <p:attrNameLst>
                                           <p:attrName>style.visibility</p:attrName>
@@ -7370,7 +7370,7 @@
                                           </p:stCondLst>
                                         </p:cTn>
                                         <p:tgtEl>
-                                          <p:spTgt spid="475285302"/>
+                                          <p:spTgt spid="1890351242"/>
                                         </p:tgtEl>
                                         <p:attrNameLst>
                                           <p:attrName>style.visibility</p:attrName>
@@ -7397,7 +7397,7 @@
                                           </p:stCondLst>
                                         </p:cTn>
                                         <p:tgtEl>
-                                          <p:spTgt spid="41657231"/>
+                                          <p:spTgt spid="347211888"/>
                                         </p:tgtEl>
                                         <p:attrNameLst>
                                           <p:attrName>style.visibility</p:attrName>
@@ -7442,7 +7442,7 @@
                                           </p:stCondLst>
                                         </p:cTn>
                                         <p:tgtEl>
-                                          <p:spTgt spid="38309387"/>
+                                          <p:spTgt spid="1371037183"/>
                                         </p:tgtEl>
                                         <p:attrNameLst>
                                           <p:attrName>style.visibility</p:attrName>
@@ -7469,7 +7469,7 @@
                                           </p:stCondLst>
                                         </p:cTn>
                                         <p:tgtEl>
-                                          <p:spTgt spid="1664274875"/>
+                                          <p:spTgt spid="1928805483"/>
                                         </p:tgtEl>
                                         <p:attrNameLst>
                                           <p:attrName>style.visibility</p:attrName>
@@ -7496,7 +7496,7 @@
                                           </p:stCondLst>
                                         </p:cTn>
                                         <p:tgtEl>
-                                          <p:spTgt spid="922352921"/>
+                                          <p:spTgt spid="1193191485"/>
                                         </p:tgtEl>
                                         <p:attrNameLst>
                                           <p:attrName>style.visibility</p:attrName>
@@ -7523,7 +7523,7 @@
                                           </p:stCondLst>
                                         </p:cTn>
                                         <p:tgtEl>
-                                          <p:spTgt spid="247380962"/>
+                                          <p:spTgt spid="586170989"/>
                                         </p:tgtEl>
                                         <p:attrNameLst>
                                           <p:attrName>style.visibility</p:attrName>
@@ -7550,7 +7550,7 @@
                                           </p:stCondLst>
                                         </p:cTn>
                                         <p:tgtEl>
-                                          <p:spTgt spid="684761674"/>
+                                          <p:spTgt spid="597226851"/>
                                         </p:tgtEl>
                                         <p:attrNameLst>
                                           <p:attrName>style.visibility</p:attrName>
@@ -7577,7 +7577,7 @@
                                           </p:stCondLst>
                                         </p:cTn>
                                         <p:tgtEl>
-                                          <p:spTgt spid="264675042"/>
+                                          <p:spTgt spid="1865411080"/>
                                         </p:tgtEl>
                                         <p:attrNameLst>
                                           <p:attrName>style.visibility</p:attrName>
@@ -7604,7 +7604,7 @@
                                           </p:stCondLst>
                                         </p:cTn>
                                         <p:tgtEl>
-                                          <p:spTgt spid="1687398607"/>
+                                          <p:spTgt spid="295484740"/>
                                         </p:tgtEl>
                                         <p:attrNameLst>
                                           <p:attrName>style.visibility</p:attrName>
@@ -7696,7 +7696,7 @@
       </p:pic>
       <p:sp>
         <p:nvSpPr>
-          <p:cNvPr id="1523908405" name="Text 0"/>
+          <p:cNvPr id="1029824324" name="Text 0"/>
           <p:cNvSpPr txBox="1"/>
           <p:nvPr/>
         </p:nvSpPr>
@@ -7748,7 +7748,7 @@
       </p:sp>
       <p:pic>
         <p:nvPicPr>
-          <p:cNvPr id="119369732" name="Image 0" descr="preencoded.png"/>
+          <p:cNvPr id="612340166" name="Image 0" descr="preencoded.png"/>
           <p:cNvPicPr>
             <a:picLocks noChangeAspect="1"/>
           </p:cNvPicPr>
@@ -7770,7 +7770,7 @@
       </p:pic>
       <p:sp>
         <p:nvSpPr>
-          <p:cNvPr id="1867682408" name="Text 1"/>
+          <p:cNvPr id="338298132" name="Text 1"/>
           <p:cNvSpPr txBox="1"/>
           <p:nvPr/>
         </p:nvSpPr>
@@ -7815,7 +7815,7 @@
       </p:sp>
       <p:sp>
         <p:nvSpPr>
-          <p:cNvPr id="889285453" name="Text 2"/>
+          <p:cNvPr id="1739735229" name="Text 2"/>
           <p:cNvSpPr txBox="1"/>
           <p:nvPr/>
         </p:nvSpPr>
@@ -7886,7 +7886,7 @@
       </p:sp>
       <p:pic>
         <p:nvPicPr>
-          <p:cNvPr id="1246596466" name="Image 1" descr="preencoded.png"/>
+          <p:cNvPr id="1113387993" name="Image 1" descr="preencoded.png"/>
           <p:cNvPicPr>
             <a:picLocks noChangeAspect="1"/>
           </p:cNvPicPr>
@@ -7908,7 +7908,7 @@
       </p:pic>
       <p:sp>
         <p:nvSpPr>
-          <p:cNvPr id="142626905" name="Text 3"/>
+          <p:cNvPr id="1548801272" name="Text 3"/>
           <p:cNvSpPr txBox="1"/>
           <p:nvPr/>
         </p:nvSpPr>
@@ -7953,7 +7953,7 @@
       </p:sp>
       <p:sp>
         <p:nvSpPr>
-          <p:cNvPr id="1756015404" name="Text 4"/>
+          <p:cNvPr id="1794295737" name="Text 4"/>
           <p:cNvSpPr txBox="1"/>
           <p:nvPr/>
         </p:nvSpPr>
@@ -8042,7 +8042,7 @@
       </p:sp>
       <p:pic>
         <p:nvPicPr>
-          <p:cNvPr id="1116013174" name="Image 2" descr="preencoded.png"/>
+          <p:cNvPr id="1531479373" name="Image 2" descr="preencoded.png"/>
           <p:cNvPicPr>
             <a:picLocks noChangeAspect="1"/>
           </p:cNvPicPr>
@@ -8064,7 +8064,7 @@
       </p:pic>
       <p:sp>
         <p:nvSpPr>
-          <p:cNvPr id="743954115" name="Text 5"/>
+          <p:cNvPr id="213026106" name="Text 5"/>
           <p:cNvSpPr txBox="1"/>
           <p:nvPr/>
         </p:nvSpPr>
@@ -8109,7 +8109,7 @@
       </p:sp>
       <p:sp>
         <p:nvSpPr>
-          <p:cNvPr id="1762973971" name="Text 6"/>
+          <p:cNvPr id="777751175" name="Text 6"/>
           <p:cNvSpPr txBox="1"/>
           <p:nvPr/>
         </p:nvSpPr>
@@ -8219,7 +8219,7 @@
                                           </p:stCondLst>
                                         </p:cTn>
                                         <p:tgtEl>
-                                          <p:spTgt spid="119369732"/>
+                                          <p:spTgt spid="612340166"/>
                                         </p:tgtEl>
                                         <p:attrNameLst>
                                           <p:attrName>style.visibility</p:attrName>
@@ -8246,7 +8246,7 @@
                                           </p:stCondLst>
                                         </p:cTn>
                                         <p:tgtEl>
-                                          <p:spTgt spid="1867682408"/>
+                                          <p:spTgt spid="338298132"/>
                                         </p:tgtEl>
                                         <p:attrNameLst>
                                           <p:attrName>style.visibility</p:attrName>
@@ -8273,7 +8273,7 @@
                                           </p:stCondLst>
                                         </p:cTn>
                                         <p:tgtEl>
-                                          <p:spTgt spid="889285453"/>
+                                          <p:spTgt spid="1739735229"/>
                                         </p:tgtEl>
                                         <p:attrNameLst>
                                           <p:attrName>style.visibility</p:attrName>
@@ -8318,7 +8318,7 @@
                                           </p:stCondLst>
                                         </p:cTn>
                                         <p:tgtEl>
-                                          <p:spTgt spid="1116013174"/>
+                                          <p:spTgt spid="1531479373"/>
                                         </p:tgtEl>
                                         <p:attrNameLst>
                                           <p:attrName>style.visibility</p:attrName>
@@ -8345,7 +8345,7 @@
                                           </p:stCondLst>
                                         </p:cTn>
                                         <p:tgtEl>
-                                          <p:spTgt spid="743954115"/>
+                                          <p:spTgt spid="213026106"/>
                                         </p:tgtEl>
                                         <p:attrNameLst>
                                           <p:attrName>style.visibility</p:attrName>
@@ -8372,7 +8372,7 @@
                                           </p:stCondLst>
                                         </p:cTn>
                                         <p:tgtEl>
-                                          <p:spTgt spid="1762973971"/>
+                                          <p:spTgt spid="777751175"/>
                                         </p:tgtEl>
                                         <p:attrNameLst>
                                           <p:attrName>style.visibility</p:attrName>
@@ -8417,7 +8417,7 @@
                                           </p:stCondLst>
                                         </p:cTn>
                                         <p:tgtEl>
-                                          <p:spTgt spid="1246596466"/>
+                                          <p:spTgt spid="1113387993"/>
                                         </p:tgtEl>
                                         <p:attrNameLst>
                                           <p:attrName>style.visibility</p:attrName>
@@ -8444,7 +8444,7 @@
                                           </p:stCondLst>
                                         </p:cTn>
                                         <p:tgtEl>
-                                          <p:spTgt spid="142626905"/>
+                                          <p:spTgt spid="1548801272"/>
                                         </p:tgtEl>
                                         <p:attrNameLst>
                                           <p:attrName>style.visibility</p:attrName>
@@ -8471,7 +8471,7 @@
                                           </p:stCondLst>
                                         </p:cTn>
                                         <p:tgtEl>
-                                          <p:spTgt spid="1756015404"/>
+                                          <p:spTgt spid="1794295737"/>
                                         </p:tgtEl>
                                         <p:attrNameLst>
                                           <p:attrName>style.visibility</p:attrName>
@@ -8586,7 +8586,7 @@
       </p:grpSpPr>
       <p:pic>
         <p:nvPicPr>
-          <p:cNvPr id="348253451" name=""/>
+          <p:cNvPr id="815547082" name=""/>
           <p:cNvPicPr>
             <a:picLocks noChangeAspect="1"/>
           </p:cNvPicPr>
@@ -8608,14 +8608,14 @@
       </p:pic>
       <p:sp>
         <p:nvSpPr>
-          <p:cNvPr id="618690790" name="TextBox 1"/>
+          <p:cNvPr id="1549324895" name="TextBox 1"/>
           <p:cNvSpPr txBox="1"/>
           <p:nvPr/>
         </p:nvSpPr>
         <p:spPr bwMode="auto">
           <a:xfrm>
-            <a:off x="457200" y="44166"/>
-            <a:ext cx="10987919" cy="701399"/>
+            <a:off x="457200" y="44165"/>
+            <a:ext cx="10989718" cy="518519"/>
           </a:xfrm>
           <a:prstGeom prst="rect">
             <a:avLst/>
@@ -8640,36 +8640,21 @@
               <a:rPr/>
               <a:t>Project Highlights</a:t>
             </a:r>
+            <a:r>
+              <a:rPr sz="1200">
+                <a:solidFill>
+                  <a:srgbClr val="67F4E2"/>
+                </a:solidFill>
+              </a:rPr>
+              <a:t> </a:t>
+            </a:r>
             <a:endParaRPr/>
           </a:p>
-          <a:p>
-            <a:pPr>
-              <a:defRPr sz="2800" b="1">
-                <a:solidFill>
-                  <a:srgbClr val="EAEEF2"/>
-                </a:solidFill>
-                <a:latin typeface="Space Grotesk"/>
-              </a:defRPr>
-            </a:pPr>
-            <a:r>
-              <a:rPr/>
-              <a:t> </a:t>
-            </a:r>
-            <a:r>
-              <a:rPr sz="1200">
-                <a:solidFill>
-                  <a:srgbClr val="67F4E2"/>
-                </a:solidFill>
-              </a:rPr>
-              <a:t>  100% IaC • Terraform + Ansible </a:t>
-            </a:r>
-            <a:endParaRPr/>
-          </a:p>
-        </p:txBody>
-      </p:sp>
-      <p:sp>
-        <p:nvSpPr>
-          <p:cNvPr id="576567317" name="Rectangle 2"/>
+        </p:txBody>
+      </p:sp>
+      <p:sp>
+        <p:nvSpPr>
+          <p:cNvPr id="1019842301" name="Rectangle 2"/>
           <p:cNvSpPr/>
           <p:nvPr/>
         </p:nvSpPr>
@@ -8716,11 +8701,29 @@
                 <a:latin typeface="JetBrains Mono"/>
               </a:defRPr>
             </a:pPr>
-            <a:r>
-              <a:rPr/>
-              <a:t>Infra as Code 100%</a:t>
-            </a:r>
             <a:endParaRPr/>
+          </a:p>
+          <a:p>
+            <a:pPr algn="ctr">
+              <a:defRPr sz="900" b="1">
+                <a:solidFill>
+                  <a:srgbClr val="67F4E2"/>
+                </a:solidFill>
+                <a:latin typeface="JetBrains Mono"/>
+              </a:defRPr>
+            </a:pPr>
+            <a:r>
+              <a:rPr lang="en-US" sz="1100" b="1" i="0" u="none" strike="noStrike" cap="none" spc="0">
+                <a:solidFill>
+                  <a:srgbClr val="67F4E2"/>
+                </a:solidFill>
+                <a:latin typeface="+mn-lt"/>
+                <a:ea typeface="+mn-ea"/>
+                <a:cs typeface="+mn-cs"/>
+              </a:rPr>
+              <a:t>100% IaC • Terraform + Ansible</a:t>
+            </a:r>
+            <a:endParaRPr sz="1100" b="1"/>
           </a:p>
           <a:p>
             <a:pPr algn="ctr">
@@ -8776,7 +8779,7 @@
       </p:sp>
       <p:sp>
         <p:nvSpPr>
-          <p:cNvPr id="1860735203" name="Rectangle 3"/>
+          <p:cNvPr id="46437132" name="Rectangle 3"/>
           <p:cNvSpPr/>
           <p:nvPr/>
         </p:nvSpPr>
@@ -8867,7 +8870,7 @@
       </p:sp>
       <p:sp>
         <p:nvSpPr>
-          <p:cNvPr id="1138474497" name="Rectangle 4"/>
+          <p:cNvPr id="577491431" name="Rectangle 4"/>
           <p:cNvSpPr/>
           <p:nvPr/>
         </p:nvSpPr>
@@ -8966,7 +8969,7 @@
       </p:sp>
       <p:sp>
         <p:nvSpPr>
-          <p:cNvPr id="234095904" name="Rectangle 5"/>
+          <p:cNvPr id="14511331" name="Rectangle 5"/>
           <p:cNvSpPr/>
           <p:nvPr/>
         </p:nvSpPr>
@@ -9057,7 +9060,7 @@
       </p:sp>
       <p:sp>
         <p:nvSpPr>
-          <p:cNvPr id="656636584" name="Rectangle 6"/>
+          <p:cNvPr id="1192231185" name="Rectangle 6"/>
           <p:cNvSpPr/>
           <p:nvPr/>
         </p:nvSpPr>
@@ -9152,7 +9155,7 @@
       </p:sp>
       <p:sp>
         <p:nvSpPr>
-          <p:cNvPr id="986648454" name="Rectangle 7"/>
+          <p:cNvPr id="2038147305" name="Rectangle 7"/>
           <p:cNvSpPr/>
           <p:nvPr/>
         </p:nvSpPr>
@@ -9267,7 +9270,7 @@
       </p:sp>
       <p:sp>
         <p:nvSpPr>
-          <p:cNvPr id="1817145457" name="Rectangle 8"/>
+          <p:cNvPr id="1798567717" name="Rectangle 8"/>
           <p:cNvSpPr/>
           <p:nvPr/>
         </p:nvSpPr>
@@ -9358,7 +9361,7 @@
       </p:sp>
       <p:sp>
         <p:nvSpPr>
-          <p:cNvPr id="738298927" name="Rectangle 9"/>
+          <p:cNvPr id="1821483858" name="Rectangle 9"/>
           <p:cNvSpPr/>
           <p:nvPr/>
         </p:nvSpPr>
@@ -9449,7 +9452,7 @@
       </p:sp>
       <p:sp>
         <p:nvSpPr>
-          <p:cNvPr id="1796359760" name="Rectangle 9"/>
+          <p:cNvPr id="1021084818" name="Rectangle 9"/>
           <p:cNvSpPr/>
           <p:nvPr/>
         </p:nvSpPr>
@@ -9675,7 +9678,7 @@
                                           </p:stCondLst>
                                         </p:cTn>
                                         <p:tgtEl>
-                                          <p:spTgt spid="576567317"/>
+                                          <p:spTgt spid="1019842301"/>
                                         </p:tgtEl>
                                         <p:attrNameLst>
                                           <p:attrName>style.visibility</p:attrName>
@@ -9702,7 +9705,7 @@
                                           </p:stCondLst>
                                         </p:cTn>
                                         <p:tgtEl>
-                                          <p:spTgt spid="348253451"/>
+                                          <p:spTgt spid="815547082"/>
                                         </p:tgtEl>
                                         <p:attrNameLst>
                                           <p:attrName>style.visibility</p:attrName>
@@ -9747,7 +9750,7 @@
                                           </p:stCondLst>
                                         </p:cTn>
                                         <p:tgtEl>
-                                          <p:spTgt spid="1860735203"/>
+                                          <p:spTgt spid="46437132"/>
                                         </p:tgtEl>
                                         <p:attrNameLst>
                                           <p:attrName>style.visibility</p:attrName>
@@ -9792,7 +9795,7 @@
                                           </p:stCondLst>
                                         </p:cTn>
                                         <p:tgtEl>
-                                          <p:spTgt spid="656636584"/>
+                                          <p:spTgt spid="1192231185"/>
                                         </p:tgtEl>
                                         <p:attrNameLst>
                                           <p:attrName>style.visibility</p:attrName>
@@ -9837,7 +9840,7 @@
                                           </p:stCondLst>
                                         </p:cTn>
                                         <p:tgtEl>
-                                          <p:spTgt spid="738298927"/>
+                                          <p:spTgt spid="1821483858"/>
                                         </p:tgtEl>
                                         <p:attrNameLst>
                                           <p:attrName>style.visibility</p:attrName>
@@ -9882,7 +9885,7 @@
                                           </p:stCondLst>
                                         </p:cTn>
                                         <p:tgtEl>
-                                          <p:spTgt spid="1817145457"/>
+                                          <p:spTgt spid="1798567717"/>
                                         </p:tgtEl>
                                         <p:attrNameLst>
                                           <p:attrName>style.visibility</p:attrName>
@@ -9927,7 +9930,7 @@
                                           </p:stCondLst>
                                         </p:cTn>
                                         <p:tgtEl>
-                                          <p:spTgt spid="1138474497"/>
+                                          <p:spTgt spid="577491431"/>
                                         </p:tgtEl>
                                         <p:attrNameLst>
                                           <p:attrName>style.visibility</p:attrName>
@@ -9972,7 +9975,7 @@
                                           </p:stCondLst>
                                         </p:cTn>
                                         <p:tgtEl>
-                                          <p:spTgt spid="986648454"/>
+                                          <p:spTgt spid="2038147305"/>
                                         </p:tgtEl>
                                         <p:attrNameLst>
                                           <p:attrName>style.visibility</p:attrName>
@@ -10017,7 +10020,7 @@
                                           </p:stCondLst>
                                         </p:cTn>
                                         <p:tgtEl>
-                                          <p:spTgt spid="1796359760"/>
+                                          <p:spTgt spid="1021084818"/>
                                         </p:tgtEl>
                                         <p:attrNameLst>
                                           <p:attrName>style.visibility</p:attrName>
@@ -10062,7 +10065,7 @@
                                           </p:stCondLst>
                                         </p:cTn>
                                         <p:tgtEl>
-                                          <p:spTgt spid="234095904"/>
+                                          <p:spTgt spid="14511331"/>
                                         </p:tgtEl>
                                         <p:attrNameLst>
                                           <p:attrName>style.visibility</p:attrName>
@@ -10132,7 +10135,7 @@
       </p:grpSpPr>
       <p:sp>
         <p:nvSpPr>
-          <p:cNvPr id="1699544736" name="Text 0"/>
+          <p:cNvPr id="1716906254" name="Text 0"/>
           <p:cNvSpPr txBox="1"/>
           <p:nvPr/>
         </p:nvSpPr>
@@ -10193,7 +10196,7 @@
       </p:sp>
       <p:pic>
         <p:nvPicPr>
-          <p:cNvPr id="657844124" name="Image 0" descr="preencoded.png"/>
+          <p:cNvPr id="1543916807" name="Image 0" descr="preencoded.png"/>
           <p:cNvPicPr>
             <a:picLocks noChangeAspect="1"/>
           </p:cNvPicPr>
@@ -10215,7 +10218,7 @@
       </p:pic>
       <p:sp>
         <p:nvSpPr>
-          <p:cNvPr id="418782816" name="Text 1"/>
+          <p:cNvPr id="858479948" name="Text 1"/>
           <p:cNvSpPr txBox="1"/>
           <p:nvPr/>
         </p:nvSpPr>
@@ -10257,7 +10260,7 @@
       </p:sp>
       <p:pic>
         <p:nvPicPr>
-          <p:cNvPr id="2830597" name="Image 1" descr="preencoded.png"/>
+          <p:cNvPr id="1891449163" name="Image 1" descr="preencoded.png"/>
           <p:cNvPicPr>
             <a:picLocks noChangeAspect="1"/>
           </p:cNvPicPr>
@@ -10279,7 +10282,7 @@
       </p:pic>
       <p:sp>
         <p:nvSpPr>
-          <p:cNvPr id="809678204" name="Text 2"/>
+          <p:cNvPr id="637304334" name="Text 2"/>
           <p:cNvSpPr txBox="1"/>
           <p:nvPr/>
         </p:nvSpPr>
@@ -10307,7 +10310,7 @@
       </p:sp>
       <p:sp>
         <p:nvSpPr>
-          <p:cNvPr id="1770970291" name="Text 3"/>
+          <p:cNvPr id="1792570015" name="Text 3"/>
           <p:cNvSpPr txBox="1"/>
           <p:nvPr/>
         </p:nvSpPr>
@@ -10349,7 +10352,7 @@
       </p:sp>
       <p:sp>
         <p:nvSpPr>
-          <p:cNvPr id="1966515433" name="Text 4"/>
+          <p:cNvPr id="1240464779" name="Text 4"/>
           <p:cNvSpPr txBox="1"/>
           <p:nvPr/>
         </p:nvSpPr>
@@ -10393,7 +10396,7 @@
       </p:sp>
       <p:pic>
         <p:nvPicPr>
-          <p:cNvPr id="1294958219" name="Image 2" descr="preencoded.png"/>
+          <p:cNvPr id="297698753" name="Image 2" descr="preencoded.png"/>
           <p:cNvPicPr>
             <a:picLocks noChangeAspect="1"/>
           </p:cNvPicPr>
@@ -10415,7 +10418,7 @@
       </p:pic>
       <p:sp>
         <p:nvSpPr>
-          <p:cNvPr id="38393781" name="Text 5"/>
+          <p:cNvPr id="71383884" name="Text 5"/>
           <p:cNvSpPr txBox="1"/>
           <p:nvPr/>
         </p:nvSpPr>
@@ -10457,7 +10460,7 @@
       </p:sp>
       <p:pic>
         <p:nvPicPr>
-          <p:cNvPr id="1089303097" name="Image 3" descr="preencoded.png"/>
+          <p:cNvPr id="1403642998" name="Image 3" descr="preencoded.png"/>
           <p:cNvPicPr>
             <a:picLocks noChangeAspect="1"/>
           </p:cNvPicPr>
@@ -10479,7 +10482,7 @@
       </p:pic>
       <p:sp>
         <p:nvSpPr>
-          <p:cNvPr id="976708835" name="Text 6"/>
+          <p:cNvPr id="1183811142" name="Text 6"/>
           <p:cNvSpPr txBox="1"/>
           <p:nvPr/>
         </p:nvSpPr>
@@ -10507,7 +10510,7 @@
       </p:sp>
       <p:sp>
         <p:nvSpPr>
-          <p:cNvPr id="1315418602" name="Text 7"/>
+          <p:cNvPr id="1536834278" name="Text 7"/>
           <p:cNvSpPr txBox="1"/>
           <p:nvPr/>
         </p:nvSpPr>
@@ -10549,7 +10552,7 @@
       </p:sp>
       <p:sp>
         <p:nvSpPr>
-          <p:cNvPr id="835203451" name="Text 8"/>
+          <p:cNvPr id="1945789804" name="Text 8"/>
           <p:cNvSpPr txBox="1"/>
           <p:nvPr/>
         </p:nvSpPr>
@@ -10593,7 +10596,7 @@
       </p:sp>
       <p:pic>
         <p:nvPicPr>
-          <p:cNvPr id="1481192824" name="Image 4" descr="preencoded.png"/>
+          <p:cNvPr id="1206772175" name="Image 4" descr="preencoded.png"/>
           <p:cNvPicPr>
             <a:picLocks noChangeAspect="1"/>
           </p:cNvPicPr>
@@ -10615,7 +10618,7 @@
       </p:pic>
       <p:sp>
         <p:nvSpPr>
-          <p:cNvPr id="296303373" name="Text 9"/>
+          <p:cNvPr id="1433773012" name="Text 9"/>
           <p:cNvSpPr txBox="1"/>
           <p:nvPr/>
         </p:nvSpPr>
@@ -10657,7 +10660,7 @@
       </p:sp>
       <p:pic>
         <p:nvPicPr>
-          <p:cNvPr id="1679211959" name="Image 5" descr="preencoded.png"/>
+          <p:cNvPr id="492283147" name="Image 5" descr="preencoded.png"/>
           <p:cNvPicPr>
             <a:picLocks noChangeAspect="1"/>
           </p:cNvPicPr>
@@ -10679,7 +10682,7 @@
       </p:pic>
       <p:sp>
         <p:nvSpPr>
-          <p:cNvPr id="1618804013" name="Text 10"/>
+          <p:cNvPr id="735499588" name="Text 10"/>
           <p:cNvSpPr txBox="1"/>
           <p:nvPr/>
         </p:nvSpPr>
@@ -10707,7 +10710,7 @@
       </p:sp>
       <p:sp>
         <p:nvSpPr>
-          <p:cNvPr id="929210913" name="Text 11"/>
+          <p:cNvPr id="1719957357" name="Text 11"/>
           <p:cNvSpPr txBox="1"/>
           <p:nvPr/>
         </p:nvSpPr>
@@ -10749,7 +10752,7 @@
       </p:sp>
       <p:sp>
         <p:nvSpPr>
-          <p:cNvPr id="1310112566" name="Text 12"/>
+          <p:cNvPr id="884114807" name="Text 12"/>
           <p:cNvSpPr txBox="1"/>
           <p:nvPr/>
         </p:nvSpPr>
@@ -10793,7 +10796,7 @@
       </p:sp>
       <p:pic>
         <p:nvPicPr>
-          <p:cNvPr id="2140339143" name="Image 6" descr="preencoded.png"/>
+          <p:cNvPr id="23211872" name="Image 6" descr="preencoded.png"/>
           <p:cNvPicPr>
             <a:picLocks noChangeAspect="1"/>
           </p:cNvPicPr>
@@ -10815,7 +10818,7 @@
       </p:pic>
       <p:sp>
         <p:nvSpPr>
-          <p:cNvPr id="731654049" name="Text 13"/>
+          <p:cNvPr id="1146773503" name="Text 13"/>
           <p:cNvSpPr txBox="1"/>
           <p:nvPr/>
         </p:nvSpPr>
@@ -10857,7 +10860,7 @@
       </p:sp>
       <p:sp>
         <p:nvSpPr>
-          <p:cNvPr id="1830479118" name="Text 14"/>
+          <p:cNvPr id="485182218" name="Text 14"/>
           <p:cNvSpPr txBox="1"/>
           <p:nvPr/>
         </p:nvSpPr>
@@ -10904,7 +10907,7 @@
       </p:sp>
       <p:sp>
         <p:nvSpPr>
-          <p:cNvPr id="586622896" name="Text 15"/>
+          <p:cNvPr id="1909728903" name="Text 15"/>
           <p:cNvSpPr txBox="1"/>
           <p:nvPr/>
         </p:nvSpPr>
@@ -10946,7 +10949,7 @@
       </p:sp>
       <p:pic>
         <p:nvPicPr>
-          <p:cNvPr id="411233871" name="Image 7" descr="preencoded.png"/>
+          <p:cNvPr id="477022940" name="Image 7" descr="preencoded.png"/>
           <p:cNvPicPr>
             <a:picLocks noChangeAspect="1"/>
           </p:cNvPicPr>
@@ -10968,7 +10971,7 @@
       </p:pic>
       <p:sp>
         <p:nvSpPr>
-          <p:cNvPr id="1932060514" name="Text 16"/>
+          <p:cNvPr id="1986270140" name="Text 16"/>
           <p:cNvSpPr txBox="1"/>
           <p:nvPr/>
         </p:nvSpPr>
@@ -11010,7 +11013,7 @@
       </p:sp>
       <p:sp>
         <p:nvSpPr>
-          <p:cNvPr id="1713997522" name="Text 17"/>
+          <p:cNvPr id="141099905" name="Text 17"/>
           <p:cNvSpPr txBox="1"/>
           <p:nvPr/>
         </p:nvSpPr>
@@ -11057,7 +11060,7 @@
       </p:sp>
       <p:sp>
         <p:nvSpPr>
-          <p:cNvPr id="1869043592" name="Text 18"/>
+          <p:cNvPr id="1411995807" name="Text 18"/>
           <p:cNvSpPr txBox="1"/>
           <p:nvPr/>
         </p:nvSpPr>
@@ -11144,7 +11147,7 @@
                                           </p:stCondLst>
                                         </p:cTn>
                                         <p:tgtEl>
-                                          <p:spTgt spid="657844124"/>
+                                          <p:spTgt spid="1543916807"/>
                                         </p:tgtEl>
                                         <p:attrNameLst>
                                           <p:attrName>style.visibility</p:attrName>
@@ -11171,7 +11174,7 @@
                                           </p:stCondLst>
                                         </p:cTn>
                                         <p:tgtEl>
-                                          <p:spTgt spid="418782816"/>
+                                          <p:spTgt spid="858479948"/>
                                         </p:tgtEl>
                                         <p:attrNameLst>
                                           <p:attrName>style.visibility</p:attrName>
@@ -11198,7 +11201,7 @@
                                           </p:stCondLst>
                                         </p:cTn>
                                         <p:tgtEl>
-                                          <p:spTgt spid="2830597"/>
+                                          <p:spTgt spid="1891449163"/>
                                         </p:tgtEl>
                                         <p:attrNameLst>
                                           <p:attrName>style.visibility</p:attrName>
@@ -11225,7 +11228,7 @@
                                           </p:stCondLst>
                                         </p:cTn>
                                         <p:tgtEl>
-                                          <p:spTgt spid="809678204"/>
+                                          <p:spTgt spid="637304334"/>
                                         </p:tgtEl>
                                         <p:attrNameLst>
                                           <p:attrName>style.visibility</p:attrName>
@@ -11252,7 +11255,7 @@
                                           </p:stCondLst>
                                         </p:cTn>
                                         <p:tgtEl>
-                                          <p:spTgt spid="1770970291"/>
+                                          <p:spTgt spid="1792570015"/>
                                         </p:tgtEl>
                                         <p:attrNameLst>
                                           <p:attrName>style.visibility</p:attrName>
@@ -11279,7 +11282,7 @@
                                           </p:stCondLst>
                                         </p:cTn>
                                         <p:tgtEl>
-                                          <p:spTgt spid="1966515433"/>
+                                          <p:spTgt spid="1240464779"/>
                                         </p:tgtEl>
                                         <p:attrNameLst>
                                           <p:attrName>style.visibility</p:attrName>
@@ -11324,7 +11327,7 @@
                                           </p:stCondLst>
                                         </p:cTn>
                                         <p:tgtEl>
-                                          <p:spTgt spid="1294958219"/>
+                                          <p:spTgt spid="297698753"/>
                                         </p:tgtEl>
                                         <p:attrNameLst>
                                           <p:attrName>style.visibility</p:attrName>
@@ -11351,7 +11354,7 @@
                                           </p:stCondLst>
                                         </p:cTn>
                                         <p:tgtEl>
-                                          <p:spTgt spid="38393781"/>
+                                          <p:spTgt spid="71383884"/>
                                         </p:tgtEl>
                                         <p:attrNameLst>
                                           <p:attrName>style.visibility</p:attrName>
@@ -11378,7 +11381,7 @@
                                           </p:stCondLst>
                                         </p:cTn>
                                         <p:tgtEl>
-                                          <p:spTgt spid="1089303097"/>
+                                          <p:spTgt spid="1403642998"/>
                                         </p:tgtEl>
                                         <p:attrNameLst>
                                           <p:attrName>style.visibility</p:attrName>
@@ -11405,7 +11408,7 @@
                                           </p:stCondLst>
                                         </p:cTn>
                                         <p:tgtEl>
-                                          <p:spTgt spid="976708835"/>
+                                          <p:spTgt spid="1183811142"/>
                                         </p:tgtEl>
                                         <p:attrNameLst>
                                           <p:attrName>style.visibility</p:attrName>
@@ -11432,7 +11435,7 @@
                                           </p:stCondLst>
                                         </p:cTn>
                                         <p:tgtEl>
-                                          <p:spTgt spid="1315418602"/>
+                                          <p:spTgt spid="1536834278"/>
                                         </p:tgtEl>
                                         <p:attrNameLst>
                                           <p:attrName>style.visibility</p:attrName>
@@ -11459,7 +11462,7 @@
                                           </p:stCondLst>
                                         </p:cTn>
                                         <p:tgtEl>
-                                          <p:spTgt spid="835203451"/>
+                                          <p:spTgt spid="1945789804"/>
                                         </p:tgtEl>
                                         <p:attrNameLst>
                                           <p:attrName>style.visibility</p:attrName>
@@ -11504,7 +11507,7 @@
                                           </p:stCondLst>
                                         </p:cTn>
                                         <p:tgtEl>
-                                          <p:spTgt spid="1481192824"/>
+                                          <p:spTgt spid="1206772175"/>
                                         </p:tgtEl>
                                         <p:attrNameLst>
                                           <p:attrName>style.visibility</p:attrName>
@@ -11531,7 +11534,7 @@
                                           </p:stCondLst>
                                         </p:cTn>
                                         <p:tgtEl>
-                                          <p:spTgt spid="296303373"/>
+                                          <p:spTgt spid="1433773012"/>
                                         </p:tgtEl>
                                         <p:attrNameLst>
                                           <p:attrName>style.visibility</p:attrName>
@@ -11558,7 +11561,7 @@
                                           </p:stCondLst>
                                         </p:cTn>
                                         <p:tgtEl>
-                                          <p:spTgt spid="1679211959"/>
+                                          <p:spTgt spid="492283147"/>
                                         </p:tgtEl>
                                         <p:attrNameLst>
                                           <p:attrName>style.visibility</p:attrName>
@@ -11585,7 +11588,7 @@
                                           </p:stCondLst>
                                         </p:cTn>
                                         <p:tgtEl>
-                                          <p:spTgt spid="1618804013"/>
+                                          <p:spTgt spid="735499588"/>
                                         </p:tgtEl>
                                         <p:attrNameLst>
                                           <p:attrName>style.visibility</p:attrName>
@@ -11612,7 +11615,7 @@
                                           </p:stCondLst>
                                         </p:cTn>
                                         <p:tgtEl>
-                                          <p:spTgt spid="929210913"/>
+                                          <p:spTgt spid="1719957357"/>
                                         </p:tgtEl>
                                         <p:attrNameLst>
                                           <p:attrName>style.visibility</p:attrName>
@@ -11639,7 +11642,7 @@
                                           </p:stCondLst>
                                         </p:cTn>
                                         <p:tgtEl>
-                                          <p:spTgt spid="1310112566"/>
+                                          <p:spTgt spid="884114807"/>
                                         </p:tgtEl>
                                         <p:attrNameLst>
                                           <p:attrName>style.visibility</p:attrName>
@@ -11684,7 +11687,7 @@
                                           </p:stCondLst>
                                         </p:cTn>
                                         <p:tgtEl>
-                                          <p:spTgt spid="2140339143"/>
+                                          <p:spTgt spid="23211872"/>
                                         </p:tgtEl>
                                         <p:attrNameLst>
                                           <p:attrName>style.visibility</p:attrName>
@@ -11711,7 +11714,7 @@
                                           </p:stCondLst>
                                         </p:cTn>
                                         <p:tgtEl>
-                                          <p:spTgt spid="731654049"/>
+                                          <p:spTgt spid="1146773503"/>
                                         </p:tgtEl>
                                         <p:attrNameLst>
                                           <p:attrName>style.visibility</p:attrName>
@@ -11738,7 +11741,7 @@
                                           </p:stCondLst>
                                         </p:cTn>
                                         <p:tgtEl>
-                                          <p:spTgt spid="1830479118"/>
+                                          <p:spTgt spid="485182218"/>
                                         </p:tgtEl>
                                         <p:attrNameLst>
                                           <p:attrName>style.visibility</p:attrName>
@@ -11765,7 +11768,7 @@
                                           </p:stCondLst>
                                         </p:cTn>
                                         <p:tgtEl>
-                                          <p:spTgt spid="586622896"/>
+                                          <p:spTgt spid="1909728903"/>
                                         </p:tgtEl>
                                         <p:attrNameLst>
                                           <p:attrName>style.visibility</p:attrName>
@@ -11792,7 +11795,7 @@
                                           </p:stCondLst>
                                         </p:cTn>
                                         <p:tgtEl>
-                                          <p:spTgt spid="411233871"/>
+                                          <p:spTgt spid="477022940"/>
                                         </p:tgtEl>
                                         <p:attrNameLst>
                                           <p:attrName>style.visibility</p:attrName>
@@ -11819,7 +11822,7 @@
                                           </p:stCondLst>
                                         </p:cTn>
                                         <p:tgtEl>
-                                          <p:spTgt spid="1932060514"/>
+                                          <p:spTgt spid="1986270140"/>
                                         </p:tgtEl>
                                         <p:attrNameLst>
                                           <p:attrName>style.visibility</p:attrName>
@@ -11846,7 +11849,7 @@
                                           </p:stCondLst>
                                         </p:cTn>
                                         <p:tgtEl>
-                                          <p:spTgt spid="1713997522"/>
+                                          <p:spTgt spid="141099905"/>
                                         </p:tgtEl>
                                         <p:attrNameLst>
                                           <p:attrName>style.visibility</p:attrName>
@@ -11873,7 +11876,7 @@
                                           </p:stCondLst>
                                         </p:cTn>
                                         <p:tgtEl>
-                                          <p:spTgt spid="1869043592"/>
+                                          <p:spTgt spid="1411995807"/>
                                         </p:tgtEl>
                                         <p:attrNameLst>
                                           <p:attrName>style.visibility</p:attrName>
@@ -11943,7 +11946,7 @@
       </p:grpSpPr>
       <p:sp>
         <p:nvSpPr>
-          <p:cNvPr id="730329308" name="Text 0"/>
+          <p:cNvPr id="445825198" name="Text 0"/>
           <p:cNvSpPr txBox="1"/>
           <p:nvPr/>
         </p:nvSpPr>
@@ -12015,7 +12018,7 @@
       </p:sp>
       <p:pic>
         <p:nvPicPr>
-          <p:cNvPr id="1883300064" name="Image 0" descr="preencoded.png"/>
+          <p:cNvPr id="361754413" name="Image 0" descr="preencoded.png"/>
           <p:cNvPicPr>
             <a:picLocks noChangeAspect="1"/>
           </p:cNvPicPr>
@@ -12037,7 +12040,7 @@
       </p:pic>
       <p:sp>
         <p:nvSpPr>
-          <p:cNvPr id="1844085100" name="Text 2"/>
+          <p:cNvPr id="1040412438" name="Text 2"/>
           <p:cNvSpPr txBox="1"/>
           <p:nvPr/>
         </p:nvSpPr>
@@ -12068,7 +12071,7 @@
       </p:sp>
       <p:sp>
         <p:nvSpPr>
-          <p:cNvPr id="1548997097" name="Text 3"/>
+          <p:cNvPr id="649528534" name="Text 3"/>
           <p:cNvSpPr txBox="1"/>
           <p:nvPr/>
         </p:nvSpPr>
@@ -12110,7 +12113,7 @@
       </p:sp>
       <p:sp>
         <p:nvSpPr>
-          <p:cNvPr id="689078818" name="Text 4"/>
+          <p:cNvPr id="1194266509" name="Text 4"/>
           <p:cNvSpPr txBox="1"/>
           <p:nvPr/>
         </p:nvSpPr>
@@ -12152,7 +12155,7 @@
       </p:sp>
       <p:pic>
         <p:nvPicPr>
-          <p:cNvPr id="1693331745" name="Image 1" descr="preencoded.png"/>
+          <p:cNvPr id="1817035683" name="Image 1" descr="preencoded.png"/>
           <p:cNvPicPr>
             <a:picLocks noChangeAspect="1"/>
           </p:cNvPicPr>
@@ -12174,7 +12177,7 @@
       </p:pic>
       <p:sp>
         <p:nvSpPr>
-          <p:cNvPr id="2081773622" name="Text 5"/>
+          <p:cNvPr id="1397256461" name="Text 5"/>
           <p:cNvSpPr txBox="1"/>
           <p:nvPr/>
         </p:nvSpPr>
@@ -12219,7 +12222,7 @@
       </p:sp>
       <p:pic>
         <p:nvPicPr>
-          <p:cNvPr id="1463139667" name="Image 2" descr="preencoded.png"/>
+          <p:cNvPr id="1520732368" name="Image 2" descr="preencoded.png"/>
           <p:cNvPicPr>
             <a:picLocks noChangeAspect="1"/>
           </p:cNvPicPr>
@@ -12241,7 +12244,7 @@
       </p:pic>
       <p:sp>
         <p:nvSpPr>
-          <p:cNvPr id="1773803996" name="Text 6"/>
+          <p:cNvPr id="500532001" name="Text 6"/>
           <p:cNvSpPr txBox="1"/>
           <p:nvPr/>
         </p:nvSpPr>
@@ -12288,7 +12291,7 @@
       </p:sp>
       <p:pic>
         <p:nvPicPr>
-          <p:cNvPr id="974627128" name="Image 3" descr="preencoded.png"/>
+          <p:cNvPr id="514711915" name="Image 3" descr="preencoded.png"/>
           <p:cNvPicPr>
             <a:picLocks noChangeAspect="1"/>
           </p:cNvPicPr>
@@ -12310,7 +12313,7 @@
       </p:pic>
       <p:sp>
         <p:nvSpPr>
-          <p:cNvPr id="283436933" name="Text 7"/>
+          <p:cNvPr id="1425410041" name="Text 7"/>
           <p:cNvSpPr txBox="1"/>
           <p:nvPr/>
         </p:nvSpPr>
@@ -12357,7 +12360,7 @@
       </p:sp>
       <p:pic>
         <p:nvPicPr>
-          <p:cNvPr id="1203022005" name="Image 4" descr="preencoded.png"/>
+          <p:cNvPr id="722927030" name="Image 4" descr="preencoded.png"/>
           <p:cNvPicPr>
             <a:picLocks noChangeAspect="1"/>
           </p:cNvPicPr>
@@ -12379,7 +12382,7 @@
       </p:pic>
       <p:sp>
         <p:nvSpPr>
-          <p:cNvPr id="1386436551" name="Text 9"/>
+          <p:cNvPr id="1466490633" name="Text 9"/>
           <p:cNvSpPr txBox="1"/>
           <p:nvPr/>
         </p:nvSpPr>
@@ -12410,7 +12413,7 @@
       </p:sp>
       <p:sp>
         <p:nvSpPr>
-          <p:cNvPr id="1359099400" name="Text 10"/>
+          <p:cNvPr id="2002263251" name="Text 10"/>
           <p:cNvSpPr txBox="1"/>
           <p:nvPr/>
         </p:nvSpPr>
@@ -12452,7 +12455,7 @@
       </p:sp>
       <p:sp>
         <p:nvSpPr>
-          <p:cNvPr id="571618745" name="Text 11"/>
+          <p:cNvPr id="81171020" name="Text 11"/>
           <p:cNvSpPr txBox="1"/>
           <p:nvPr/>
         </p:nvSpPr>
@@ -12494,7 +12497,7 @@
       </p:sp>
       <p:pic>
         <p:nvPicPr>
-          <p:cNvPr id="312738088" name="Image 5" descr="preencoded.png"/>
+          <p:cNvPr id="151770486" name="Image 5" descr="preencoded.png"/>
           <p:cNvPicPr>
             <a:picLocks noChangeAspect="1"/>
           </p:cNvPicPr>
@@ -12516,7 +12519,7 @@
       </p:pic>
       <p:sp>
         <p:nvSpPr>
-          <p:cNvPr id="713026759" name="Text 12"/>
+          <p:cNvPr id="2091585077" name="Text 12"/>
           <p:cNvSpPr txBox="1"/>
           <p:nvPr/>
         </p:nvSpPr>
@@ -12561,7 +12564,7 @@
       </p:sp>
       <p:pic>
         <p:nvPicPr>
-          <p:cNvPr id="371094956" name="Image 6" descr="preencoded.png"/>
+          <p:cNvPr id="1919678969" name="Image 6" descr="preencoded.png"/>
           <p:cNvPicPr>
             <a:picLocks noChangeAspect="1"/>
           </p:cNvPicPr>
@@ -12583,7 +12586,7 @@
       </p:pic>
       <p:sp>
         <p:nvSpPr>
-          <p:cNvPr id="1627667145" name="Text 13"/>
+          <p:cNvPr id="1987009862" name="Text 13"/>
           <p:cNvSpPr txBox="1"/>
           <p:nvPr/>
         </p:nvSpPr>
@@ -12630,7 +12633,7 @@
       </p:sp>
       <p:pic>
         <p:nvPicPr>
-          <p:cNvPr id="941924350" name="Image 7" descr="preencoded.png"/>
+          <p:cNvPr id="1981103467" name="Image 7" descr="preencoded.png"/>
           <p:cNvPicPr>
             <a:picLocks noChangeAspect="1"/>
           </p:cNvPicPr>
@@ -12652,7 +12655,7 @@
       </p:pic>
       <p:sp>
         <p:nvSpPr>
-          <p:cNvPr id="1688188826" name="Text 14"/>
+          <p:cNvPr id="1589094451" name="Text 14"/>
           <p:cNvSpPr txBox="1"/>
           <p:nvPr/>
         </p:nvSpPr>
@@ -12699,7 +12702,7 @@
       </p:sp>
       <p:pic>
         <p:nvPicPr>
-          <p:cNvPr id="194628175" name="Image 8" descr="preencoded.png"/>
+          <p:cNvPr id="65055049" name="Image 8" descr="preencoded.png"/>
           <p:cNvPicPr>
             <a:picLocks noChangeAspect="1"/>
           </p:cNvPicPr>
@@ -12721,7 +12724,7 @@
       </p:pic>
       <p:sp>
         <p:nvSpPr>
-          <p:cNvPr id="1298068982" name="Text 16"/>
+          <p:cNvPr id="1749201060" name="Text 16"/>
           <p:cNvSpPr txBox="1"/>
           <p:nvPr/>
         </p:nvSpPr>
@@ -12752,7 +12755,7 @@
       </p:sp>
       <p:sp>
         <p:nvSpPr>
-          <p:cNvPr id="126943014" name="Text 17"/>
+          <p:cNvPr id="2053522613" name="Text 17"/>
           <p:cNvSpPr txBox="1"/>
           <p:nvPr/>
         </p:nvSpPr>
@@ -12794,7 +12797,7 @@
       </p:sp>
       <p:sp>
         <p:nvSpPr>
-          <p:cNvPr id="576612315" name="Text 18"/>
+          <p:cNvPr id="65159843" name="Text 18"/>
           <p:cNvSpPr txBox="1"/>
           <p:nvPr/>
         </p:nvSpPr>
@@ -12836,7 +12839,7 @@
       </p:sp>
       <p:pic>
         <p:nvPicPr>
-          <p:cNvPr id="1734203473" name="Image 9" descr="preencoded.png"/>
+          <p:cNvPr id="625828764" name="Image 9" descr="preencoded.png"/>
           <p:cNvPicPr>
             <a:picLocks noChangeAspect="1"/>
           </p:cNvPicPr>
@@ -12858,7 +12861,7 @@
       </p:pic>
       <p:sp>
         <p:nvSpPr>
-          <p:cNvPr id="118244875" name="Text 19"/>
+          <p:cNvPr id="1647497232" name="Text 19"/>
           <p:cNvSpPr txBox="1"/>
           <p:nvPr/>
         </p:nvSpPr>
@@ -12903,7 +12906,7 @@
       </p:sp>
       <p:pic>
         <p:nvPicPr>
-          <p:cNvPr id="1429945510" name="Image 10" descr="preencoded.png"/>
+          <p:cNvPr id="955157546" name="Image 10" descr="preencoded.png"/>
           <p:cNvPicPr>
             <a:picLocks noChangeAspect="1"/>
           </p:cNvPicPr>
@@ -12925,7 +12928,7 @@
       </p:pic>
       <p:sp>
         <p:nvSpPr>
-          <p:cNvPr id="620036554" name="Text 20"/>
+          <p:cNvPr id="917561258" name="Text 20"/>
           <p:cNvSpPr txBox="1"/>
           <p:nvPr/>
         </p:nvSpPr>
@@ -12972,7 +12975,7 @@
       </p:sp>
       <p:pic>
         <p:nvPicPr>
-          <p:cNvPr id="1352651950" name="Image 11" descr="preencoded.png"/>
+          <p:cNvPr id="1463433352" name="Image 11" descr="preencoded.png"/>
           <p:cNvPicPr>
             <a:picLocks noChangeAspect="1"/>
           </p:cNvPicPr>
@@ -12994,7 +12997,7 @@
       </p:pic>
       <p:sp>
         <p:nvSpPr>
-          <p:cNvPr id="494994934" name="Text 21"/>
+          <p:cNvPr id="596875129" name="Text 21"/>
           <p:cNvSpPr txBox="1"/>
           <p:nvPr/>
         </p:nvSpPr>
@@ -13041,7 +13044,7 @@
       </p:sp>
       <p:pic>
         <p:nvPicPr>
-          <p:cNvPr id="1577797127" name="Image 12" descr="preencoded.png"/>
+          <p:cNvPr id="1142490640" name="Image 12" descr="preencoded.png"/>
           <p:cNvPicPr>
             <a:picLocks noChangeAspect="1"/>
           </p:cNvPicPr>
@@ -13063,7 +13066,7 @@
       </p:pic>
       <p:sp>
         <p:nvSpPr>
-          <p:cNvPr id="999729112" name="Text 23"/>
+          <p:cNvPr id="628479833" name="Text 23"/>
           <p:cNvSpPr txBox="1"/>
           <p:nvPr/>
         </p:nvSpPr>
@@ -13094,7 +13097,7 @@
       </p:sp>
       <p:sp>
         <p:nvSpPr>
-          <p:cNvPr id="1724249153" name="Text 24"/>
+          <p:cNvPr id="413923493" name="Text 24"/>
           <p:cNvSpPr txBox="1"/>
           <p:nvPr/>
         </p:nvSpPr>
@@ -13136,7 +13139,7 @@
       </p:sp>
       <p:sp>
         <p:nvSpPr>
-          <p:cNvPr id="143584259" name="Text 25"/>
+          <p:cNvPr id="745095010" name="Text 25"/>
           <p:cNvSpPr txBox="1"/>
           <p:nvPr/>
         </p:nvSpPr>
@@ -13189,7 +13192,7 @@
       </p:sp>
       <p:pic>
         <p:nvPicPr>
-          <p:cNvPr id="123278500" name="Image 13" descr="preencoded.png"/>
+          <p:cNvPr id="638261627" name="Image 13" descr="preencoded.png"/>
           <p:cNvPicPr>
             <a:picLocks noChangeAspect="1"/>
           </p:cNvPicPr>
@@ -13211,7 +13214,7 @@
       </p:pic>
       <p:sp>
         <p:nvSpPr>
-          <p:cNvPr id="1330060487" name="Text 26"/>
+          <p:cNvPr id="963069155" name="Text 26"/>
           <p:cNvSpPr txBox="1"/>
           <p:nvPr/>
         </p:nvSpPr>
@@ -13256,7 +13259,7 @@
       </p:sp>
       <p:pic>
         <p:nvPicPr>
-          <p:cNvPr id="251870076" name="Image 14" descr="preencoded.png"/>
+          <p:cNvPr id="1538295841" name="Image 14" descr="preencoded.png"/>
           <p:cNvPicPr>
             <a:picLocks noChangeAspect="1"/>
           </p:cNvPicPr>
@@ -13278,7 +13281,7 @@
       </p:pic>
       <p:sp>
         <p:nvSpPr>
-          <p:cNvPr id="230999409" name="Text 27"/>
+          <p:cNvPr id="54239043" name="Text 27"/>
           <p:cNvSpPr txBox="1"/>
           <p:nvPr/>
         </p:nvSpPr>
@@ -13325,7 +13328,7 @@
       </p:sp>
       <p:pic>
         <p:nvPicPr>
-          <p:cNvPr id="325870645" name="Image 15" descr="preencoded.png"/>
+          <p:cNvPr id="938457394" name="Image 15" descr="preencoded.png"/>
           <p:cNvPicPr>
             <a:picLocks noChangeAspect="1"/>
           </p:cNvPicPr>
@@ -13347,7 +13350,7 @@
       </p:pic>
       <p:sp>
         <p:nvSpPr>
-          <p:cNvPr id="545628077" name="Text 28"/>
+          <p:cNvPr id="1761729143" name="Text 28"/>
           <p:cNvSpPr txBox="1"/>
           <p:nvPr/>
         </p:nvSpPr>
@@ -13394,7 +13397,7 @@
       </p:sp>
       <p:pic>
         <p:nvPicPr>
-          <p:cNvPr id="1140666170" name="Image 16" descr="preencoded.png"/>
+          <p:cNvPr id="834739752" name="Image 16" descr="preencoded.png"/>
           <p:cNvPicPr>
             <a:picLocks noChangeAspect="1"/>
           </p:cNvPicPr>
@@ -13416,7 +13419,7 @@
       </p:pic>
       <p:sp>
         <p:nvSpPr>
-          <p:cNvPr id="492514766" name="Shape 30"/>
+          <p:cNvPr id="1492409162" name="Shape 30"/>
           <p:cNvSpPr/>
           <p:nvPr/>
         </p:nvSpPr>
@@ -13438,7 +13441,7 @@
       </p:sp>
       <p:sp>
         <p:nvSpPr>
-          <p:cNvPr id="1111750395" name="Text 31"/>
+          <p:cNvPr id="73635071" name="Text 31"/>
           <p:cNvSpPr txBox="1"/>
           <p:nvPr/>
         </p:nvSpPr>
@@ -14214,7 +14217,7 @@
       </p:grpSpPr>
       <p:sp>
         <p:nvSpPr>
-          <p:cNvPr id="152374014" name="Text 0"/>
+          <p:cNvPr id="1282114511" name="Text 0"/>
           <p:cNvSpPr txBox="1"/>
           <p:nvPr/>
         </p:nvSpPr>
@@ -14256,7 +14259,7 @@
       </p:sp>
       <p:sp>
         <p:nvSpPr>
-          <p:cNvPr id="374197078" name="Text 3"/>
+          <p:cNvPr id="1558648001" name="Text 3"/>
           <p:cNvSpPr txBox="1"/>
           <p:nvPr/>
         </p:nvSpPr>
@@ -14287,7 +14290,7 @@
       </p:sp>
       <p:sp>
         <p:nvSpPr>
-          <p:cNvPr id="2045544628" name="Text 8"/>
+          <p:cNvPr id="784387038" name="Text 8"/>
           <p:cNvSpPr txBox="1"/>
           <p:nvPr/>
         </p:nvSpPr>
@@ -14329,7 +14332,7 @@
       </p:sp>
       <p:pic>
         <p:nvPicPr>
-          <p:cNvPr id="1476744041" name="Image 1" descr="preencoded.png"/>
+          <p:cNvPr id="1700652519" name="Image 1" descr="preencoded.png"/>
           <p:cNvPicPr>
             <a:picLocks noChangeAspect="1"/>
           </p:cNvPicPr>
@@ -14351,7 +14354,7 @@
       </p:pic>
       <p:sp>
         <p:nvSpPr>
-          <p:cNvPr id="1565175968" name="Text 9"/>
+          <p:cNvPr id="677585808" name="Text 9"/>
           <p:cNvSpPr txBox="1"/>
           <p:nvPr/>
         </p:nvSpPr>
@@ -14825,7 +14828,7 @@
                                           </p:stCondLst>
                                         </p:cTn>
                                         <p:tgtEl>
-                                          <p:spTgt spid="2045544628"/>
+                                          <p:spTgt spid="784387038"/>
                                         </p:tgtEl>
                                         <p:attrNameLst>
                                           <p:attrName>style.visibility</p:attrName>
@@ -14852,7 +14855,7 @@
                                           </p:stCondLst>
                                         </p:cTn>
                                         <p:tgtEl>
-                                          <p:spTgt spid="1476744041"/>
+                                          <p:spTgt spid="1700652519"/>
                                         </p:tgtEl>
                                         <p:attrNameLst>
                                           <p:attrName>style.visibility</p:attrName>
@@ -14879,7 +14882,7 @@
                                           </p:stCondLst>
                                         </p:cTn>
                                         <p:tgtEl>
-                                          <p:spTgt spid="1565175968"/>
+                                          <p:spTgt spid="677585808"/>
                                         </p:tgtEl>
                                         <p:attrNameLst>
                                           <p:attrName>style.visibility</p:attrName>
@@ -14949,7 +14952,7 @@
       </p:grpSpPr>
       <p:sp>
         <p:nvSpPr>
-          <p:cNvPr id="643013417" name="Text 0"/>
+          <p:cNvPr id="244259589" name="Text 0"/>
           <p:cNvSpPr txBox="1"/>
           <p:nvPr/>
         </p:nvSpPr>
@@ -15002,7 +15005,7 @@
       </p:sp>
       <p:pic>
         <p:nvPicPr>
-          <p:cNvPr id="1732175162" name="Image 0" descr="preencoded.png"/>
+          <p:cNvPr id="951293022" name="Image 0" descr="preencoded.png"/>
           <p:cNvPicPr>
             <a:picLocks noChangeAspect="1"/>
           </p:cNvPicPr>
@@ -15024,7 +15027,7 @@
       </p:pic>
       <p:sp>
         <p:nvSpPr>
-          <p:cNvPr id="131450688" name="Text 1"/>
+          <p:cNvPr id="111297844" name="Text 1"/>
           <p:cNvSpPr txBox="1"/>
           <p:nvPr/>
         </p:nvSpPr>
@@ -15066,7 +15069,7 @@
       </p:sp>
       <p:sp>
         <p:nvSpPr>
-          <p:cNvPr id="341541080" name="Text 2"/>
+          <p:cNvPr id="1234485164" name="Text 2"/>
           <p:cNvSpPr txBox="1"/>
           <p:nvPr/>
         </p:nvSpPr>
@@ -15108,7 +15111,7 @@
       </p:sp>
       <p:pic>
         <p:nvPicPr>
-          <p:cNvPr id="828092939" name="Image 1" descr="preencoded.png"/>
+          <p:cNvPr id="252508751" name="Image 1" descr="preencoded.png"/>
           <p:cNvPicPr>
             <a:picLocks noChangeAspect="1"/>
           </p:cNvPicPr>
@@ -15130,7 +15133,7 @@
       </p:pic>
       <p:sp>
         <p:nvSpPr>
-          <p:cNvPr id="400132352" name="Text 3"/>
+          <p:cNvPr id="2142934935" name="Text 3"/>
           <p:cNvSpPr txBox="1"/>
           <p:nvPr/>
         </p:nvSpPr>
@@ -15172,7 +15175,7 @@
       </p:sp>
       <p:sp>
         <p:nvSpPr>
-          <p:cNvPr id="920859234" name="Text 4"/>
+          <p:cNvPr id="1653497091" name="Text 4"/>
           <p:cNvSpPr txBox="1"/>
           <p:nvPr/>
         </p:nvSpPr>
@@ -15224,7 +15227,7 @@
       </p:sp>
       <p:pic>
         <p:nvPicPr>
-          <p:cNvPr id="1942550973" name="Image 2" descr="preencoded.png"/>
+          <p:cNvPr id="1722882232" name="Image 2" descr="preencoded.png"/>
           <p:cNvPicPr>
             <a:picLocks noChangeAspect="1"/>
           </p:cNvPicPr>
@@ -15246,7 +15249,7 @@
       </p:pic>
       <p:sp>
         <p:nvSpPr>
-          <p:cNvPr id="326931667" name="Text 5"/>
+          <p:cNvPr id="1322786675" name="Text 5"/>
           <p:cNvSpPr txBox="1"/>
           <p:nvPr/>
         </p:nvSpPr>
@@ -15288,7 +15291,7 @@
       </p:sp>
       <p:sp>
         <p:nvSpPr>
-          <p:cNvPr id="367809030" name="Text 6"/>
+          <p:cNvPr id="2069784037" name="Text 6"/>
           <p:cNvSpPr txBox="1"/>
           <p:nvPr/>
         </p:nvSpPr>
@@ -15330,7 +15333,7 @@
       </p:sp>
       <p:pic>
         <p:nvPicPr>
-          <p:cNvPr id="1975630114" name="Image 3" descr="preencoded.png"/>
+          <p:cNvPr id="404858032" name="Image 3" descr="preencoded.png"/>
           <p:cNvPicPr>
             <a:picLocks noChangeAspect="1"/>
           </p:cNvPicPr>
@@ -15352,7 +15355,7 @@
       </p:pic>
       <p:sp>
         <p:nvSpPr>
-          <p:cNvPr id="341992437" name="Text 7"/>
+          <p:cNvPr id="835523337" name="Text 7"/>
           <p:cNvSpPr txBox="1"/>
           <p:nvPr/>
         </p:nvSpPr>
@@ -15415,7 +15418,7 @@
       </p:sp>
       <p:sp>
         <p:nvSpPr>
-          <p:cNvPr id="941684454" name="Text 8"/>
+          <p:cNvPr id="559933635" name="Text 8"/>
           <p:cNvSpPr txBox="1"/>
           <p:nvPr/>
         </p:nvSpPr>
@@ -15480,7 +15483,7 @@
       </p:sp>
       <p:pic>
         <p:nvPicPr>
-          <p:cNvPr id="187115439" name="Image 4" descr="preencoded.png"/>
+          <p:cNvPr id="92068741" name="Image 4" descr="preencoded.png"/>
           <p:cNvPicPr>
             <a:picLocks noChangeAspect="1"/>
           </p:cNvPicPr>
@@ -15502,7 +15505,7 @@
       </p:pic>
       <p:sp>
         <p:nvSpPr>
-          <p:cNvPr id="413860581" name="Text 9"/>
+          <p:cNvPr id="69683310" name="Text 9"/>
           <p:cNvSpPr txBox="1"/>
           <p:nvPr/>
         </p:nvSpPr>
@@ -15544,7 +15547,7 @@
       </p:sp>
       <p:sp>
         <p:nvSpPr>
-          <p:cNvPr id="572929706" name="Text 10"/>
+          <p:cNvPr id="715887746" name="Text 10"/>
           <p:cNvSpPr txBox="1"/>
           <p:nvPr/>
         </p:nvSpPr>
@@ -15586,7 +15589,7 @@
       </p:sp>
       <p:pic>
         <p:nvPicPr>
-          <p:cNvPr id="1560686790" name="Image 5" descr="preencoded.png"/>
+          <p:cNvPr id="1018417685" name="Image 5" descr="preencoded.png"/>
           <p:cNvPicPr>
             <a:picLocks noChangeAspect="1"/>
           </p:cNvPicPr>
@@ -15608,7 +15611,7 @@
       </p:pic>
       <p:sp>
         <p:nvSpPr>
-          <p:cNvPr id="190886780" name="Text 11"/>
+          <p:cNvPr id="1938532900" name="Text 11"/>
           <p:cNvSpPr txBox="1"/>
           <p:nvPr/>
         </p:nvSpPr>
@@ -15692,7 +15695,7 @@
       </p:sp>
       <p:sp>
         <p:nvSpPr>
-          <p:cNvPr id="1644430675" name="Text 12"/>
+          <p:cNvPr id="1762646398" name="Text 12"/>
           <p:cNvSpPr txBox="1"/>
           <p:nvPr/>
         </p:nvSpPr>
@@ -15733,7 +15736,7 @@
       </p:sp>
       <p:pic>
         <p:nvPicPr>
-          <p:cNvPr id="19309316" name="Image 6" descr="preencoded.png"/>
+          <p:cNvPr id="1561852062" name="Image 6" descr="preencoded.png"/>
           <p:cNvPicPr>
             <a:picLocks noChangeAspect="1"/>
           </p:cNvPicPr>
@@ -15755,7 +15758,7 @@
       </p:pic>
       <p:sp>
         <p:nvSpPr>
-          <p:cNvPr id="1038410754" name="Text 13"/>
+          <p:cNvPr id="8299947" name="Text 13"/>
           <p:cNvSpPr txBox="1"/>
           <p:nvPr/>
         </p:nvSpPr>
@@ -15797,7 +15800,7 @@
       </p:sp>
       <p:sp>
         <p:nvSpPr>
-          <p:cNvPr id="78344148" name="Text 14"/>
+          <p:cNvPr id="947004339" name="Text 14"/>
           <p:cNvSpPr txBox="1"/>
           <p:nvPr/>
         </p:nvSpPr>
@@ -15839,7 +15842,7 @@
       </p:sp>
       <p:sp>
         <p:nvSpPr>
-          <p:cNvPr id="454851743" name="Text 15"/>
+          <p:cNvPr id="457911166" name="Text 15"/>
           <p:cNvSpPr txBox="1"/>
           <p:nvPr/>
         </p:nvSpPr>
@@ -15925,7 +15928,7 @@
                                           </p:stCondLst>
                                         </p:cTn>
                                         <p:tgtEl>
-                                          <p:spTgt spid="1732175162"/>
+                                          <p:spTgt spid="951293022"/>
                                         </p:tgtEl>
                                         <p:attrNameLst>
                                           <p:attrName>style.visibility</p:attrName>
@@ -15952,7 +15955,7 @@
                                           </p:stCondLst>
                                         </p:cTn>
                                         <p:tgtEl>
-                                          <p:spTgt spid="131450688"/>
+                                          <p:spTgt spid="111297844"/>
                                         </p:tgtEl>
                                         <p:attrNameLst>
                                           <p:attrName>style.visibility</p:attrName>
@@ -15979,7 +15982,7 @@
                                           </p:stCondLst>
                                         </p:cTn>
                                         <p:tgtEl>
-                                          <p:spTgt spid="341541080"/>
+                                          <p:spTgt spid="1234485164"/>
                                         </p:tgtEl>
                                         <p:attrNameLst>
                                           <p:attrName>style.visibility</p:attrName>
@@ -16006,7 +16009,7 @@
                                           </p:stCondLst>
                                         </p:cTn>
                                         <p:tgtEl>
-                                          <p:spTgt spid="828092939"/>
+                                          <p:spTgt spid="252508751"/>
                                         </p:tgtEl>
                                         <p:attrNameLst>
                                           <p:attrName>style.visibility</p:attrName>
@@ -16033,7 +16036,7 @@
                                           </p:stCondLst>
                                         </p:cTn>
                                         <p:tgtEl>
-                                          <p:spTgt spid="400132352"/>
+                                          <p:spTgt spid="2142934935"/>
                                         </p:tgtEl>
                                         <p:attrNameLst>
                                           <p:attrName>style.visibility</p:attrName>
@@ -16060,7 +16063,7 @@
                                           </p:stCondLst>
                                         </p:cTn>
                                         <p:tgtEl>
-                                          <p:spTgt spid="920859234"/>
+                                          <p:spTgt spid="1653497091"/>
                                         </p:tgtEl>
                                         <p:attrNameLst>
                                           <p:attrName>style.visibility</p:attrName>
@@ -16105,7 +16108,7 @@
                                           </p:stCondLst>
                                         </p:cTn>
                                         <p:tgtEl>
-                                          <p:spTgt spid="1942550973"/>
+                                          <p:spTgt spid="1722882232"/>
                                         </p:tgtEl>
                                         <p:attrNameLst>
                                           <p:attrName>style.visibility</p:attrName>
@@ -16132,7 +16135,7 @@
                                           </p:stCondLst>
                                         </p:cTn>
                                         <p:tgtEl>
-                                          <p:spTgt spid="326931667"/>
+                                          <p:spTgt spid="1322786675"/>
                                         </p:tgtEl>
                                         <p:attrNameLst>
                                           <p:attrName>style.visibility</p:attrName>
@@ -16159,7 +16162,7 @@
                                           </p:stCondLst>
                                         </p:cTn>
                                         <p:tgtEl>
-                                          <p:spTgt spid="367809030"/>
+                                          <p:spTgt spid="2069784037"/>
                                         </p:tgtEl>
                                         <p:attrNameLst>
                                           <p:attrName>style.visibility</p:attrName>
@@ -16186,7 +16189,7 @@
                                           </p:stCondLst>
                                         </p:cTn>
                                         <p:tgtEl>
-                                          <p:spTgt spid="1975630114"/>
+                                          <p:spTgt spid="404858032"/>
                                         </p:tgtEl>
                                         <p:attrNameLst>
                                           <p:attrName>style.visibility</p:attrName>
@@ -16213,7 +16216,7 @@
                                           </p:stCondLst>
                                         </p:cTn>
                                         <p:tgtEl>
-                                          <p:spTgt spid="341992437"/>
+                                          <p:spTgt spid="835523337"/>
                                         </p:tgtEl>
                                         <p:attrNameLst>
                                           <p:attrName>style.visibility</p:attrName>
@@ -16240,7 +16243,7 @@
                                           </p:stCondLst>
                                         </p:cTn>
                                         <p:tgtEl>
-                                          <p:spTgt spid="941684454"/>
+                                          <p:spTgt spid="559933635"/>
                                         </p:tgtEl>
                                         <p:attrNameLst>
                                           <p:attrName>style.visibility</p:attrName>
@@ -16285,7 +16288,7 @@
                                           </p:stCondLst>
                                         </p:cTn>
                                         <p:tgtEl>
-                                          <p:spTgt spid="187115439"/>
+                                          <p:spTgt spid="92068741"/>
                                         </p:tgtEl>
                                         <p:attrNameLst>
                                           <p:attrName>style.visibility</p:attrName>
@@ -16312,7 +16315,7 @@
                                           </p:stCondLst>
                                         </p:cTn>
                                         <p:tgtEl>
-                                          <p:spTgt spid="413860581"/>
+                                          <p:spTgt spid="69683310"/>
                                         </p:tgtEl>
                                         <p:attrNameLst>
                                           <p:attrName>style.visibility</p:attrName>
@@ -16339,7 +16342,7 @@
                                           </p:stCondLst>
                                         </p:cTn>
                                         <p:tgtEl>
-                                          <p:spTgt spid="572929706"/>
+                                          <p:spTgt spid="715887746"/>
                                         </p:tgtEl>
                                         <p:attrNameLst>
                                           <p:attrName>style.visibility</p:attrName>
@@ -16366,7 +16369,7 @@
                                           </p:stCondLst>
                                         </p:cTn>
                                         <p:tgtEl>
-                                          <p:spTgt spid="1560686790"/>
+                                          <p:spTgt spid="1018417685"/>
                                         </p:tgtEl>
                                         <p:attrNameLst>
                                           <p:attrName>style.visibility</p:attrName>
@@ -16393,7 +16396,7 @@
                                           </p:stCondLst>
                                         </p:cTn>
                                         <p:tgtEl>
-                                          <p:spTgt spid="190886780"/>
+                                          <p:spTgt spid="1938532900"/>
                                         </p:tgtEl>
                                         <p:attrNameLst>
                                           <p:attrName>style.visibility</p:attrName>
@@ -16420,7 +16423,7 @@
                                           </p:stCondLst>
                                         </p:cTn>
                                         <p:tgtEl>
-                                          <p:spTgt spid="1644430675"/>
+                                          <p:spTgt spid="1762646398"/>
                                         </p:tgtEl>
                                         <p:attrNameLst>
                                           <p:attrName>style.visibility</p:attrName>
@@ -16465,7 +16468,7 @@
                                           </p:stCondLst>
                                         </p:cTn>
                                         <p:tgtEl>
-                                          <p:spTgt spid="19309316"/>
+                                          <p:spTgt spid="1561852062"/>
                                         </p:tgtEl>
                                         <p:attrNameLst>
                                           <p:attrName>style.visibility</p:attrName>
@@ -16492,7 +16495,7 @@
                                           </p:stCondLst>
                                         </p:cTn>
                                         <p:tgtEl>
-                                          <p:spTgt spid="1038410754"/>
+                                          <p:spTgt spid="8299947"/>
                                         </p:tgtEl>
                                         <p:attrNameLst>
                                           <p:attrName>style.visibility</p:attrName>
@@ -16519,7 +16522,7 @@
                                           </p:stCondLst>
                                         </p:cTn>
                                         <p:tgtEl>
-                                          <p:spTgt spid="78344148"/>
+                                          <p:spTgt spid="947004339"/>
                                         </p:tgtEl>
                                         <p:attrNameLst>
                                           <p:attrName>style.visibility</p:attrName>
@@ -16546,7 +16549,7 @@
                                           </p:stCondLst>
                                         </p:cTn>
                                         <p:tgtEl>
-                                          <p:spTgt spid="454851743"/>
+                                          <p:spTgt spid="457911166"/>
                                         </p:tgtEl>
                                         <p:attrNameLst>
                                           <p:attrName>style.visibility</p:attrName>
@@ -16616,7 +16619,7 @@
       </p:grpSpPr>
       <p:sp>
         <p:nvSpPr>
-          <p:cNvPr id="185337995" name="Text 0"/>
+          <p:cNvPr id="8621146" name="Text 0"/>
           <p:cNvSpPr txBox="1"/>
           <p:nvPr/>
         </p:nvSpPr>
@@ -16666,7 +16669,7 @@
       </p:sp>
       <p:pic>
         <p:nvPicPr>
-          <p:cNvPr id="1894761858" name="Image 0" descr="preencoded.png"/>
+          <p:cNvPr id="312695101" name="Image 0" descr="preencoded.png"/>
           <p:cNvPicPr>
             <a:picLocks noChangeAspect="1"/>
           </p:cNvPicPr>
@@ -16688,7 +16691,7 @@
       </p:pic>
       <p:sp>
         <p:nvSpPr>
-          <p:cNvPr id="1106923826" name="Text 1"/>
+          <p:cNvPr id="1470488259" name="Text 1"/>
           <p:cNvSpPr txBox="1"/>
           <p:nvPr/>
         </p:nvSpPr>
@@ -16732,7 +16735,7 @@
       </p:sp>
       <p:pic>
         <p:nvPicPr>
-          <p:cNvPr id="478113773" name="Image 2" descr="preencoded.png"/>
+          <p:cNvPr id="971982053" name="Image 2" descr="preencoded.png"/>
           <p:cNvPicPr>
             <a:picLocks noChangeAspect="1"/>
           </p:cNvPicPr>
@@ -16754,7 +16757,7 @@
       </p:pic>
       <p:sp>
         <p:nvSpPr>
-          <p:cNvPr id="1606213410" name="Text 2"/>
+          <p:cNvPr id="574501505" name="Text 2"/>
           <p:cNvSpPr txBox="1"/>
           <p:nvPr/>
         </p:nvSpPr>
@@ -16799,7 +16802,7 @@
       </p:sp>
       <p:sp>
         <p:nvSpPr>
-          <p:cNvPr id="124883763" name="Text 3"/>
+          <p:cNvPr id="369544874" name="Text 3"/>
           <p:cNvSpPr txBox="1"/>
           <p:nvPr/>
         </p:nvSpPr>
@@ -16841,7 +16844,7 @@
       </p:sp>
       <p:sp>
         <p:nvSpPr>
-          <p:cNvPr id="2070455389" name="Text 4"/>
+          <p:cNvPr id="635701228" name="Text 4"/>
           <p:cNvSpPr txBox="1"/>
           <p:nvPr/>
         </p:nvSpPr>
@@ -16885,7 +16888,7 @@
       </p:sp>
       <p:sp>
         <p:nvSpPr>
-          <p:cNvPr id="1402567752" name="Text 5"/>
+          <p:cNvPr id="689246356" name="Text 5"/>
           <p:cNvSpPr txBox="1"/>
           <p:nvPr/>
         </p:nvSpPr>
@@ -16927,7 +16930,7 @@
       </p:sp>
       <p:sp>
         <p:nvSpPr>
-          <p:cNvPr id="833050934" name="Text 6"/>
+          <p:cNvPr id="1315037875" name="Text 6"/>
           <p:cNvSpPr txBox="1"/>
           <p:nvPr/>
         </p:nvSpPr>
@@ -16971,7 +16974,7 @@
       </p:sp>
       <p:sp>
         <p:nvSpPr>
-          <p:cNvPr id="82946327" name="Text 7"/>
+          <p:cNvPr id="2112656944" name="Text 7"/>
           <p:cNvSpPr txBox="1"/>
           <p:nvPr/>
         </p:nvSpPr>
@@ -17013,7 +17016,7 @@
       </p:sp>
       <p:sp>
         <p:nvSpPr>
-          <p:cNvPr id="856170407" name="Text 8"/>
+          <p:cNvPr id="2135220451" name="Text 8"/>
           <p:cNvSpPr txBox="1"/>
           <p:nvPr/>
         </p:nvSpPr>
@@ -17057,7 +17060,7 @@
       </p:sp>
       <p:pic>
         <p:nvPicPr>
-          <p:cNvPr id="507931814" name="Image 3" descr="preencoded.png"/>
+          <p:cNvPr id="268858643" name="Image 3" descr="preencoded.png"/>
           <p:cNvPicPr>
             <a:picLocks noChangeAspect="1"/>
           </p:cNvPicPr>
@@ -17079,7 +17082,7 @@
       </p:pic>
       <p:sp>
         <p:nvSpPr>
-          <p:cNvPr id="508486452" name="Text 9"/>
+          <p:cNvPr id="1835634612" name="Text 9"/>
           <p:cNvSpPr txBox="1"/>
           <p:nvPr/>
         </p:nvSpPr>
@@ -17124,7 +17127,7 @@
       </p:sp>
       <p:sp>
         <p:nvSpPr>
-          <p:cNvPr id="35714813" name="Text 10"/>
+          <p:cNvPr id="1947607598" name="Text 10"/>
           <p:cNvSpPr txBox="1"/>
           <p:nvPr/>
         </p:nvSpPr>
@@ -17166,7 +17169,7 @@
       </p:sp>
       <p:sp>
         <p:nvSpPr>
-          <p:cNvPr id="639957214" name="Text 11"/>
+          <p:cNvPr id="742192842" name="Text 11"/>
           <p:cNvSpPr txBox="1"/>
           <p:nvPr/>
         </p:nvSpPr>
@@ -17210,7 +17213,7 @@
       </p:sp>
       <p:sp>
         <p:nvSpPr>
-          <p:cNvPr id="671815212" name="Text 12"/>
+          <p:cNvPr id="1966939335" name="Text 12"/>
           <p:cNvSpPr txBox="1"/>
           <p:nvPr/>
         </p:nvSpPr>
@@ -17252,7 +17255,7 @@
       </p:sp>
       <p:sp>
         <p:nvSpPr>
-          <p:cNvPr id="707787162" name="Text 13"/>
+          <p:cNvPr id="1866619050" name="Text 13"/>
           <p:cNvSpPr txBox="1"/>
           <p:nvPr/>
         </p:nvSpPr>
@@ -17296,7 +17299,7 @@
       </p:sp>
       <p:sp>
         <p:nvSpPr>
-          <p:cNvPr id="654338214" name="Text 14"/>
+          <p:cNvPr id="851211810" name="Text 14"/>
           <p:cNvSpPr txBox="1"/>
           <p:nvPr/>
         </p:nvSpPr>
@@ -17338,7 +17341,7 @@
       </p:sp>
       <p:sp>
         <p:nvSpPr>
-          <p:cNvPr id="2032519025" name="Text 15"/>
+          <p:cNvPr id="1189482535" name="Text 15"/>
           <p:cNvSpPr txBox="1"/>
           <p:nvPr/>
         </p:nvSpPr>
@@ -17382,7 +17385,7 @@
       </p:sp>
       <p:pic>
         <p:nvPicPr>
-          <p:cNvPr id="1079941447" name="Image 4" descr="preencoded.png"/>
+          <p:cNvPr id="1223170632" name="Image 4" descr="preencoded.png"/>
           <p:cNvPicPr>
             <a:picLocks noChangeAspect="1"/>
           </p:cNvPicPr>
@@ -17404,7 +17407,7 @@
       </p:pic>
       <p:sp>
         <p:nvSpPr>
-          <p:cNvPr id="1660875931" name="Text 16"/>
+          <p:cNvPr id="673993549" name="Text 16"/>
           <p:cNvSpPr txBox="1"/>
           <p:nvPr/>
         </p:nvSpPr>
@@ -17564,7 +17567,7 @@
                                           </p:stCondLst>
                                         </p:cTn>
                                         <p:tgtEl>
-                                          <p:spTgt spid="1894761858"/>
+                                          <p:spTgt spid="312695101"/>
                                         </p:tgtEl>
                                         <p:attrNameLst>
                                           <p:attrName>style.visibility</p:attrName>
@@ -17591,7 +17594,7 @@
                                           </p:stCondLst>
                                         </p:cTn>
                                         <p:tgtEl>
-                                          <p:spTgt spid="1106923826"/>
+                                          <p:spTgt spid="1470488259"/>
                                         </p:tgtEl>
                                         <p:attrNameLst>
                                           <p:attrName>style.visibility</p:attrName>
@@ -17618,7 +17621,7 @@
                                           </p:stCondLst>
                                         </p:cTn>
                                         <p:tgtEl>
-                                          <p:spTgt spid="478113773"/>
+                                          <p:spTgt spid="971982053"/>
                                         </p:tgtEl>
                                         <p:attrNameLst>
                                           <p:attrName>style.visibility</p:attrName>
@@ -17645,7 +17648,7 @@
                                           </p:stCondLst>
                                         </p:cTn>
                                         <p:tgtEl>
-                                          <p:spTgt spid="1606213410"/>
+                                          <p:spTgt spid="574501505"/>
                                         </p:tgtEl>
                                         <p:attrNameLst>
                                           <p:attrName>style.visibility</p:attrName>
@@ -17672,7 +17675,7 @@
                                           </p:stCondLst>
                                         </p:cTn>
                                         <p:tgtEl>
-                                          <p:spTgt spid="124883763"/>
+                                          <p:spTgt spid="369544874"/>
                                         </p:tgtEl>
                                         <p:attrNameLst>
                                           <p:attrName>style.visibility</p:attrName>
@@ -17699,7 +17702,7 @@
                                           </p:stCondLst>
                                         </p:cTn>
                                         <p:tgtEl>
-                                          <p:spTgt spid="2070455389"/>
+                                          <p:spTgt spid="635701228"/>
                                         </p:tgtEl>
                                         <p:attrNameLst>
                                           <p:attrName>style.visibility</p:attrName>
@@ -17726,7 +17729,7 @@
                                           </p:stCondLst>
                                         </p:cTn>
                                         <p:tgtEl>
-                                          <p:spTgt spid="1402567752"/>
+                                          <p:spTgt spid="689246356"/>
                                         </p:tgtEl>
                                         <p:attrNameLst>
                                           <p:attrName>style.visibility</p:attrName>
@@ -17753,7 +17756,7 @@
                                           </p:stCondLst>
                                         </p:cTn>
                                         <p:tgtEl>
-                                          <p:spTgt spid="833050934"/>
+                                          <p:spTgt spid="1315037875"/>
                                         </p:tgtEl>
                                         <p:attrNameLst>
                                           <p:attrName>style.visibility</p:attrName>
@@ -17780,7 +17783,7 @@
                                           </p:stCondLst>
                                         </p:cTn>
                                         <p:tgtEl>
-                                          <p:spTgt spid="82946327"/>
+                                          <p:spTgt spid="2112656944"/>
                                         </p:tgtEl>
                                         <p:attrNameLst>
                                           <p:attrName>style.visibility</p:attrName>
@@ -17807,7 +17810,7 @@
                                           </p:stCondLst>
                                         </p:cTn>
                                         <p:tgtEl>
-                                          <p:spTgt spid="856170407"/>
+                                          <p:spTgt spid="2135220451"/>
                                         </p:tgtEl>
                                         <p:attrNameLst>
                                           <p:attrName>style.visibility</p:attrName>
@@ -17834,7 +17837,7 @@
                                           </p:stCondLst>
                                         </p:cTn>
                                         <p:tgtEl>
-                                          <p:spTgt spid="507931814"/>
+                                          <p:spTgt spid="268858643"/>
                                         </p:tgtEl>
                                         <p:attrNameLst>
                                           <p:attrName>style.visibility</p:attrName>
@@ -17861,7 +17864,7 @@
                                           </p:stCondLst>
                                         </p:cTn>
                                         <p:tgtEl>
-                                          <p:spTgt spid="508486452"/>
+                                          <p:spTgt spid="1835634612"/>
                                         </p:tgtEl>
                                         <p:attrNameLst>
                                           <p:attrName>style.visibility</p:attrName>
@@ -17888,7 +17891,7 @@
                                           </p:stCondLst>
                                         </p:cTn>
                                         <p:tgtEl>
-                                          <p:spTgt spid="35714813"/>
+                                          <p:spTgt spid="1947607598"/>
                                         </p:tgtEl>
                                         <p:attrNameLst>
                                           <p:attrName>style.visibility</p:attrName>
@@ -17915,7 +17918,7 @@
                                           </p:stCondLst>
                                         </p:cTn>
                                         <p:tgtEl>
-                                          <p:spTgt spid="639957214"/>
+                                          <p:spTgt spid="742192842"/>
                                         </p:tgtEl>
                                         <p:attrNameLst>
                                           <p:attrName>style.visibility</p:attrName>
@@ -17942,7 +17945,7 @@
                                           </p:stCondLst>
                                         </p:cTn>
                                         <p:tgtEl>
-                                          <p:spTgt spid="671815212"/>
+                                          <p:spTgt spid="1966939335"/>
                                         </p:tgtEl>
                                         <p:attrNameLst>
                                           <p:attrName>style.visibility</p:attrName>
@@ -17969,7 +17972,7 @@
                                           </p:stCondLst>
                                         </p:cTn>
                                         <p:tgtEl>
-                                          <p:spTgt spid="707787162"/>
+                                          <p:spTgt spid="1866619050"/>
                                         </p:tgtEl>
                                         <p:attrNameLst>
                                           <p:attrName>style.visibility</p:attrName>
@@ -17996,7 +17999,7 @@
                                           </p:stCondLst>
                                         </p:cTn>
                                         <p:tgtEl>
-                                          <p:spTgt spid="654338214"/>
+                                          <p:spTgt spid="851211810"/>
                                         </p:tgtEl>
                                         <p:attrNameLst>
                                           <p:attrName>style.visibility</p:attrName>
@@ -18023,7 +18026,7 @@
                                           </p:stCondLst>
                                         </p:cTn>
                                         <p:tgtEl>
-                                          <p:spTgt spid="2032519025"/>
+                                          <p:spTgt spid="1189482535"/>
                                         </p:tgtEl>
                                         <p:attrNameLst>
                                           <p:attrName>style.visibility</p:attrName>
@@ -18050,7 +18053,7 @@
                                           </p:stCondLst>
                                         </p:cTn>
                                         <p:tgtEl>
-                                          <p:spTgt spid="1079941447"/>
+                                          <p:spTgt spid="1223170632"/>
                                         </p:tgtEl>
                                         <p:attrNameLst>
                                           <p:attrName>style.visibility</p:attrName>
@@ -18077,7 +18080,7 @@
                                           </p:stCondLst>
                                         </p:cTn>
                                         <p:tgtEl>
-                                          <p:spTgt spid="1660875931"/>
+                                          <p:spTgt spid="673993549"/>
                                         </p:tgtEl>
                                         <p:attrNameLst>
                                           <p:attrName>style.visibility</p:attrName>

</xml_diff>

<commit_message>
last changes in .ppt
</commit_message>
<xml_diff>
--- a/presentation/Proj2-Observability-Deep-Dive.pptx
+++ b/presentation/Proj2-Observability-Deep-Dive.pptx
@@ -5,7 +5,7 @@
     <p:sldMasterId id="2147483648" r:id="rId1"/>
   </p:sldMasterIdLst>
   <p:notesMasterIdLst>
-    <p:notesMasterId r:id="rId16"/>
+    <p:notesMasterId r:id="rId15"/>
   </p:notesMasterIdLst>
   <p:sldIdLst>
     <p:sldId id="256" r:id="rId3"/>
@@ -20,7 +20,6 @@
     <p:sldId id="265" r:id="rId12"/>
     <p:sldId id="266" r:id="rId13"/>
     <p:sldId id="267" r:id="rId14"/>
-    <p:sldId id="268" r:id="rId15"/>
   </p:sldIdLst>
   <p:sldSz cx="12192000" cy="6858000"/>
   <p:notesSz cx="6858000" cy="12192000"/>
@@ -143,7 +142,7 @@
       </p:grpSpPr>
       <p:sp>
         <p:nvSpPr>
-          <p:cNvPr id="1065201538" name="Header Placeholder 1"/>
+          <p:cNvPr id="1108988923" name="Header Placeholder 1"/>
           <p:cNvSpPr>
             <a:spLocks noGrp="1"/>
           </p:cNvSpPr>
@@ -177,7 +176,7 @@
       </p:sp>
       <p:sp>
         <p:nvSpPr>
-          <p:cNvPr id="568215508" name="Date Placeholder 2"/>
+          <p:cNvPr id="115517461" name="Date Placeholder 2"/>
           <p:cNvSpPr>
             <a:spLocks noGrp="1"/>
           </p:cNvSpPr>
@@ -215,7 +214,7 @@
       </p:sp>
       <p:sp>
         <p:nvSpPr>
-          <p:cNvPr id="374535639" name="Slide Image Placeholder 3"/>
+          <p:cNvPr id="1691103468" name="Slide Image Placeholder 3"/>
           <p:cNvSpPr>
             <a:spLocks noChangeAspect="1" noGrp="1" noRot="1"/>
           </p:cNvSpPr>
@@ -251,7 +250,7 @@
       </p:sp>
       <p:sp>
         <p:nvSpPr>
-          <p:cNvPr id="1127903957" name="Notes Placeholder 4"/>
+          <p:cNvPr id="1700915369" name="Notes Placeholder 4"/>
           <p:cNvSpPr>
             <a:spLocks noGrp="1"/>
           </p:cNvSpPr>
@@ -325,7 +324,7 @@
       </p:sp>
       <p:sp>
         <p:nvSpPr>
-          <p:cNvPr id="1754574714" name="Footer Placeholder 5"/>
+          <p:cNvPr id="1345166283" name="Footer Placeholder 5"/>
           <p:cNvSpPr>
             <a:spLocks noGrp="1"/>
           </p:cNvSpPr>
@@ -359,7 +358,7 @@
       </p:sp>
       <p:sp>
         <p:nvSpPr>
-          <p:cNvPr id="1296659396" name="Slide Number Placeholder 6"/>
+          <p:cNvPr id="526716957" name="Slide Number Placeholder 6"/>
           <p:cNvSpPr>
             <a:spLocks noGrp="1"/>
           </p:cNvSpPr>
@@ -512,7 +511,7 @@
       </p:grpSpPr>
       <p:sp>
         <p:nvSpPr>
-          <p:cNvPr id="742712706" name="Slide Image Placeholder 1"/>
+          <p:cNvPr id="1684839110" name="Slide Image Placeholder 1"/>
           <p:cNvSpPr>
             <a:spLocks noChangeAspect="1" noGrp="1" noRot="1"/>
           </p:cNvSpPr>
@@ -524,7 +523,7 @@
       </p:sp>
       <p:sp>
         <p:nvSpPr>
-          <p:cNvPr id="130051816" name="Notes Placeholder 2"/>
+          <p:cNvPr id="33662417" name="Notes Placeholder 2"/>
           <p:cNvSpPr>
             <a:spLocks noGrp="1"/>
           </p:cNvSpPr>
@@ -546,7 +545,7 @@
       </p:sp>
       <p:sp>
         <p:nvSpPr>
-          <p:cNvPr id="1928438998" name="Slide Number Placeholder 3"/>
+          <p:cNvPr id="1898053119" name="Slide Number Placeholder 3"/>
           <p:cNvSpPr>
             <a:spLocks noGrp="1"/>
           </p:cNvSpPr>
@@ -597,7 +596,7 @@
       </p:grpSpPr>
       <p:sp>
         <p:nvSpPr>
-          <p:cNvPr id="556692178" name="Slide Image Placeholder 1"/>
+          <p:cNvPr id="1731353512" name="Slide Image Placeholder 1"/>
           <p:cNvSpPr>
             <a:spLocks noChangeAspect="1" noGrp="1" noRot="1"/>
           </p:cNvSpPr>
@@ -609,7 +608,7 @@
       </p:sp>
       <p:sp>
         <p:nvSpPr>
-          <p:cNvPr id="995417998" name="Notes Placeholder 2"/>
+          <p:cNvPr id="1107295405" name="Notes Placeholder 2"/>
           <p:cNvSpPr>
             <a:spLocks noGrp="1"/>
           </p:cNvSpPr>
@@ -631,7 +630,7 @@
       </p:sp>
       <p:sp>
         <p:nvSpPr>
-          <p:cNvPr id="182972796" name="Slide Number Placeholder 3"/>
+          <p:cNvPr id="332608851" name="Slide Number Placeholder 3"/>
           <p:cNvSpPr>
             <a:spLocks noGrp="1"/>
           </p:cNvSpPr>
@@ -682,7 +681,7 @@
       </p:grpSpPr>
       <p:sp>
         <p:nvSpPr>
-          <p:cNvPr id="2128804161" name="Slide Image Placeholder 1"/>
+          <p:cNvPr id="873837261" name="Slide Image Placeholder 1"/>
           <p:cNvSpPr>
             <a:spLocks noChangeAspect="1" noGrp="1" noRot="1"/>
           </p:cNvSpPr>
@@ -694,7 +693,7 @@
       </p:sp>
       <p:sp>
         <p:nvSpPr>
-          <p:cNvPr id="1787438369" name="Notes Placeholder 2"/>
+          <p:cNvPr id="1504424049" name="Notes Placeholder 2"/>
           <p:cNvSpPr>
             <a:spLocks noGrp="1"/>
           </p:cNvSpPr>
@@ -716,7 +715,7 @@
       </p:sp>
       <p:sp>
         <p:nvSpPr>
-          <p:cNvPr id="2033750410" name="Slide Number Placeholder 3"/>
+          <p:cNvPr id="1298480877" name="Slide Number Placeholder 3"/>
           <p:cNvSpPr>
             <a:spLocks noGrp="1"/>
           </p:cNvSpPr>
@@ -734,7 +733,7 @@
             </a:pPr>
             <a:fld id="{F7021451-1387-4CA6-816F-3879F97B5CBC}" type="slidenum">
               <a:rPr lang="en-US"/>
-              <a:t>15</a:t>
+              <a:t>16</a:t>
             </a:fld>
             <a:endParaRPr lang="en-US"/>
           </a:p>
@@ -767,7 +766,7 @@
       </p:grpSpPr>
       <p:sp>
         <p:nvSpPr>
-          <p:cNvPr id="842463104" name="Slide Image Placeholder 1"/>
+          <p:cNvPr id="1925302831" name="Slide Image Placeholder 1"/>
           <p:cNvSpPr>
             <a:spLocks noChangeAspect="1" noGrp="1" noRot="1"/>
           </p:cNvSpPr>
@@ -779,7 +778,7 @@
       </p:sp>
       <p:sp>
         <p:nvSpPr>
-          <p:cNvPr id="486765285" name="Notes Placeholder 2"/>
+          <p:cNvPr id="1333080032" name="Notes Placeholder 2"/>
           <p:cNvSpPr>
             <a:spLocks noGrp="1"/>
           </p:cNvSpPr>
@@ -801,92 +800,7 @@
       </p:sp>
       <p:sp>
         <p:nvSpPr>
-          <p:cNvPr id="1708859877" name="Slide Number Placeholder 3"/>
-          <p:cNvSpPr>
-            <a:spLocks noGrp="1"/>
-          </p:cNvSpPr>
-          <p:nvPr>
-            <p:ph type="sldNum" sz="quarter" idx="10"/>
-          </p:nvPr>
-        </p:nvSpPr>
-        <p:spPr bwMode="auto"/>
-        <p:txBody>
-          <a:bodyPr/>
-          <a:lstStyle/>
-          <a:p>
-            <a:pPr>
-              <a:defRPr/>
-            </a:pPr>
-            <a:fld id="{F7021451-1387-4CA6-816F-3879F97B5CBC}" type="slidenum">
-              <a:rPr lang="en-US"/>
-              <a:t>16</a:t>
-            </a:fld>
-            <a:endParaRPr lang="en-US"/>
-          </a:p>
-        </p:txBody>
-      </p:sp>
-    </p:spTree>
-  </p:cSld>
-  <p:clrMapOvr>
-    <a:masterClrMapping/>
-  </p:clrMapOvr>
-</p:notes>
-</file>
-
-<file path=ppt/notesSlides/notesSlide13.xml><?xml version="1.0" encoding="utf-8"?>
-<p:notes xmlns:a="http://schemas.openxmlformats.org/drawingml/2006/main" xmlns:r="http://schemas.openxmlformats.org/officeDocument/2006/relationships" xmlns:p="http://schemas.openxmlformats.org/presentationml/2006/main" xmlns:m="http://schemas.openxmlformats.org/officeDocument/2006/math" xmlns:w="http://schemas.openxmlformats.org/wordprocessingml/2006/main">
-  <p:cSld name="">
-    <p:spTree>
-      <p:nvGrpSpPr>
-        <p:cNvPr id="1" name=""/>
-        <p:cNvGrpSpPr/>
-        <p:nvPr/>
-      </p:nvGrpSpPr>
-      <p:grpSpPr bwMode="auto">
-        <a:xfrm>
-          <a:off x="0" y="0"/>
-          <a:ext cx="0" cy="0"/>
-          <a:chOff x="0" y="0"/>
-          <a:chExt cx="0" cy="0"/>
-        </a:xfrm>
-      </p:grpSpPr>
-      <p:sp>
-        <p:nvSpPr>
-          <p:cNvPr id="554393411" name="Slide Image Placeholder 1"/>
-          <p:cNvSpPr>
-            <a:spLocks noChangeAspect="1" noGrp="1" noRot="1"/>
-          </p:cNvSpPr>
-          <p:nvPr>
-            <p:ph type="sldImg"/>
-          </p:nvPr>
-        </p:nvSpPr>
-        <p:spPr bwMode="auto"/>
-      </p:sp>
-      <p:sp>
-        <p:nvSpPr>
-          <p:cNvPr id="489971003" name="Notes Placeholder 2"/>
-          <p:cNvSpPr>
-            <a:spLocks noGrp="1"/>
-          </p:cNvSpPr>
-          <p:nvPr>
-            <p:ph type="body" idx="1"/>
-          </p:nvPr>
-        </p:nvSpPr>
-        <p:spPr bwMode="auto"/>
-        <p:txBody>
-          <a:bodyPr/>
-          <a:lstStyle/>
-          <a:p>
-            <a:pPr>
-              <a:defRPr/>
-            </a:pPr>
-            <a:endParaRPr lang="en-US"/>
-          </a:p>
-        </p:txBody>
-      </p:sp>
-      <p:sp>
-        <p:nvSpPr>
-          <p:cNvPr id="1152813147" name="Slide Number Placeholder 3"/>
+          <p:cNvPr id="314733865" name="Slide Number Placeholder 3"/>
           <p:cNvSpPr>
             <a:spLocks noGrp="1"/>
           </p:cNvSpPr>
@@ -937,7 +851,7 @@
       </p:grpSpPr>
       <p:sp>
         <p:nvSpPr>
-          <p:cNvPr id="1156018777" name="Slide Image Placeholder 1"/>
+          <p:cNvPr id="1456468586" name="Slide Image Placeholder 1"/>
           <p:cNvSpPr>
             <a:spLocks noChangeAspect="1" noGrp="1" noRot="1"/>
           </p:cNvSpPr>
@@ -949,7 +863,7 @@
       </p:sp>
       <p:sp>
         <p:nvSpPr>
-          <p:cNvPr id="1960867237" name="Notes Placeholder 2"/>
+          <p:cNvPr id="1146678833" name="Notes Placeholder 2"/>
           <p:cNvSpPr>
             <a:spLocks noGrp="1"/>
           </p:cNvSpPr>
@@ -971,7 +885,7 @@
       </p:sp>
       <p:sp>
         <p:nvSpPr>
-          <p:cNvPr id="1201468277" name="Slide Number Placeholder 3"/>
+          <p:cNvPr id="1753169824" name="Slide Number Placeholder 3"/>
           <p:cNvSpPr>
             <a:spLocks noGrp="1"/>
           </p:cNvSpPr>
@@ -1022,7 +936,7 @@
       </p:grpSpPr>
       <p:sp>
         <p:nvSpPr>
-          <p:cNvPr id="103268517" name="Slide Image Placeholder 1"/>
+          <p:cNvPr id="2020420605" name="Slide Image Placeholder 1"/>
           <p:cNvSpPr>
             <a:spLocks noChangeAspect="1" noGrp="1" noRot="1"/>
           </p:cNvSpPr>
@@ -1034,7 +948,7 @@
       </p:sp>
       <p:sp>
         <p:nvSpPr>
-          <p:cNvPr id="1629116461" name="Notes Placeholder 2"/>
+          <p:cNvPr id="538319949" name="Notes Placeholder 2"/>
           <p:cNvSpPr>
             <a:spLocks noGrp="1"/>
           </p:cNvSpPr>
@@ -1060,7 +974,7 @@
       </p:sp>
       <p:sp>
         <p:nvSpPr>
-          <p:cNvPr id="159646275" name="Slide Number Placeholder 3"/>
+          <p:cNvPr id="893329581" name="Slide Number Placeholder 3"/>
           <p:cNvSpPr>
             <a:spLocks noGrp="1"/>
           </p:cNvSpPr>
@@ -1111,7 +1025,7 @@
       </p:grpSpPr>
       <p:sp>
         <p:nvSpPr>
-          <p:cNvPr id="1854619510" name="Slide Image Placeholder 1"/>
+          <p:cNvPr id="722303779" name="Slide Image Placeholder 1"/>
           <p:cNvSpPr>
             <a:spLocks noChangeAspect="1" noGrp="1" noRot="1"/>
           </p:cNvSpPr>
@@ -1123,7 +1037,7 @@
       </p:sp>
       <p:sp>
         <p:nvSpPr>
-          <p:cNvPr id="1740728359" name="Notes Placeholder 2"/>
+          <p:cNvPr id="190775043" name="Notes Placeholder 2"/>
           <p:cNvSpPr>
             <a:spLocks noGrp="1"/>
           </p:cNvSpPr>
@@ -1145,7 +1059,7 @@
       </p:sp>
       <p:sp>
         <p:nvSpPr>
-          <p:cNvPr id="473170661" name="Slide Number Placeholder 3"/>
+          <p:cNvPr id="1961704323" name="Slide Number Placeholder 3"/>
           <p:cNvSpPr>
             <a:spLocks noGrp="1"/>
           </p:cNvSpPr>
@@ -1196,7 +1110,7 @@
       </p:grpSpPr>
       <p:sp>
         <p:nvSpPr>
-          <p:cNvPr id="117706251" name="Slide Image Placeholder 1"/>
+          <p:cNvPr id="1743636952" name="Slide Image Placeholder 1"/>
           <p:cNvSpPr>
             <a:spLocks noChangeAspect="1" noGrp="1" noRot="1"/>
           </p:cNvSpPr>
@@ -1208,7 +1122,7 @@
       </p:sp>
       <p:sp>
         <p:nvSpPr>
-          <p:cNvPr id="1084642136" name="Notes Placeholder 2"/>
+          <p:cNvPr id="685025188" name="Notes Placeholder 2"/>
           <p:cNvSpPr>
             <a:spLocks noGrp="1"/>
           </p:cNvSpPr>
@@ -1230,7 +1144,7 @@
       </p:sp>
       <p:sp>
         <p:nvSpPr>
-          <p:cNvPr id="804899876" name="Slide Number Placeholder 3"/>
+          <p:cNvPr id="1155098665" name="Slide Number Placeholder 3"/>
           <p:cNvSpPr>
             <a:spLocks noGrp="1"/>
           </p:cNvSpPr>
@@ -1281,7 +1195,7 @@
       </p:grpSpPr>
       <p:sp>
         <p:nvSpPr>
-          <p:cNvPr id="1674434707" name="Slide Image Placeholder 1"/>
+          <p:cNvPr id="910679718" name="Slide Image Placeholder 1"/>
           <p:cNvSpPr>
             <a:spLocks noChangeAspect="1" noGrp="1" noRot="1"/>
           </p:cNvSpPr>
@@ -1293,7 +1207,7 @@
       </p:sp>
       <p:sp>
         <p:nvSpPr>
-          <p:cNvPr id="237739029" name="Notes Placeholder 2"/>
+          <p:cNvPr id="1474774850" name="Notes Placeholder 2"/>
           <p:cNvSpPr>
             <a:spLocks noGrp="1"/>
           </p:cNvSpPr>
@@ -1315,7 +1229,7 @@
       </p:sp>
       <p:sp>
         <p:nvSpPr>
-          <p:cNvPr id="982418031" name="Slide Number Placeholder 3"/>
+          <p:cNvPr id="97743644" name="Slide Number Placeholder 3"/>
           <p:cNvSpPr>
             <a:spLocks noGrp="1"/>
           </p:cNvSpPr>
@@ -1366,7 +1280,7 @@
       </p:grpSpPr>
       <p:sp>
         <p:nvSpPr>
-          <p:cNvPr id="313600353" name="Slide Image Placeholder 1"/>
+          <p:cNvPr id="1439147033" name="Slide Image Placeholder 1"/>
           <p:cNvSpPr>
             <a:spLocks noChangeAspect="1" noGrp="1" noRot="1"/>
           </p:cNvSpPr>
@@ -1378,7 +1292,7 @@
       </p:sp>
       <p:sp>
         <p:nvSpPr>
-          <p:cNvPr id="685217000" name="Notes Placeholder 2"/>
+          <p:cNvPr id="937116041" name="Notes Placeholder 2"/>
           <p:cNvSpPr>
             <a:spLocks noGrp="1"/>
           </p:cNvSpPr>
@@ -1400,7 +1314,7 @@
       </p:sp>
       <p:sp>
         <p:nvSpPr>
-          <p:cNvPr id="436868919" name="Slide Number Placeholder 3"/>
+          <p:cNvPr id="21177613" name="Slide Number Placeholder 3"/>
           <p:cNvSpPr>
             <a:spLocks noGrp="1"/>
           </p:cNvSpPr>
@@ -1451,7 +1365,7 @@
       </p:grpSpPr>
       <p:sp>
         <p:nvSpPr>
-          <p:cNvPr id="902034954" name="Slide Image Placeholder 1"/>
+          <p:cNvPr id="470319901" name="Slide Image Placeholder 1"/>
           <p:cNvSpPr>
             <a:spLocks noChangeAspect="1" noGrp="1" noRot="1"/>
           </p:cNvSpPr>
@@ -1463,7 +1377,7 @@
       </p:sp>
       <p:sp>
         <p:nvSpPr>
-          <p:cNvPr id="153593657" name="Notes Placeholder 2"/>
+          <p:cNvPr id="1557136451" name="Notes Placeholder 2"/>
           <p:cNvSpPr>
             <a:spLocks noGrp="1"/>
           </p:cNvSpPr>
@@ -1485,7 +1399,7 @@
       </p:sp>
       <p:sp>
         <p:nvSpPr>
-          <p:cNvPr id="1161571662" name="Slide Number Placeholder 3"/>
+          <p:cNvPr id="901158677" name="Slide Number Placeholder 3"/>
           <p:cNvSpPr>
             <a:spLocks noGrp="1"/>
           </p:cNvSpPr>
@@ -1536,7 +1450,7 @@
       </p:grpSpPr>
       <p:sp>
         <p:nvSpPr>
-          <p:cNvPr id="527043288" name="Slide Image Placeholder 1"/>
+          <p:cNvPr id="591081580" name="Slide Image Placeholder 1"/>
           <p:cNvSpPr>
             <a:spLocks noChangeAspect="1" noGrp="1" noRot="1"/>
           </p:cNvSpPr>
@@ -1548,7 +1462,7 @@
       </p:sp>
       <p:sp>
         <p:nvSpPr>
-          <p:cNvPr id="994032670" name="Notes Placeholder 2"/>
+          <p:cNvPr id="1216156627" name="Notes Placeholder 2"/>
           <p:cNvSpPr>
             <a:spLocks noGrp="1"/>
           </p:cNvSpPr>
@@ -1570,7 +1484,7 @@
       </p:sp>
       <p:sp>
         <p:nvSpPr>
-          <p:cNvPr id="1474114137" name="Slide Number Placeholder 3"/>
+          <p:cNvPr id="744616072" name="Slide Number Placeholder 3"/>
           <p:cNvSpPr>
             <a:spLocks noGrp="1"/>
           </p:cNvSpPr>
@@ -1935,7 +1849,7 @@
       </p:grpSpPr>
       <p:pic>
         <p:nvPicPr>
-          <p:cNvPr id="1240609177" name="Image 0" descr="preencoded.png"/>
+          <p:cNvPr id="1511733443" name="Image 0" descr="preencoded.png"/>
           <p:cNvPicPr>
             <a:picLocks noChangeAspect="1"/>
           </p:cNvPicPr>
@@ -1957,7 +1871,7 @@
       </p:pic>
       <p:sp>
         <p:nvSpPr>
-          <p:cNvPr id="1134853824" name="Text 0"/>
+          <p:cNvPr id="1229979019" name="Text 0"/>
           <p:cNvSpPr txBox="1"/>
           <p:nvPr/>
         </p:nvSpPr>
@@ -1988,7 +1902,7 @@
       </p:sp>
       <p:sp>
         <p:nvSpPr>
-          <p:cNvPr id="1528874424" name="Shape 1"/>
+          <p:cNvPr id="1679785311" name="Shape 1"/>
           <p:cNvSpPr/>
           <p:nvPr/>
         </p:nvSpPr>
@@ -2008,7 +1922,7 @@
       </p:sp>
       <p:sp>
         <p:nvSpPr>
-          <p:cNvPr id="1971675587" name="Text 2"/>
+          <p:cNvPr id="1869990513" name="Text 2"/>
           <p:cNvSpPr txBox="1"/>
           <p:nvPr/>
         </p:nvSpPr>
@@ -2078,7 +1992,7 @@
       </p:sp>
       <p:sp>
         <p:nvSpPr>
-          <p:cNvPr id="922077354" name="Text 3"/>
+          <p:cNvPr id="1509516403" name="Text 3"/>
           <p:cNvSpPr txBox="1"/>
           <p:nvPr/>
         </p:nvSpPr>
@@ -2141,7 +2055,7 @@
       </p:sp>
       <p:pic>
         <p:nvPicPr>
-          <p:cNvPr id="904051130" name="Image 1" descr="preencoded.png"/>
+          <p:cNvPr id="483418563" name="Image 1" descr="preencoded.png"/>
           <p:cNvPicPr>
             <a:picLocks noChangeAspect="1"/>
           </p:cNvPicPr>
@@ -2163,7 +2077,7 @@
       </p:pic>
       <p:sp>
         <p:nvSpPr>
-          <p:cNvPr id="220938188" name="Text 4"/>
+          <p:cNvPr id="1499042263" name="Text 4"/>
           <p:cNvSpPr txBox="1"/>
           <p:nvPr/>
         </p:nvSpPr>
@@ -2224,7 +2138,7 @@
       </p:sp>
       <p:pic>
         <p:nvPicPr>
-          <p:cNvPr id="1240002917" name="Image 2" descr="preencoded.png"/>
+          <p:cNvPr id="1117175794" name="Image 2" descr="preencoded.png"/>
           <p:cNvPicPr>
             <a:picLocks noChangeAspect="1"/>
           </p:cNvPicPr>
@@ -2246,7 +2160,7 @@
       </p:pic>
       <p:sp>
         <p:nvSpPr>
-          <p:cNvPr id="1264234310" name="Text 5"/>
+          <p:cNvPr id="592348876" name="Text 5"/>
           <p:cNvSpPr txBox="1"/>
           <p:nvPr/>
         </p:nvSpPr>
@@ -2328,7 +2242,7 @@
       </p:grpSpPr>
       <p:sp>
         <p:nvSpPr>
-          <p:cNvPr id="557609916" name="Text 0"/>
+          <p:cNvPr id="2108828998" name="Text 0"/>
           <p:cNvSpPr txBox="1"/>
           <p:nvPr/>
         </p:nvSpPr>
@@ -2378,7 +2292,7 @@
       </p:sp>
       <p:pic>
         <p:nvPicPr>
-          <p:cNvPr id="1390598263" name="Image 0" descr="preencoded.png"/>
+          <p:cNvPr id="722202052" name="Image 0" descr="preencoded.png"/>
           <p:cNvPicPr>
             <a:picLocks noChangeAspect="1"/>
           </p:cNvPicPr>
@@ -2400,7 +2314,7 @@
       </p:pic>
       <p:sp>
         <p:nvSpPr>
-          <p:cNvPr id="648570426" name="Text 1"/>
+          <p:cNvPr id="2060151831" name="Text 1"/>
           <p:cNvSpPr txBox="1"/>
           <p:nvPr/>
         </p:nvSpPr>
@@ -2445,7 +2359,7 @@
       </p:sp>
       <p:sp>
         <p:nvSpPr>
-          <p:cNvPr id="456140690" name="Text 2"/>
+          <p:cNvPr id="259361021" name="Text 2"/>
           <p:cNvSpPr txBox="1"/>
           <p:nvPr/>
         </p:nvSpPr>
@@ -2497,7 +2411,7 @@
       </p:sp>
       <p:pic>
         <p:nvPicPr>
-          <p:cNvPr id="1853586511" name="Image 1" descr="preencoded.png"/>
+          <p:cNvPr id="322729170" name="Image 1" descr="preencoded.png"/>
           <p:cNvPicPr>
             <a:picLocks noChangeAspect="1"/>
           </p:cNvPicPr>
@@ -2519,7 +2433,7 @@
       </p:pic>
       <p:sp>
         <p:nvSpPr>
-          <p:cNvPr id="1966536712" name="Text 3"/>
+          <p:cNvPr id="909735828" name="Text 3"/>
           <p:cNvSpPr txBox="1"/>
           <p:nvPr/>
         </p:nvSpPr>
@@ -2564,7 +2478,7 @@
       </p:sp>
       <p:sp>
         <p:nvSpPr>
-          <p:cNvPr id="1081191372" name="Text 4"/>
+          <p:cNvPr id="1322651830" name="Text 4"/>
           <p:cNvSpPr txBox="1"/>
           <p:nvPr/>
         </p:nvSpPr>
@@ -2608,7 +2522,7 @@
       </p:sp>
       <p:pic>
         <p:nvPicPr>
-          <p:cNvPr id="559204969" name="Image 3" descr="preencoded.png"/>
+          <p:cNvPr id="1537635820" name="Image 3" descr="preencoded.png"/>
           <p:cNvPicPr>
             <a:picLocks noChangeAspect="1"/>
           </p:cNvPicPr>
@@ -2630,7 +2544,7 @@
       </p:pic>
       <p:sp>
         <p:nvSpPr>
-          <p:cNvPr id="1129246059" name="Text 7"/>
+          <p:cNvPr id="326291245" name="Text 7"/>
           <p:cNvSpPr txBox="1"/>
           <p:nvPr/>
         </p:nvSpPr>
@@ -2661,7 +2575,7 @@
       </p:sp>
       <p:sp>
         <p:nvSpPr>
-          <p:cNvPr id="1696275484" name="Text 8"/>
+          <p:cNvPr id="1188700022" name="Text 8"/>
           <p:cNvSpPr txBox="1"/>
           <p:nvPr/>
         </p:nvSpPr>
@@ -2706,7 +2620,7 @@
       </p:sp>
       <p:sp>
         <p:nvSpPr>
-          <p:cNvPr id="1526972033" name="Text 9"/>
+          <p:cNvPr id="1847175230" name="Text 9"/>
           <p:cNvSpPr txBox="1"/>
           <p:nvPr/>
         </p:nvSpPr>
@@ -2751,7 +2665,7 @@
       </p:sp>
       <p:sp>
         <p:nvSpPr>
-          <p:cNvPr id="1556235889" name="Text 10"/>
+          <p:cNvPr id="879386423" name="Text 10"/>
           <p:cNvSpPr txBox="1"/>
           <p:nvPr/>
         </p:nvSpPr>
@@ -2795,7 +2709,7 @@
       </p:sp>
       <p:pic>
         <p:nvPicPr>
-          <p:cNvPr id="790683732" name="Image 4" descr="preencoded.png"/>
+          <p:cNvPr id="872096436" name="Image 4" descr="preencoded.png"/>
           <p:cNvPicPr>
             <a:picLocks noChangeAspect="1"/>
           </p:cNvPicPr>
@@ -2817,7 +2731,7 @@
       </p:pic>
       <p:sp>
         <p:nvSpPr>
-          <p:cNvPr id="1702203045" name="Text 11"/>
+          <p:cNvPr id="1266754298" name="Text 11"/>
           <p:cNvSpPr txBox="1"/>
           <p:nvPr/>
         </p:nvSpPr>
@@ -2861,7 +2775,7 @@
       </p:sp>
       <p:pic>
         <p:nvPicPr>
-          <p:cNvPr id="1771771698" name="Image 5" descr="preencoded.png"/>
+          <p:cNvPr id="1838732876" name="Image 5" descr="preencoded.png"/>
           <p:cNvPicPr>
             <a:picLocks noChangeAspect="1"/>
           </p:cNvPicPr>
@@ -2883,7 +2797,7 @@
       </p:pic>
       <p:sp>
         <p:nvSpPr>
-          <p:cNvPr id="1634651189" name="Text 12"/>
+          <p:cNvPr id="1138271911" name="Text 12"/>
           <p:cNvSpPr txBox="1"/>
           <p:nvPr/>
         </p:nvSpPr>
@@ -2927,7 +2841,7 @@
       </p:sp>
       <p:pic>
         <p:nvPicPr>
-          <p:cNvPr id="1995109989" name="Image 6" descr="preencoded.png"/>
+          <p:cNvPr id="812012061" name="Image 6" descr="preencoded.png"/>
           <p:cNvPicPr>
             <a:picLocks noChangeAspect="1"/>
           </p:cNvPicPr>
@@ -2949,7 +2863,7 @@
       </p:pic>
       <p:sp>
         <p:nvSpPr>
-          <p:cNvPr id="788729658" name="Text 13"/>
+          <p:cNvPr id="1129670054" name="Text 13"/>
           <p:cNvSpPr txBox="1"/>
           <p:nvPr/>
         </p:nvSpPr>
@@ -2993,7 +2907,7 @@
       </p:sp>
       <p:pic>
         <p:nvPicPr>
-          <p:cNvPr id="1530304340" name="Image 7" descr="preencoded.png"/>
+          <p:cNvPr id="1311931975" name="Image 7" descr="preencoded.png"/>
           <p:cNvPicPr>
             <a:picLocks noChangeAspect="1"/>
           </p:cNvPicPr>
@@ -3015,7 +2929,7 @@
       </p:pic>
       <p:sp>
         <p:nvSpPr>
-          <p:cNvPr id="1383311611" name="Text 14"/>
+          <p:cNvPr id="1598413620" name="Text 14"/>
           <p:cNvSpPr txBox="1"/>
           <p:nvPr/>
         </p:nvSpPr>
@@ -3059,7 +2973,7 @@
       </p:sp>
       <p:pic>
         <p:nvPicPr>
-          <p:cNvPr id="925506961" name="Image 8" descr="preencoded.png"/>
+          <p:cNvPr id="1795960800" name="Image 8" descr="preencoded.png"/>
           <p:cNvPicPr>
             <a:picLocks noChangeAspect="1"/>
           </p:cNvPicPr>
@@ -3081,7 +2995,7 @@
       </p:pic>
       <p:sp>
         <p:nvSpPr>
-          <p:cNvPr id="2143844412" name="Text 15"/>
+          <p:cNvPr id="1326138546" name="Text 15"/>
           <p:cNvSpPr txBox="1"/>
           <p:nvPr/>
         </p:nvSpPr>
@@ -3112,7 +3026,7 @@
       </p:sp>
       <p:sp>
         <p:nvSpPr>
-          <p:cNvPr id="795766197" name="Text 16"/>
+          <p:cNvPr id="2086481451" name="Text 16"/>
           <p:cNvSpPr txBox="1"/>
           <p:nvPr/>
         </p:nvSpPr>
@@ -3157,7 +3071,7 @@
       </p:sp>
       <p:sp>
         <p:nvSpPr>
-          <p:cNvPr id="719952926" name="Text 17"/>
+          <p:cNvPr id="1579303790" name="Text 17"/>
           <p:cNvSpPr txBox="1"/>
           <p:nvPr/>
         </p:nvSpPr>
@@ -3202,7 +3116,7 @@
       </p:sp>
       <p:sp>
         <p:nvSpPr>
-          <p:cNvPr id="1723277994" name="Text 18"/>
+          <p:cNvPr id="1911717343" name="Text 18"/>
           <p:cNvSpPr txBox="1"/>
           <p:nvPr/>
         </p:nvSpPr>
@@ -3246,7 +3160,7 @@
       </p:sp>
       <p:pic>
         <p:nvPicPr>
-          <p:cNvPr id="1660952114" name="Image 9" descr="preencoded.png"/>
+          <p:cNvPr id="539185479" name="Image 9" descr="preencoded.png"/>
           <p:cNvPicPr>
             <a:picLocks noChangeAspect="1"/>
           </p:cNvPicPr>
@@ -3268,7 +3182,7 @@
       </p:pic>
       <p:sp>
         <p:nvSpPr>
-          <p:cNvPr id="1818341125" name="Text 19"/>
+          <p:cNvPr id="630275023" name="Text 19"/>
           <p:cNvSpPr txBox="1"/>
           <p:nvPr/>
         </p:nvSpPr>
@@ -3312,7 +3226,7 @@
       </p:sp>
       <p:pic>
         <p:nvPicPr>
-          <p:cNvPr id="1480440501" name="Image 10" descr="preencoded.png"/>
+          <p:cNvPr id="1028804030" name="Image 10" descr="preencoded.png"/>
           <p:cNvPicPr>
             <a:picLocks noChangeAspect="1"/>
           </p:cNvPicPr>
@@ -3334,7 +3248,7 @@
       </p:pic>
       <p:sp>
         <p:nvSpPr>
-          <p:cNvPr id="540680581" name="Text 20"/>
+          <p:cNvPr id="1791265099" name="Text 20"/>
           <p:cNvSpPr txBox="1"/>
           <p:nvPr/>
         </p:nvSpPr>
@@ -3378,7 +3292,7 @@
       </p:sp>
       <p:pic>
         <p:nvPicPr>
-          <p:cNvPr id="137730957" name="Image 11" descr="preencoded.png"/>
+          <p:cNvPr id="70803997" name="Image 11" descr="preencoded.png"/>
           <p:cNvPicPr>
             <a:picLocks noChangeAspect="1"/>
           </p:cNvPicPr>
@@ -3400,7 +3314,7 @@
       </p:pic>
       <p:sp>
         <p:nvSpPr>
-          <p:cNvPr id="637566281" name="Text 21"/>
+          <p:cNvPr id="935560368" name="Text 21"/>
           <p:cNvSpPr txBox="1"/>
           <p:nvPr/>
         </p:nvSpPr>
@@ -3444,7 +3358,7 @@
       </p:sp>
       <p:pic>
         <p:nvPicPr>
-          <p:cNvPr id="704671311" name="Image 12" descr="preencoded.png"/>
+          <p:cNvPr id="1476764634" name="Image 12" descr="preencoded.png"/>
           <p:cNvPicPr>
             <a:picLocks noChangeAspect="1"/>
           </p:cNvPicPr>
@@ -3466,7 +3380,7 @@
       </p:pic>
       <p:sp>
         <p:nvSpPr>
-          <p:cNvPr id="1236320841" name="Text 22"/>
+          <p:cNvPr id="1382322585" name="Text 22"/>
           <p:cNvSpPr txBox="1"/>
           <p:nvPr/>
         </p:nvSpPr>
@@ -3510,7 +3424,7 @@
       </p:sp>
       <p:pic>
         <p:nvPicPr>
-          <p:cNvPr id="55828787" name="Image 13" descr="preencoded.png"/>
+          <p:cNvPr id="267915015" name="Image 13" descr="preencoded.png"/>
           <p:cNvPicPr>
             <a:picLocks noChangeAspect="1"/>
           </p:cNvPicPr>
@@ -3532,7 +3446,7 @@
       </p:pic>
       <p:sp>
         <p:nvSpPr>
-          <p:cNvPr id="175594133" name="Text 23"/>
+          <p:cNvPr id="1769489423" name="Text 23"/>
           <p:cNvSpPr txBox="1"/>
           <p:nvPr/>
         </p:nvSpPr>
@@ -3563,7 +3477,7 @@
       </p:sp>
       <p:sp>
         <p:nvSpPr>
-          <p:cNvPr id="867690964" name="Text 24"/>
+          <p:cNvPr id="1442168271" name="Text 24"/>
           <p:cNvSpPr txBox="1"/>
           <p:nvPr/>
         </p:nvSpPr>
@@ -3608,7 +3522,7 @@
       </p:sp>
       <p:sp>
         <p:nvSpPr>
-          <p:cNvPr id="1636123672" name="Text 25"/>
+          <p:cNvPr id="289596808" name="Text 25"/>
           <p:cNvSpPr txBox="1"/>
           <p:nvPr/>
         </p:nvSpPr>
@@ -3653,7 +3567,7 @@
       </p:sp>
       <p:sp>
         <p:nvSpPr>
-          <p:cNvPr id="1019456574" name="Text 26"/>
+          <p:cNvPr id="279951841" name="Text 26"/>
           <p:cNvSpPr txBox="1"/>
           <p:nvPr/>
         </p:nvSpPr>
@@ -3697,7 +3611,7 @@
       </p:sp>
       <p:pic>
         <p:nvPicPr>
-          <p:cNvPr id="252573919" name="Image 14" descr="preencoded.png"/>
+          <p:cNvPr id="1814717937" name="Image 14" descr="preencoded.png"/>
           <p:cNvPicPr>
             <a:picLocks noChangeAspect="1"/>
           </p:cNvPicPr>
@@ -3719,7 +3633,7 @@
       </p:pic>
       <p:sp>
         <p:nvSpPr>
-          <p:cNvPr id="107503232" name="Text 27"/>
+          <p:cNvPr id="2030693279" name="Text 27"/>
           <p:cNvSpPr txBox="1"/>
           <p:nvPr/>
         </p:nvSpPr>
@@ -3763,7 +3677,7 @@
       </p:sp>
       <p:pic>
         <p:nvPicPr>
-          <p:cNvPr id="1301512041" name="Image 15" descr="preencoded.png"/>
+          <p:cNvPr id="881220573" name="Image 15" descr="preencoded.png"/>
           <p:cNvPicPr>
             <a:picLocks noChangeAspect="1"/>
           </p:cNvPicPr>
@@ -3785,7 +3699,7 @@
       </p:pic>
       <p:sp>
         <p:nvSpPr>
-          <p:cNvPr id="917201493" name="Text 28"/>
+          <p:cNvPr id="721272272" name="Text 28"/>
           <p:cNvSpPr txBox="1"/>
           <p:nvPr/>
         </p:nvSpPr>
@@ -3829,7 +3743,7 @@
       </p:sp>
       <p:pic>
         <p:nvPicPr>
-          <p:cNvPr id="1713930604" name="Image 16" descr="preencoded.png"/>
+          <p:cNvPr id="1115189786" name="Image 16" descr="preencoded.png"/>
           <p:cNvPicPr>
             <a:picLocks noChangeAspect="1"/>
           </p:cNvPicPr>
@@ -3851,7 +3765,7 @@
       </p:pic>
       <p:sp>
         <p:nvSpPr>
-          <p:cNvPr id="1453463441" name="Text 29"/>
+          <p:cNvPr id="1001271859" name="Text 29"/>
           <p:cNvSpPr txBox="1"/>
           <p:nvPr/>
         </p:nvSpPr>
@@ -3895,7 +3809,7 @@
       </p:sp>
       <p:pic>
         <p:nvPicPr>
-          <p:cNvPr id="57112402" name="Image 17" descr="preencoded.png"/>
+          <p:cNvPr id="1737750457" name="Image 17" descr="preencoded.png"/>
           <p:cNvPicPr>
             <a:picLocks noChangeAspect="1"/>
           </p:cNvPicPr>
@@ -3917,7 +3831,7 @@
       </p:pic>
       <p:sp>
         <p:nvSpPr>
-          <p:cNvPr id="1366294901" name="Text 30"/>
+          <p:cNvPr id="1933840840" name="Text 30"/>
           <p:cNvSpPr txBox="1"/>
           <p:nvPr/>
         </p:nvSpPr>
@@ -3961,7 +3875,7 @@
       </p:sp>
       <p:pic>
         <p:nvPicPr>
-          <p:cNvPr id="1246296385" name="Image 18" descr="preencoded.png"/>
+          <p:cNvPr id="809598808" name="Image 18" descr="preencoded.png"/>
           <p:cNvPicPr>
             <a:picLocks noChangeAspect="1"/>
           </p:cNvPicPr>
@@ -3983,7 +3897,7 @@
       </p:pic>
       <p:sp>
         <p:nvSpPr>
-          <p:cNvPr id="1469898975" name="Text 31"/>
+          <p:cNvPr id="1545796896" name="Text 31"/>
           <p:cNvSpPr txBox="1"/>
           <p:nvPr/>
         </p:nvSpPr>
@@ -4014,7 +3928,7 @@
       </p:sp>
       <p:sp>
         <p:nvSpPr>
-          <p:cNvPr id="1031767205" name="Text 32"/>
+          <p:cNvPr id="266717566" name="Text 32"/>
           <p:cNvSpPr txBox="1"/>
           <p:nvPr/>
         </p:nvSpPr>
@@ -4059,7 +3973,7 @@
       </p:sp>
       <p:sp>
         <p:nvSpPr>
-          <p:cNvPr id="1693099272" name="Text 33"/>
+          <p:cNvPr id="32347352" name="Text 33"/>
           <p:cNvSpPr txBox="1"/>
           <p:nvPr/>
         </p:nvSpPr>
@@ -4104,7 +4018,7 @@
       </p:sp>
       <p:sp>
         <p:nvSpPr>
-          <p:cNvPr id="259205536" name="Text 34"/>
+          <p:cNvPr id="710236542" name="Text 34"/>
           <p:cNvSpPr txBox="1"/>
           <p:nvPr/>
         </p:nvSpPr>
@@ -4148,7 +4062,7 @@
       </p:sp>
       <p:pic>
         <p:nvPicPr>
-          <p:cNvPr id="35687348" name="Image 19" descr="preencoded.png"/>
+          <p:cNvPr id="1055575703" name="Image 19" descr="preencoded.png"/>
           <p:cNvPicPr>
             <a:picLocks noChangeAspect="1"/>
           </p:cNvPicPr>
@@ -4170,7 +4084,7 @@
       </p:pic>
       <p:sp>
         <p:nvSpPr>
-          <p:cNvPr id="1896967291" name="Text 35"/>
+          <p:cNvPr id="1419275361" name="Text 35"/>
           <p:cNvSpPr txBox="1"/>
           <p:nvPr/>
         </p:nvSpPr>
@@ -4214,7 +4128,7 @@
       </p:sp>
       <p:pic>
         <p:nvPicPr>
-          <p:cNvPr id="626358222" name="Image 20" descr="preencoded.png"/>
+          <p:cNvPr id="1982808340" name="Image 20" descr="preencoded.png"/>
           <p:cNvPicPr>
             <a:picLocks noChangeAspect="1"/>
           </p:cNvPicPr>
@@ -4236,7 +4150,7 @@
       </p:pic>
       <p:sp>
         <p:nvSpPr>
-          <p:cNvPr id="386428427" name="Text 36"/>
+          <p:cNvPr id="639219271" name="Text 36"/>
           <p:cNvSpPr txBox="1"/>
           <p:nvPr/>
         </p:nvSpPr>
@@ -4280,7 +4194,7 @@
       </p:sp>
       <p:pic>
         <p:nvPicPr>
-          <p:cNvPr id="1172735460" name="Image 21" descr="preencoded.png"/>
+          <p:cNvPr id="1458293291" name="Image 21" descr="preencoded.png"/>
           <p:cNvPicPr>
             <a:picLocks noChangeAspect="1"/>
           </p:cNvPicPr>
@@ -4302,7 +4216,7 @@
       </p:pic>
       <p:sp>
         <p:nvSpPr>
-          <p:cNvPr id="1325843956" name="Text 37"/>
+          <p:cNvPr id="1040358410" name="Text 37"/>
           <p:cNvSpPr txBox="1"/>
           <p:nvPr/>
         </p:nvSpPr>
@@ -4346,7 +4260,7 @@
       </p:sp>
       <p:pic>
         <p:nvPicPr>
-          <p:cNvPr id="1034277073" name="Image 22" descr="preencoded.png"/>
+          <p:cNvPr id="331435353" name="Image 22" descr="preencoded.png"/>
           <p:cNvPicPr>
             <a:picLocks noChangeAspect="1"/>
           </p:cNvPicPr>
@@ -4368,7 +4282,7 @@
       </p:pic>
       <p:sp>
         <p:nvSpPr>
-          <p:cNvPr id="1448388133" name="Text 38"/>
+          <p:cNvPr id="1061290240" name="Text 38"/>
           <p:cNvSpPr txBox="1"/>
           <p:nvPr/>
         </p:nvSpPr>
@@ -4427,859 +4341,6 @@
 </file>
 
 <file path=ppt/slides/slide11.xml><?xml version="1.0" encoding="utf-8"?>
-<p:sld xmlns:a="http://schemas.openxmlformats.org/drawingml/2006/main" xmlns:r="http://schemas.openxmlformats.org/officeDocument/2006/relationships" xmlns:p="http://schemas.openxmlformats.org/presentationml/2006/main" xmlns:m="http://schemas.openxmlformats.org/officeDocument/2006/math" xmlns:w="http://schemas.openxmlformats.org/wordprocessingml/2006/main" xmlns:mc="http://schemas.openxmlformats.org/markup-compatibility/2006" showMasterPhAnim="0" showMasterSp="1" show="1">
-  <p:cSld name="Slide 15">
-    <p:bg>
-      <p:bgPr shadeToTitle="0">
-        <a:solidFill>
-          <a:srgbClr val="181622"/>
-        </a:solidFill>
-      </p:bgPr>
-    </p:bg>
-    <p:spTree>
-      <p:nvGrpSpPr>
-        <p:cNvPr id="1" name=""/>
-        <p:cNvGrpSpPr/>
-        <p:nvPr/>
-      </p:nvGrpSpPr>
-      <p:grpSpPr bwMode="auto">
-        <a:xfrm>
-          <a:off x="0" y="0"/>
-          <a:ext cx="0" cy="0"/>
-          <a:chOff x="0" y="0"/>
-          <a:chExt cx="0" cy="0"/>
-        </a:xfrm>
-      </p:grpSpPr>
-      <p:sp>
-        <p:nvSpPr>
-          <p:cNvPr id="351446875" name="Text 0"/>
-          <p:cNvSpPr txBox="1"/>
-          <p:nvPr/>
-        </p:nvSpPr>
-        <p:spPr bwMode="auto">
-          <a:xfrm>
-            <a:off x="533400" y="495300"/>
-            <a:ext cx="6275784" cy="425648"/>
-          </a:xfrm>
-          <a:prstGeom prst="rect">
-            <a:avLst/>
-          </a:prstGeom>
-          <a:ln/>
-        </p:spPr>
-        <p:txBody>
-          <a:bodyPr wrap="none" lIns="0" tIns="0" rIns="0" bIns="0" rtlCol="0" anchor="t"/>
-          <a:lstStyle/>
-          <a:p>
-            <a:pPr marL="0" indent="0">
-              <a:buNone/>
-              <a:defRPr/>
-            </a:pPr>
-            <a:r>
-              <a:rPr lang="en-US" sz="3450" b="1" spc="-69">
-                <a:solidFill>
-                  <a:srgbClr val="EAEEF2"/>
-                </a:solidFill>
-                <a:latin typeface="Space Grotesk"/>
-                <a:ea typeface="Space Grotesk"/>
-                <a:cs typeface="Space Grotesk"/>
-              </a:rPr>
-              <a:t>Learnings — </a:t>
-            </a:r>
-            <a:r>
-              <a:rPr lang="en-US" sz="3450" b="1" spc="-69">
-                <a:solidFill>
-                  <a:srgbClr val="67F4E2"/>
-                </a:solidFill>
-                <a:latin typeface="Inter"/>
-                <a:ea typeface="Inter"/>
-                <a:cs typeface="Inter"/>
-              </a:rPr>
-              <a:t>What I Learned</a:t>
-            </a:r>
-            <a:endParaRPr lang="en-US" sz="3450"/>
-          </a:p>
-        </p:txBody>
-      </p:sp>
-      <p:pic>
-        <p:nvPicPr>
-          <p:cNvPr id="767385955" name="Image 0" descr="preencoded.png"/>
-          <p:cNvPicPr>
-            <a:picLocks noChangeAspect="1"/>
-          </p:cNvPicPr>
-          <p:nvPr/>
-        </p:nvPicPr>
-        <p:blipFill rotWithShape="1">
-          <a:blip r:embed="rId3"/>
-          <a:stretch/>
-        </p:blipFill>
-        <p:spPr bwMode="auto">
-          <a:xfrm>
-            <a:off x="533400" y="1483668"/>
-            <a:ext cx="6275784" cy="785515"/>
-          </a:xfrm>
-          <a:prstGeom prst="rect">
-            <a:avLst/>
-          </a:prstGeom>
-        </p:spPr>
-      </p:pic>
-      <p:pic>
-        <p:nvPicPr>
-          <p:cNvPr id="1641921998" name="Image 1" descr="preencoded.png"/>
-          <p:cNvPicPr>
-            <a:picLocks noChangeAspect="1"/>
-          </p:cNvPicPr>
-          <p:nvPr/>
-        </p:nvPicPr>
-        <p:blipFill rotWithShape="1">
-          <a:blip r:embed="rId4"/>
-          <a:stretch/>
-        </p:blipFill>
-        <p:spPr bwMode="auto">
-          <a:xfrm>
-            <a:off x="676275" y="1607493"/>
-            <a:ext cx="266700" cy="266700"/>
-          </a:xfrm>
-          <a:prstGeom prst="rect">
-            <a:avLst/>
-          </a:prstGeom>
-        </p:spPr>
-      </p:pic>
-      <p:sp>
-        <p:nvSpPr>
-          <p:cNvPr id="1286062993" name="Text 1"/>
-          <p:cNvSpPr txBox="1"/>
-          <p:nvPr/>
-        </p:nvSpPr>
-        <p:spPr bwMode="auto">
-          <a:xfrm>
-            <a:off x="746373" y="1664643"/>
-            <a:ext cx="187077" cy="200025"/>
-          </a:xfrm>
-          <a:prstGeom prst="rect">
-            <a:avLst/>
-          </a:prstGeom>
-          <a:ln/>
-        </p:spPr>
-        <p:txBody>
-          <a:bodyPr wrap="none" lIns="0" tIns="0" rIns="0" bIns="0" rtlCol="0" anchor="t"/>
-          <a:lstStyle/>
-          <a:p>
-            <a:pPr marL="0" indent="0" algn="l">
-              <a:lnSpc>
-                <a:spcPts val="1350"/>
-              </a:lnSpc>
-              <a:buNone/>
-              <a:defRPr/>
-            </a:pPr>
-            <a:r>
-              <a:rPr lang="en-US" sz="900" b="1">
-                <a:solidFill>
-                  <a:srgbClr val="67F4E2"/>
-                </a:solidFill>
-                <a:latin typeface="Inter"/>
-                <a:ea typeface="Inter"/>
-                <a:cs typeface="Inter"/>
-              </a:rPr>
-              <a:t>01</a:t>
-            </a:r>
-            <a:endParaRPr lang="en-US" sz="900"/>
-          </a:p>
-        </p:txBody>
-      </p:sp>
-      <p:sp>
-        <p:nvSpPr>
-          <p:cNvPr id="190044859" name="Text 2"/>
-          <p:cNvSpPr txBox="1"/>
-          <p:nvPr/>
-        </p:nvSpPr>
-        <p:spPr bwMode="auto">
-          <a:xfrm>
-            <a:off x="1095375" y="1607493"/>
-            <a:ext cx="5570934" cy="160734"/>
-          </a:xfrm>
-          <a:prstGeom prst="rect">
-            <a:avLst/>
-          </a:prstGeom>
-          <a:ln/>
-        </p:spPr>
-        <p:txBody>
-          <a:bodyPr wrap="none" lIns="0" tIns="0" rIns="0" bIns="0" rtlCol="0" anchor="t"/>
-          <a:lstStyle/>
-          <a:p>
-            <a:pPr marL="0" indent="0" algn="l">
-              <a:lnSpc>
-                <a:spcPts val="1266"/>
-              </a:lnSpc>
-              <a:spcAft>
-                <a:spcPts val="300"/>
-              </a:spcAft>
-              <a:buNone/>
-              <a:defRPr/>
-            </a:pPr>
-            <a:r>
-              <a:rPr lang="en-US" sz="1000" b="1" spc="-10">
-                <a:solidFill>
-                  <a:srgbClr val="EAEEF2"/>
-                </a:solidFill>
-                <a:latin typeface="Space Grotesk"/>
-                <a:ea typeface="Space Grotesk"/>
-                <a:cs typeface="Space Grotesk"/>
-              </a:rPr>
-              <a:t>Separation of concerns: access.log vs app.log</a:t>
-            </a:r>
-            <a:endParaRPr lang="en-US" sz="1000"/>
-          </a:p>
-        </p:txBody>
-      </p:sp>
-      <p:sp>
-        <p:nvSpPr>
-          <p:cNvPr id="1416058898" name="Text 3"/>
-          <p:cNvSpPr txBox="1"/>
-          <p:nvPr/>
-        </p:nvSpPr>
-        <p:spPr bwMode="auto">
-          <a:xfrm>
-            <a:off x="1095375" y="1806327"/>
-            <a:ext cx="5570934" cy="339030"/>
-          </a:xfrm>
-          <a:prstGeom prst="rect">
-            <a:avLst/>
-          </a:prstGeom>
-          <a:ln/>
-        </p:spPr>
-        <p:txBody>
-          <a:bodyPr wrap="square" lIns="0" tIns="0" rIns="0" bIns="0" rtlCol="0" anchor="t"/>
-          <a:lstStyle/>
-          <a:p>
-            <a:pPr marL="0" indent="0">
-              <a:buNone/>
-              <a:defRPr/>
-            </a:pPr>
-            <a:r>
-              <a:rPr lang="en-US" sz="900">
-                <a:solidFill>
-                  <a:srgbClr val="EAEEF3">
-                    <a:alpha val="72000"/>
-                  </a:srgbClr>
-                </a:solidFill>
-                <a:latin typeface="Inter"/>
-                <a:ea typeface="Inter"/>
-                <a:cs typeface="Inter"/>
-              </a:rPr>
-              <a:t>Pointing both </a:t>
-            </a:r>
-            <a:r>
-              <a:rPr lang="en-US" sz="900" b="1">
-                <a:solidFill>
-                  <a:srgbClr val="EAEEF2"/>
-                </a:solidFill>
-                <a:latin typeface="Inter"/>
-                <a:ea typeface="Inter"/>
-                <a:cs typeface="Inter"/>
-              </a:rPr>
-              <a:t>--access-logfile</a:t>
-            </a:r>
-            <a:r>
-              <a:rPr lang="en-US" sz="900">
-                <a:solidFill>
-                  <a:srgbClr val="EAEEF3">
-                    <a:alpha val="72000"/>
-                  </a:srgbClr>
-                </a:solidFill>
-                <a:latin typeface="Inter"/>
-                <a:ea typeface="Inter"/>
-                <a:cs typeface="Inter"/>
-              </a:rPr>
-              <a:t> and </a:t>
-            </a:r>
-            <a:r>
-              <a:rPr lang="en-US" sz="900" b="1">
-                <a:solidFill>
-                  <a:srgbClr val="EAEEF2"/>
-                </a:solidFill>
-                <a:latin typeface="Inter"/>
-                <a:ea typeface="Inter"/>
-                <a:cs typeface="Inter"/>
-              </a:rPr>
-              <a:t>--error-logfile</a:t>
-            </a:r>
-            <a:r>
-              <a:rPr lang="en-US" sz="900">
-                <a:solidFill>
-                  <a:srgbClr val="EAEEF3">
-                    <a:alpha val="72000"/>
-                  </a:srgbClr>
-                </a:solidFill>
-                <a:latin typeface="Inter"/>
-                <a:ea typeface="Inter"/>
-                <a:cs typeface="Inter"/>
-              </a:rPr>
-              <a:t> to same </a:t>
-            </a:r>
-            <a:r>
-              <a:rPr lang="en-US" sz="900" b="1">
-                <a:solidFill>
-                  <a:srgbClr val="EAEEF2"/>
-                </a:solidFill>
-                <a:latin typeface="Inter"/>
-                <a:ea typeface="Inter"/>
-                <a:cs typeface="Inter"/>
-              </a:rPr>
-              <a:t>app.log</a:t>
-            </a:r>
-            <a:r>
-              <a:rPr lang="en-US" sz="900">
-                <a:solidFill>
-                  <a:srgbClr val="EAEEF3">
-                    <a:alpha val="72000"/>
-                  </a:srgbClr>
-                </a:solidFill>
-                <a:latin typeface="Inter"/>
-                <a:ea typeface="Inter"/>
-                <a:cs typeface="Inter"/>
-              </a:rPr>
-              <a:t> mixes Apache format </a:t>
-            </a:r>
-            <a:r>
-              <a:rPr lang="en-US" sz="900">
-                <a:solidFill>
-                  <a:srgbClr val="EAEEF3">
-                    <a:alpha val="72000"/>
-                  </a:srgbClr>
-                </a:solidFill>
-                <a:latin typeface="monospace"/>
-                <a:ea typeface="monospace"/>
-                <a:cs typeface="monospace"/>
-              </a:rPr>
-              <a:t>91.0.58.40 - - [13/Aug...]</a:t>
-            </a:r>
-            <a:r>
-              <a:rPr lang="en-US" sz="900">
-                <a:solidFill>
-                  <a:srgbClr val="EAEEF3">
-                    <a:alpha val="72000"/>
-                  </a:srgbClr>
-                </a:solidFill>
-                <a:latin typeface="Inter"/>
-                <a:ea typeface="Inter"/>
-                <a:cs typeface="Inter"/>
-              </a:rPr>
-              <a:t> with JSON. Parser breaks → Discovered fields 11, no level.</a:t>
-            </a:r>
-            <a:endParaRPr lang="en-US" sz="900"/>
-          </a:p>
-        </p:txBody>
-      </p:sp>
-      <p:pic>
-        <p:nvPicPr>
-          <p:cNvPr id="65403245" name="Image 6" descr="preencoded.png"/>
-          <p:cNvPicPr>
-            <a:picLocks noChangeAspect="1"/>
-          </p:cNvPicPr>
-          <p:nvPr/>
-        </p:nvPicPr>
-        <p:blipFill rotWithShape="1">
-          <a:blip r:embed="rId5"/>
-          <a:stretch/>
-        </p:blipFill>
-        <p:spPr bwMode="auto">
-          <a:xfrm>
-            <a:off x="533399" y="3260580"/>
-            <a:ext cx="6275784" cy="766465"/>
-          </a:xfrm>
-          <a:prstGeom prst="rect">
-            <a:avLst/>
-          </a:prstGeom>
-        </p:spPr>
-      </p:pic>
-      <p:pic>
-        <p:nvPicPr>
-          <p:cNvPr id="896267642" name="Image 7" descr="preencoded.png"/>
-          <p:cNvPicPr>
-            <a:picLocks noChangeAspect="1"/>
-          </p:cNvPicPr>
-          <p:nvPr/>
-        </p:nvPicPr>
-        <p:blipFill rotWithShape="1">
-          <a:blip r:embed="rId6"/>
-          <a:stretch/>
-        </p:blipFill>
-        <p:spPr bwMode="auto">
-          <a:xfrm>
-            <a:off x="676274" y="3384406"/>
-            <a:ext cx="266700" cy="266700"/>
-          </a:xfrm>
-          <a:prstGeom prst="rect">
-            <a:avLst/>
-          </a:prstGeom>
-        </p:spPr>
-      </p:pic>
-      <p:sp>
-        <p:nvSpPr>
-          <p:cNvPr id="220042725" name="Text 10"/>
-          <p:cNvSpPr txBox="1"/>
-          <p:nvPr/>
-        </p:nvSpPr>
-        <p:spPr bwMode="auto">
-          <a:xfrm>
-            <a:off x="732382" y="3441556"/>
-            <a:ext cx="127853" cy="200745"/>
-          </a:xfrm>
-          <a:prstGeom prst="rect">
-            <a:avLst/>
-          </a:prstGeom>
-          <a:ln/>
-        </p:spPr>
-        <p:txBody>
-          <a:bodyPr wrap="none" lIns="0" tIns="0" rIns="0" bIns="0" rtlCol="0" anchor="t"/>
-          <a:lstStyle/>
-          <a:p>
-            <a:pPr marL="0" indent="0" algn="l">
-              <a:lnSpc>
-                <a:spcPts val="1350"/>
-              </a:lnSpc>
-              <a:buNone/>
-              <a:defRPr/>
-            </a:pPr>
-            <a:r>
-              <a:rPr lang="en-US" sz="900" b="1">
-                <a:solidFill>
-                  <a:srgbClr val="67F4E2"/>
-                </a:solidFill>
-                <a:latin typeface="Inter"/>
-                <a:ea typeface="Inter"/>
-                <a:cs typeface="Inter"/>
-              </a:rPr>
-              <a:t>0</a:t>
-            </a:r>
-            <a:r>
-              <a:rPr lang="de-DE" sz="900" b="1">
-                <a:solidFill>
-                  <a:srgbClr val="67F4E2"/>
-                </a:solidFill>
-                <a:latin typeface="Inter"/>
-                <a:ea typeface="Inter"/>
-                <a:cs typeface="Inter"/>
-              </a:rPr>
-              <a:t>2</a:t>
-            </a:r>
-            <a:endParaRPr lang="en-US" sz="900"/>
-          </a:p>
-        </p:txBody>
-      </p:sp>
-      <p:sp>
-        <p:nvSpPr>
-          <p:cNvPr id="310257843" name="Text 11"/>
-          <p:cNvSpPr txBox="1"/>
-          <p:nvPr/>
-        </p:nvSpPr>
-        <p:spPr bwMode="auto">
-          <a:xfrm>
-            <a:off x="1095374" y="3384406"/>
-            <a:ext cx="5570934" cy="160734"/>
-          </a:xfrm>
-          <a:prstGeom prst="rect">
-            <a:avLst/>
-          </a:prstGeom>
-          <a:ln/>
-        </p:spPr>
-        <p:txBody>
-          <a:bodyPr wrap="none" lIns="0" tIns="0" rIns="0" bIns="0" rtlCol="0" anchor="t"/>
-          <a:lstStyle/>
-          <a:p>
-            <a:pPr marL="0" indent="0" algn="l">
-              <a:lnSpc>
-                <a:spcPts val="1266"/>
-              </a:lnSpc>
-              <a:spcAft>
-                <a:spcPts val="300"/>
-              </a:spcAft>
-              <a:buNone/>
-              <a:defRPr/>
-            </a:pPr>
-            <a:r>
-              <a:rPr lang="en-US" sz="1000" b="1" spc="-10">
-                <a:solidFill>
-                  <a:srgbClr val="EAEEF2"/>
-                </a:solidFill>
-                <a:latin typeface="Space Grotesk"/>
-                <a:ea typeface="Space Grotesk"/>
-                <a:cs typeface="Space Grotesk"/>
-              </a:rPr>
-              <a:t>IAM least privilege bite</a:t>
-            </a:r>
-            <a:endParaRPr lang="en-US" sz="1000"/>
-          </a:p>
-        </p:txBody>
-      </p:sp>
-      <p:sp>
-        <p:nvSpPr>
-          <p:cNvPr id="1792687075" name="Text 12"/>
-          <p:cNvSpPr txBox="1"/>
-          <p:nvPr/>
-        </p:nvSpPr>
-        <p:spPr bwMode="auto">
-          <a:xfrm>
-            <a:off x="1095374" y="3583240"/>
-            <a:ext cx="5570934" cy="319980"/>
-          </a:xfrm>
-          <a:prstGeom prst="rect">
-            <a:avLst/>
-          </a:prstGeom>
-          <a:ln/>
-        </p:spPr>
-        <p:txBody>
-          <a:bodyPr wrap="square" lIns="0" tIns="0" rIns="0" bIns="0" rtlCol="0" anchor="t"/>
-          <a:lstStyle/>
-          <a:p>
-            <a:pPr marL="0" indent="0">
-              <a:buNone/>
-              <a:defRPr/>
-            </a:pPr>
-            <a:r>
-              <a:rPr lang="en-US" sz="900" b="1">
-                <a:solidFill>
-                  <a:srgbClr val="EAEEF2"/>
-                </a:solidFill>
-                <a:latin typeface="Inter"/>
-                <a:ea typeface="Inter"/>
-                <a:cs typeface="Inter"/>
-              </a:rPr>
-              <a:t>proj2-ec2-role PutMetricData works</a:t>
-            </a:r>
-            <a:r>
-              <a:rPr lang="en-US" sz="900">
-                <a:solidFill>
-                  <a:srgbClr val="EAEEF3">
-                    <a:alpha val="72000"/>
-                  </a:srgbClr>
-                </a:solidFill>
-                <a:latin typeface="Inter"/>
-                <a:ea typeface="Inter"/>
-                <a:cs typeface="Inter"/>
-              </a:rPr>
-              <a:t> but ListMetrics fails. Validate from Admin console, not EC2. Learned to test both planes.</a:t>
-            </a:r>
-            <a:endParaRPr lang="en-US" sz="900"/>
-          </a:p>
-        </p:txBody>
-      </p:sp>
-      <p:pic>
-        <p:nvPicPr>
-          <p:cNvPr id="759827195" name="Image 8" descr="preencoded.png"/>
-          <p:cNvPicPr>
-            <a:picLocks noChangeAspect="1"/>
-          </p:cNvPicPr>
-          <p:nvPr/>
-        </p:nvPicPr>
-        <p:blipFill rotWithShape="1">
-          <a:blip r:embed="rId7"/>
-          <a:stretch/>
-        </p:blipFill>
-        <p:spPr bwMode="auto">
-          <a:xfrm>
-            <a:off x="533400" y="5204817"/>
-            <a:ext cx="6275784" cy="766465"/>
-          </a:xfrm>
-          <a:prstGeom prst="rect">
-            <a:avLst/>
-          </a:prstGeom>
-        </p:spPr>
-      </p:pic>
-      <p:pic>
-        <p:nvPicPr>
-          <p:cNvPr id="95930989" name="Image 9" descr="preencoded.png"/>
-          <p:cNvPicPr>
-            <a:picLocks noChangeAspect="1"/>
-          </p:cNvPicPr>
-          <p:nvPr/>
-        </p:nvPicPr>
-        <p:blipFill rotWithShape="1">
-          <a:blip r:embed="rId8"/>
-          <a:stretch/>
-        </p:blipFill>
-        <p:spPr bwMode="auto">
-          <a:xfrm>
-            <a:off x="676275" y="5328642"/>
-            <a:ext cx="266700" cy="266700"/>
-          </a:xfrm>
-          <a:prstGeom prst="rect">
-            <a:avLst/>
-          </a:prstGeom>
-        </p:spPr>
-      </p:pic>
-      <p:sp>
-        <p:nvSpPr>
-          <p:cNvPr id="1628991008" name="Text 13"/>
-          <p:cNvSpPr txBox="1"/>
-          <p:nvPr/>
-        </p:nvSpPr>
-        <p:spPr bwMode="auto">
-          <a:xfrm>
-            <a:off x="735508" y="5385791"/>
-            <a:ext cx="127853" cy="200745"/>
-          </a:xfrm>
-          <a:prstGeom prst="rect">
-            <a:avLst/>
-          </a:prstGeom>
-          <a:ln/>
-        </p:spPr>
-        <p:txBody>
-          <a:bodyPr wrap="none" lIns="0" tIns="0" rIns="0" bIns="0" rtlCol="0" anchor="t"/>
-          <a:lstStyle/>
-          <a:p>
-            <a:pPr marL="0" indent="0" algn="l">
-              <a:lnSpc>
-                <a:spcPts val="1350"/>
-              </a:lnSpc>
-              <a:buNone/>
-              <a:defRPr/>
-            </a:pPr>
-            <a:r>
-              <a:rPr lang="en-US" sz="900" b="1">
-                <a:solidFill>
-                  <a:srgbClr val="38BDF8"/>
-                </a:solidFill>
-                <a:latin typeface="Inter"/>
-                <a:ea typeface="Inter"/>
-                <a:cs typeface="Inter"/>
-              </a:rPr>
-              <a:t>0</a:t>
-            </a:r>
-            <a:r>
-              <a:rPr lang="de-DE" sz="900" b="1">
-                <a:solidFill>
-                  <a:srgbClr val="38BDF8"/>
-                </a:solidFill>
-                <a:latin typeface="Inter"/>
-                <a:ea typeface="Inter"/>
-                <a:cs typeface="Inter"/>
-              </a:rPr>
-              <a:t>3</a:t>
-            </a:r>
-            <a:endParaRPr lang="en-US" sz="900"/>
-          </a:p>
-        </p:txBody>
-      </p:sp>
-      <p:sp>
-        <p:nvSpPr>
-          <p:cNvPr id="1726739959" name="Text 14"/>
-          <p:cNvSpPr txBox="1"/>
-          <p:nvPr/>
-        </p:nvSpPr>
-        <p:spPr bwMode="auto">
-          <a:xfrm>
-            <a:off x="1095375" y="5328642"/>
-            <a:ext cx="5570934" cy="160734"/>
-          </a:xfrm>
-          <a:prstGeom prst="rect">
-            <a:avLst/>
-          </a:prstGeom>
-          <a:ln/>
-        </p:spPr>
-        <p:txBody>
-          <a:bodyPr wrap="none" lIns="0" tIns="0" rIns="0" bIns="0" rtlCol="0" anchor="t"/>
-          <a:lstStyle/>
-          <a:p>
-            <a:pPr marL="0" indent="0" algn="l">
-              <a:lnSpc>
-                <a:spcPts val="1266"/>
-              </a:lnSpc>
-              <a:spcAft>
-                <a:spcPts val="300"/>
-              </a:spcAft>
-              <a:buNone/>
-              <a:defRPr/>
-            </a:pPr>
-            <a:r>
-              <a:rPr lang="en-US" sz="1000" b="1" spc="-10">
-                <a:solidFill>
-                  <a:srgbClr val="EAEEF2"/>
-                </a:solidFill>
-                <a:latin typeface="Space Grotesk"/>
-                <a:ea typeface="Space Grotesk"/>
-                <a:cs typeface="Space Grotesk"/>
-              </a:rPr>
-              <a:t>Correlation ID is game changer</a:t>
-            </a:r>
-            <a:endParaRPr lang="en-US" sz="1000"/>
-          </a:p>
-        </p:txBody>
-      </p:sp>
-      <p:sp>
-        <p:nvSpPr>
-          <p:cNvPr id="1085237909" name="Text 15"/>
-          <p:cNvSpPr txBox="1"/>
-          <p:nvPr/>
-        </p:nvSpPr>
-        <p:spPr bwMode="auto">
-          <a:xfrm>
-            <a:off x="1095375" y="5527477"/>
-            <a:ext cx="5570934" cy="319980"/>
-          </a:xfrm>
-          <a:prstGeom prst="rect">
-            <a:avLst/>
-          </a:prstGeom>
-          <a:ln/>
-        </p:spPr>
-        <p:txBody>
-          <a:bodyPr wrap="square" lIns="0" tIns="0" rIns="0" bIns="0" rtlCol="0" anchor="t"/>
-          <a:lstStyle/>
-          <a:p>
-            <a:pPr marL="0" indent="0">
-              <a:buNone/>
-              <a:defRPr/>
-            </a:pPr>
-            <a:r>
-              <a:rPr lang="en-US" sz="900">
-                <a:solidFill>
-                  <a:srgbClr val="EAEEF3">
-                    <a:alpha val="72000"/>
-                  </a:srgbClr>
-                </a:solidFill>
-                <a:latin typeface="Inter"/>
-                <a:ea typeface="Inter"/>
-                <a:cs typeface="Inter"/>
-              </a:rPr>
-              <a:t>One header </a:t>
-            </a:r>
-            <a:r>
-              <a:rPr lang="en-US" sz="900" b="1">
-                <a:solidFill>
-                  <a:srgbClr val="EAEEF2"/>
-                </a:solidFill>
-                <a:latin typeface="Inter"/>
-                <a:ea typeface="Inter"/>
-                <a:cs typeface="Inter"/>
-              </a:rPr>
-              <a:t>X-Correlation-ID</a:t>
-            </a:r>
-            <a:r>
-              <a:rPr lang="en-US" sz="900">
-                <a:solidFill>
-                  <a:srgbClr val="EAEEF3">
-                    <a:alpha val="72000"/>
-                  </a:srgbClr>
-                </a:solidFill>
-                <a:latin typeface="Inter"/>
-                <a:ea typeface="Inter"/>
-                <a:cs typeface="Inter"/>
-              </a:rPr>
-              <a:t> = </a:t>
-            </a:r>
-            <a:r>
-              <a:rPr lang="en-US" sz="900" b="1">
-                <a:solidFill>
-                  <a:srgbClr val="EAEEF2"/>
-                </a:solidFill>
-                <a:latin typeface="Inter"/>
-                <a:ea typeface="Inter"/>
-                <a:cs typeface="Inter"/>
-              </a:rPr>
-              <a:t>51e9ef29-4528…</a:t>
-            </a:r>
-            <a:r>
-              <a:rPr lang="en-US" sz="900">
-                <a:solidFill>
-                  <a:srgbClr val="EAEEF3">
-                    <a:alpha val="72000"/>
-                  </a:srgbClr>
-                </a:solidFill>
-                <a:latin typeface="Inter"/>
-                <a:ea typeface="Inter"/>
-                <a:cs typeface="Inter"/>
-              </a:rPr>
-              <a:t> ties order_created + request_completed. Without X-Ray, full trace in Logs Insights via </a:t>
-            </a:r>
-            <a:r>
-              <a:rPr lang="en-US" sz="900" b="1">
-                <a:solidFill>
-                  <a:srgbClr val="EAEEF2"/>
-                </a:solidFill>
-                <a:latin typeface="Inter"/>
-                <a:ea typeface="Inter"/>
-                <a:cs typeface="Inter"/>
-              </a:rPr>
-              <a:t>filter correlation_id="demo-123"</a:t>
-            </a:r>
-            <a:r>
-              <a:rPr lang="en-US" sz="900">
-                <a:solidFill>
-                  <a:srgbClr val="EAEEF3">
-                    <a:alpha val="72000"/>
-                  </a:srgbClr>
-                </a:solidFill>
-                <a:latin typeface="Inter"/>
-                <a:ea typeface="Inter"/>
-                <a:cs typeface="Inter"/>
-              </a:rPr>
-              <a:t>.</a:t>
-            </a:r>
-            <a:endParaRPr lang="en-US" sz="900"/>
-          </a:p>
-        </p:txBody>
-      </p:sp>
-      <p:pic>
-        <p:nvPicPr>
-          <p:cNvPr id="1144901885" name="Image 10" descr="preencoded.png"/>
-          <p:cNvPicPr>
-            <a:picLocks noChangeAspect="1"/>
-          </p:cNvPicPr>
-          <p:nvPr/>
-        </p:nvPicPr>
-        <p:blipFill rotWithShape="1">
-          <a:blip r:embed="rId9"/>
-          <a:stretch/>
-        </p:blipFill>
-        <p:spPr bwMode="auto">
-          <a:xfrm>
-            <a:off x="7113984" y="495300"/>
-            <a:ext cx="4544616" cy="5867399"/>
-          </a:xfrm>
-          <a:prstGeom prst="rect">
-            <a:avLst/>
-          </a:prstGeom>
-        </p:spPr>
-      </p:pic>
-      <p:pic>
-        <p:nvPicPr>
-          <p:cNvPr id="743493388" name="Image 11" descr="preencoded.png"/>
-          <p:cNvPicPr>
-            <a:picLocks noChangeAspect="1"/>
-          </p:cNvPicPr>
-          <p:nvPr/>
-        </p:nvPicPr>
-        <p:blipFill rotWithShape="1">
-          <a:blip r:embed="rId10"/>
-          <a:stretch/>
-        </p:blipFill>
-        <p:spPr bwMode="auto">
-          <a:xfrm>
-            <a:off x="7123509" y="504825"/>
-            <a:ext cx="4525566" cy="5848350"/>
-          </a:xfrm>
-          <a:prstGeom prst="rect">
-            <a:avLst/>
-          </a:prstGeom>
-        </p:spPr>
-      </p:pic>
-    </p:spTree>
-  </p:cSld>
-  <p:clrMapOvr>
-    <a:masterClrMapping/>
-  </p:clrMapOvr>
-  <mc:AlternateContent xmlns:mc="http://schemas.openxmlformats.org/markup-compatibility/2006">
-    <mc:Choice xmlns:p159="http://schemas.microsoft.com/office/powerpoint/2015/09/main" xmlns:p14="http://schemas.microsoft.com/office/powerpoint/2010/main" Requires="p159">
-      <p:transition p14:dur="500" advClick="1"/>
-    </mc:Choice>
-    <mc:Fallback>
-      <p:transition advClick="1"/>
-    </mc:Fallback>
-  </mc:AlternateContent>
-</p:sld>
-</file>
-
-<file path=ppt/slides/slide12.xml><?xml version="1.0" encoding="utf-8"?>
 <p:sld xmlns:a="http://schemas.openxmlformats.org/drawingml/2006/main" xmlns:r="http://schemas.openxmlformats.org/officeDocument/2006/relationships" xmlns:p="http://schemas.openxmlformats.org/presentationml/2006/main" xmlns:m="http://schemas.openxmlformats.org/officeDocument/2006/math" xmlns:w="http://schemas.openxmlformats.org/wordprocessingml/2006/main" xmlns:mc="http://schemas.openxmlformats.org/markup-compatibility/2006" showMasterPhAnim="0" showMasterSp="1" show="1">
   <p:cSld name="Slide 16">
     <p:bg>
@@ -5305,7 +4366,7 @@
       </p:grpSpPr>
       <p:sp>
         <p:nvSpPr>
-          <p:cNvPr id="801545282" name="Text 0"/>
+          <p:cNvPr id="1650002429" name="Text 0"/>
           <p:cNvSpPr txBox="1"/>
           <p:nvPr/>
         </p:nvSpPr>
@@ -5355,7 +4416,7 @@
       </p:sp>
       <p:pic>
         <p:nvPicPr>
-          <p:cNvPr id="247137435" name="Image 0" descr="preencoded.png"/>
+          <p:cNvPr id="81041982" name="Image 0" descr="preencoded.png"/>
           <p:cNvPicPr>
             <a:picLocks noChangeAspect="1"/>
           </p:cNvPicPr>
@@ -5377,7 +4438,7 @@
       </p:pic>
       <p:sp>
         <p:nvSpPr>
-          <p:cNvPr id="546801990" name="Text 1"/>
+          <p:cNvPr id="892441824" name="Text 1"/>
           <p:cNvSpPr txBox="1"/>
           <p:nvPr/>
         </p:nvSpPr>
@@ -5419,7 +4480,7 @@
       </p:sp>
       <p:sp>
         <p:nvSpPr>
-          <p:cNvPr id="970953378" name="Text 2"/>
+          <p:cNvPr id="1408696317" name="Text 2"/>
           <p:cNvSpPr txBox="1"/>
           <p:nvPr/>
         </p:nvSpPr>
@@ -5461,7 +4522,7 @@
       </p:sp>
       <p:sp>
         <p:nvSpPr>
-          <p:cNvPr id="868492357" name="Text 3"/>
+          <p:cNvPr id="1534062045" name="Text 3"/>
           <p:cNvSpPr txBox="1"/>
           <p:nvPr/>
         </p:nvSpPr>
@@ -5505,7 +4566,7 @@
       </p:sp>
       <p:pic>
         <p:nvPicPr>
-          <p:cNvPr id="2052153875" name="Image 2" descr="preencoded.png"/>
+          <p:cNvPr id="827588544" name="Image 2" descr="preencoded.png"/>
           <p:cNvPicPr>
             <a:picLocks noChangeAspect="1"/>
           </p:cNvPicPr>
@@ -5527,7 +4588,7 @@
       </p:pic>
       <p:sp>
         <p:nvSpPr>
-          <p:cNvPr id="742247931" name="Text 5"/>
+          <p:cNvPr id="175033739" name="Text 5"/>
           <p:cNvSpPr txBox="1"/>
           <p:nvPr/>
         </p:nvSpPr>
@@ -5580,7 +4641,7 @@
       </p:sp>
       <p:sp>
         <p:nvSpPr>
-          <p:cNvPr id="1392265242" name="Text 6"/>
+          <p:cNvPr id="526571442" name="Text 6"/>
           <p:cNvSpPr txBox="1"/>
           <p:nvPr/>
         </p:nvSpPr>
@@ -5622,7 +4683,7 @@
       </p:sp>
       <p:sp>
         <p:nvSpPr>
-          <p:cNvPr id="1738280646" name="Text 7"/>
+          <p:cNvPr id="760401870" name="Text 7"/>
           <p:cNvSpPr txBox="1"/>
           <p:nvPr/>
         </p:nvSpPr>
@@ -5680,7 +4741,7 @@
 </p:sld>
 </file>
 
-<file path=ppt/slides/slide13.xml><?xml version="1.0" encoding="utf-8"?>
+<file path=ppt/slides/slide12.xml><?xml version="1.0" encoding="utf-8"?>
 <p:sld xmlns:a="http://schemas.openxmlformats.org/drawingml/2006/main" xmlns:r="http://schemas.openxmlformats.org/officeDocument/2006/relationships" xmlns:p="http://schemas.openxmlformats.org/presentationml/2006/main" xmlns:m="http://schemas.openxmlformats.org/officeDocument/2006/math" xmlns:w="http://schemas.openxmlformats.org/wordprocessingml/2006/main" xmlns:mc="http://schemas.openxmlformats.org/markup-compatibility/2006" showMasterPhAnim="0" showMasterSp="1" show="1">
   <p:cSld name="Slide 18">
     <p:bg>
@@ -5706,7 +4767,7 @@
       </p:grpSpPr>
       <p:sp>
         <p:nvSpPr>
-          <p:cNvPr id="455831210" name="Text 0"/>
+          <p:cNvPr id="597249127" name="Text 0"/>
           <p:cNvSpPr txBox="1"/>
           <p:nvPr/>
         </p:nvSpPr>
@@ -5788,7 +4849,7 @@
       </p:sp>
       <p:sp>
         <p:nvSpPr>
-          <p:cNvPr id="375310395" name="Shape 11"/>
+          <p:cNvPr id="848734494" name="Shape 11"/>
           <p:cNvSpPr/>
           <p:nvPr/>
         </p:nvSpPr>
@@ -5850,7 +4911,7 @@
       </p:grpSpPr>
       <p:sp>
         <p:nvSpPr>
-          <p:cNvPr id="1301777318" name="Text 0"/>
+          <p:cNvPr id="804108247" name="Text 0"/>
           <p:cNvSpPr txBox="1"/>
           <p:nvPr/>
         </p:nvSpPr>
@@ -5892,7 +4953,7 @@
       </p:sp>
       <p:pic>
         <p:nvPicPr>
-          <p:cNvPr id="1293155738" name="Image 0" descr="preencoded.png"/>
+          <p:cNvPr id="583058950" name="Image 0" descr="preencoded.png"/>
           <p:cNvPicPr>
             <a:picLocks noChangeAspect="1"/>
           </p:cNvPicPr>
@@ -5914,7 +4975,7 @@
       </p:pic>
       <p:sp>
         <p:nvSpPr>
-          <p:cNvPr id="669683775" name="Text 1"/>
+          <p:cNvPr id="1252844597" name="Text 1"/>
           <p:cNvSpPr txBox="1"/>
           <p:nvPr/>
         </p:nvSpPr>
@@ -5956,7 +5017,7 @@
       </p:sp>
       <p:sp>
         <p:nvSpPr>
-          <p:cNvPr id="2040363220" name="Text 2"/>
+          <p:cNvPr id="560221307" name="Text 2"/>
           <p:cNvSpPr txBox="1"/>
           <p:nvPr/>
         </p:nvSpPr>
@@ -5998,7 +5059,7 @@
       </p:sp>
       <p:pic>
         <p:nvPicPr>
-          <p:cNvPr id="427377579" name="Image 1" descr="preencoded.png"/>
+          <p:cNvPr id="1615434991" name="Image 1" descr="preencoded.png"/>
           <p:cNvPicPr>
             <a:picLocks noChangeAspect="1"/>
           </p:cNvPicPr>
@@ -6020,7 +5081,7 @@
       </p:pic>
       <p:sp>
         <p:nvSpPr>
-          <p:cNvPr id="732643015" name="Text 4"/>
+          <p:cNvPr id="1451133410" name="Text 4"/>
           <p:cNvSpPr txBox="1"/>
           <p:nvPr/>
         </p:nvSpPr>
@@ -6062,7 +5123,7 @@
       </p:sp>
       <p:sp>
         <p:nvSpPr>
-          <p:cNvPr id="1022434688" name="Text 5"/>
+          <p:cNvPr id="2127782036" name="Text 5"/>
           <p:cNvSpPr txBox="1"/>
           <p:nvPr/>
         </p:nvSpPr>
@@ -6104,7 +5165,7 @@
       </p:sp>
       <p:pic>
         <p:nvPicPr>
-          <p:cNvPr id="1935035060" name="Image 2" descr="preencoded.png"/>
+          <p:cNvPr id="1459936454" name="Image 2" descr="preencoded.png"/>
           <p:cNvPicPr>
             <a:picLocks noChangeAspect="1"/>
           </p:cNvPicPr>
@@ -6126,7 +5187,7 @@
       </p:pic>
       <p:sp>
         <p:nvSpPr>
-          <p:cNvPr id="1795962726" name="Text 7"/>
+          <p:cNvPr id="1159880331" name="Text 7"/>
           <p:cNvSpPr txBox="1"/>
           <p:nvPr/>
         </p:nvSpPr>
@@ -6168,7 +5229,7 @@
       </p:sp>
       <p:sp>
         <p:nvSpPr>
-          <p:cNvPr id="1538559007" name="Text 8"/>
+          <p:cNvPr id="723416929" name="Text 8"/>
           <p:cNvSpPr txBox="1"/>
           <p:nvPr/>
         </p:nvSpPr>
@@ -6210,7 +5271,7 @@
       </p:sp>
       <p:pic>
         <p:nvPicPr>
-          <p:cNvPr id="1360490664" name="Image 3" descr="preencoded.png"/>
+          <p:cNvPr id="1650303298" name="Image 3" descr="preencoded.png"/>
           <p:cNvPicPr>
             <a:picLocks noChangeAspect="1"/>
           </p:cNvPicPr>
@@ -6232,7 +5293,7 @@
       </p:pic>
       <p:sp>
         <p:nvSpPr>
-          <p:cNvPr id="536519832" name="Text 10"/>
+          <p:cNvPr id="158549456" name="Text 10"/>
           <p:cNvSpPr txBox="1"/>
           <p:nvPr/>
         </p:nvSpPr>
@@ -6274,7 +5335,7 @@
       </p:sp>
       <p:sp>
         <p:nvSpPr>
-          <p:cNvPr id="1221080377" name="Text 11"/>
+          <p:cNvPr id="101710957" name="Text 11"/>
           <p:cNvSpPr txBox="1"/>
           <p:nvPr/>
         </p:nvSpPr>
@@ -6316,7 +5377,7 @@
       </p:sp>
       <p:pic>
         <p:nvPicPr>
-          <p:cNvPr id="631723080" name="Image 4" descr="preencoded.png"/>
+          <p:cNvPr id="1780468618" name="Image 4" descr="preencoded.png"/>
           <p:cNvPicPr>
             <a:picLocks noChangeAspect="1"/>
           </p:cNvPicPr>
@@ -6338,7 +5399,7 @@
       </p:pic>
       <p:sp>
         <p:nvSpPr>
-          <p:cNvPr id="957608786" name="Text 13"/>
+          <p:cNvPr id="2046881380" name="Text 13"/>
           <p:cNvSpPr txBox="1"/>
           <p:nvPr/>
         </p:nvSpPr>
@@ -6380,14 +5441,14 @@
       </p:sp>
       <p:sp>
         <p:nvSpPr>
-          <p:cNvPr id="1674017214" name="Text 14"/>
+          <p:cNvPr id="1951355360" name="Text 14"/>
           <p:cNvSpPr txBox="1"/>
           <p:nvPr/>
         </p:nvSpPr>
         <p:spPr bwMode="auto">
           <a:xfrm>
-            <a:off x="1666875" y="4667250"/>
-            <a:ext cx="4972050" cy="209550"/>
+            <a:off x="1666874" y="4667249"/>
+            <a:ext cx="1211876" cy="213869"/>
           </a:xfrm>
           <a:prstGeom prst="rect">
             <a:avLst/>
@@ -6414,7 +5475,7 @@
                 <a:ea typeface="Inter"/>
                 <a:cs typeface="Inter"/>
               </a:rPr>
-              <a:t>5. Learnings &amp; Improvements</a:t>
+              <a:t>5. Improvements</a:t>
             </a:r>
             <a:endParaRPr lang="en-US" sz="1200"/>
           </a:p>
@@ -6422,7 +5483,7 @@
       </p:sp>
       <p:pic>
         <p:nvPicPr>
-          <p:cNvPr id="1280587436" name="Image 5" descr="preencoded.png"/>
+          <p:cNvPr id="1044301596" name="Image 5" descr="preencoded.png"/>
           <p:cNvPicPr>
             <a:picLocks noChangeAspect="1"/>
           </p:cNvPicPr>
@@ -6444,7 +5505,7 @@
       </p:pic>
       <p:sp>
         <p:nvSpPr>
-          <p:cNvPr id="1890351242" name="Text 16"/>
+          <p:cNvPr id="377255994" name="Text 16"/>
           <p:cNvSpPr txBox="1"/>
           <p:nvPr/>
         </p:nvSpPr>
@@ -6486,7 +5547,7 @@
       </p:sp>
       <p:sp>
         <p:nvSpPr>
-          <p:cNvPr id="347211888" name="Text 17"/>
+          <p:cNvPr id="1635594893" name="Text 17"/>
           <p:cNvSpPr txBox="1"/>
           <p:nvPr/>
         </p:nvSpPr>
@@ -6528,7 +5589,7 @@
       </p:sp>
       <p:pic>
         <p:nvPicPr>
-          <p:cNvPr id="1371037183" name="Image 6" descr="preencoded.png"/>
+          <p:cNvPr id="689358981" name="Image 6" descr="preencoded.png"/>
           <p:cNvPicPr>
             <a:picLocks noChangeAspect="1"/>
           </p:cNvPicPr>
@@ -6550,7 +5611,7 @@
       </p:pic>
       <p:sp>
         <p:nvSpPr>
-          <p:cNvPr id="1928805483" name="Text 19"/>
+          <p:cNvPr id="2069766592" name="Text 19"/>
           <p:cNvSpPr txBox="1"/>
           <p:nvPr/>
         </p:nvSpPr>
@@ -6614,7 +5675,7 @@
       </p:sp>
       <p:sp>
         <p:nvSpPr>
-          <p:cNvPr id="1193191485" name="Text 20"/>
+          <p:cNvPr id="1631593722" name="Text 20"/>
           <p:cNvSpPr txBox="1"/>
           <p:nvPr/>
         </p:nvSpPr>
@@ -6658,7 +5719,7 @@
       </p:sp>
       <p:sp>
         <p:nvSpPr>
-          <p:cNvPr id="586170989" name="Shape 21"/>
+          <p:cNvPr id="851809671" name="Shape 21"/>
           <p:cNvSpPr/>
           <p:nvPr/>
         </p:nvSpPr>
@@ -6680,7 +5741,7 @@
       </p:sp>
       <p:sp>
         <p:nvSpPr>
-          <p:cNvPr id="597226851" name="Text 22"/>
+          <p:cNvPr id="1731341760" name="Text 22"/>
           <p:cNvSpPr txBox="1"/>
           <p:nvPr/>
         </p:nvSpPr>
@@ -6733,7 +5794,7 @@
       </p:sp>
       <p:sp>
         <p:nvSpPr>
-          <p:cNvPr id="1865411080" name="Text 23"/>
+          <p:cNvPr id="338655085" name="Text 23"/>
           <p:cNvSpPr txBox="1"/>
           <p:nvPr/>
         </p:nvSpPr>
@@ -6777,7 +5838,7 @@
       </p:sp>
       <p:sp>
         <p:nvSpPr>
-          <p:cNvPr id="295484740" name="Shape 24"/>
+          <p:cNvPr id="938124507" name="Shape 24"/>
           <p:cNvSpPr/>
           <p:nvPr/>
         </p:nvSpPr>
@@ -6848,7 +5909,7 @@
                                           </p:stCondLst>
                                         </p:cTn>
                                         <p:tgtEl>
-                                          <p:spTgt spid="1293155738"/>
+                                          <p:spTgt spid="583058950"/>
                                         </p:tgtEl>
                                         <p:attrNameLst>
                                           <p:attrName>style.visibility</p:attrName>
@@ -6875,7 +5936,7 @@
                                           </p:stCondLst>
                                         </p:cTn>
                                         <p:tgtEl>
-                                          <p:spTgt spid="669683775"/>
+                                          <p:spTgt spid="1252844597"/>
                                         </p:tgtEl>
                                         <p:attrNameLst>
                                           <p:attrName>style.visibility</p:attrName>
@@ -6902,7 +5963,7 @@
                                           </p:stCondLst>
                                         </p:cTn>
                                         <p:tgtEl>
-                                          <p:spTgt spid="2040363220"/>
+                                          <p:spTgt spid="560221307"/>
                                         </p:tgtEl>
                                         <p:attrNameLst>
                                           <p:attrName>style.visibility</p:attrName>
@@ -6947,7 +6008,7 @@
                                           </p:stCondLst>
                                         </p:cTn>
                                         <p:tgtEl>
-                                          <p:spTgt spid="427377579"/>
+                                          <p:spTgt spid="1615434991"/>
                                         </p:tgtEl>
                                         <p:attrNameLst>
                                           <p:attrName>style.visibility</p:attrName>
@@ -6974,7 +6035,7 @@
                                           </p:stCondLst>
                                         </p:cTn>
                                         <p:tgtEl>
-                                          <p:spTgt spid="732643015"/>
+                                          <p:spTgt spid="1451133410"/>
                                         </p:tgtEl>
                                         <p:attrNameLst>
                                           <p:attrName>style.visibility</p:attrName>
@@ -7001,7 +6062,7 @@
                                           </p:stCondLst>
                                         </p:cTn>
                                         <p:tgtEl>
-                                          <p:spTgt spid="1022434688"/>
+                                          <p:spTgt spid="2127782036"/>
                                         </p:tgtEl>
                                         <p:attrNameLst>
                                           <p:attrName>style.visibility</p:attrName>
@@ -7046,7 +6107,7 @@
                                           </p:stCondLst>
                                         </p:cTn>
                                         <p:tgtEl>
-                                          <p:spTgt spid="1935035060"/>
+                                          <p:spTgt spid="1459936454"/>
                                         </p:tgtEl>
                                         <p:attrNameLst>
                                           <p:attrName>style.visibility</p:attrName>
@@ -7073,7 +6134,7 @@
                                           </p:stCondLst>
                                         </p:cTn>
                                         <p:tgtEl>
-                                          <p:spTgt spid="1795962726"/>
+                                          <p:spTgt spid="1159880331"/>
                                         </p:tgtEl>
                                         <p:attrNameLst>
                                           <p:attrName>style.visibility</p:attrName>
@@ -7100,7 +6161,7 @@
                                           </p:stCondLst>
                                         </p:cTn>
                                         <p:tgtEl>
-                                          <p:spTgt spid="1538559007"/>
+                                          <p:spTgt spid="723416929"/>
                                         </p:tgtEl>
                                         <p:attrNameLst>
                                           <p:attrName>style.visibility</p:attrName>
@@ -7145,7 +6206,7 @@
                                           </p:stCondLst>
                                         </p:cTn>
                                         <p:tgtEl>
-                                          <p:spTgt spid="1360490664"/>
+                                          <p:spTgt spid="1650303298"/>
                                         </p:tgtEl>
                                         <p:attrNameLst>
                                           <p:attrName>style.visibility</p:attrName>
@@ -7172,7 +6233,7 @@
                                           </p:stCondLst>
                                         </p:cTn>
                                         <p:tgtEl>
-                                          <p:spTgt spid="536519832"/>
+                                          <p:spTgt spid="158549456"/>
                                         </p:tgtEl>
                                         <p:attrNameLst>
                                           <p:attrName>style.visibility</p:attrName>
@@ -7199,7 +6260,7 @@
                                           </p:stCondLst>
                                         </p:cTn>
                                         <p:tgtEl>
-                                          <p:spTgt spid="1221080377"/>
+                                          <p:spTgt spid="101710957"/>
                                         </p:tgtEl>
                                         <p:attrNameLst>
                                           <p:attrName>style.visibility</p:attrName>
@@ -7244,7 +6305,7 @@
                                           </p:stCondLst>
                                         </p:cTn>
                                         <p:tgtEl>
-                                          <p:spTgt spid="631723080"/>
+                                          <p:spTgt spid="1780468618"/>
                                         </p:tgtEl>
                                         <p:attrNameLst>
                                           <p:attrName>style.visibility</p:attrName>
@@ -7271,7 +6332,7 @@
                                           </p:stCondLst>
                                         </p:cTn>
                                         <p:tgtEl>
-                                          <p:spTgt spid="957608786"/>
+                                          <p:spTgt spid="2046881380"/>
                                         </p:tgtEl>
                                         <p:attrNameLst>
                                           <p:attrName>style.visibility</p:attrName>
@@ -7298,7 +6359,7 @@
                                           </p:stCondLst>
                                         </p:cTn>
                                         <p:tgtEl>
-                                          <p:spTgt spid="1674017214"/>
+                                          <p:spTgt spid="1951355360"/>
                                         </p:tgtEl>
                                         <p:attrNameLst>
                                           <p:attrName>style.visibility</p:attrName>
@@ -7343,7 +6404,7 @@
                                           </p:stCondLst>
                                         </p:cTn>
                                         <p:tgtEl>
-                                          <p:spTgt spid="1280587436"/>
+                                          <p:spTgt spid="1044301596"/>
                                         </p:tgtEl>
                                         <p:attrNameLst>
                                           <p:attrName>style.visibility</p:attrName>
@@ -7370,7 +6431,7 @@
                                           </p:stCondLst>
                                         </p:cTn>
                                         <p:tgtEl>
-                                          <p:spTgt spid="1890351242"/>
+                                          <p:spTgt spid="377255994"/>
                                         </p:tgtEl>
                                         <p:attrNameLst>
                                           <p:attrName>style.visibility</p:attrName>
@@ -7397,7 +6458,7 @@
                                           </p:stCondLst>
                                         </p:cTn>
                                         <p:tgtEl>
-                                          <p:spTgt spid="347211888"/>
+                                          <p:spTgt spid="1635594893"/>
                                         </p:tgtEl>
                                         <p:attrNameLst>
                                           <p:attrName>style.visibility</p:attrName>
@@ -7442,7 +6503,7 @@
                                           </p:stCondLst>
                                         </p:cTn>
                                         <p:tgtEl>
-                                          <p:spTgt spid="1371037183"/>
+                                          <p:spTgt spid="689358981"/>
                                         </p:tgtEl>
                                         <p:attrNameLst>
                                           <p:attrName>style.visibility</p:attrName>
@@ -7469,7 +6530,7 @@
                                           </p:stCondLst>
                                         </p:cTn>
                                         <p:tgtEl>
-                                          <p:spTgt spid="1928805483"/>
+                                          <p:spTgt spid="2069766592"/>
                                         </p:tgtEl>
                                         <p:attrNameLst>
                                           <p:attrName>style.visibility</p:attrName>
@@ -7496,7 +6557,7 @@
                                           </p:stCondLst>
                                         </p:cTn>
                                         <p:tgtEl>
-                                          <p:spTgt spid="1193191485"/>
+                                          <p:spTgt spid="1631593722"/>
                                         </p:tgtEl>
                                         <p:attrNameLst>
                                           <p:attrName>style.visibility</p:attrName>
@@ -7523,7 +6584,7 @@
                                           </p:stCondLst>
                                         </p:cTn>
                                         <p:tgtEl>
-                                          <p:spTgt spid="586170989"/>
+                                          <p:spTgt spid="851809671"/>
                                         </p:tgtEl>
                                         <p:attrNameLst>
                                           <p:attrName>style.visibility</p:attrName>
@@ -7550,7 +6611,7 @@
                                           </p:stCondLst>
                                         </p:cTn>
                                         <p:tgtEl>
-                                          <p:spTgt spid="597226851"/>
+                                          <p:spTgt spid="1731341760"/>
                                         </p:tgtEl>
                                         <p:attrNameLst>
                                           <p:attrName>style.visibility</p:attrName>
@@ -7577,7 +6638,7 @@
                                           </p:stCondLst>
                                         </p:cTn>
                                         <p:tgtEl>
-                                          <p:spTgt spid="1865411080"/>
+                                          <p:spTgt spid="338655085"/>
                                         </p:tgtEl>
                                         <p:attrNameLst>
                                           <p:attrName>style.visibility</p:attrName>
@@ -7604,7 +6665,7 @@
                                           </p:stCondLst>
                                         </p:cTn>
                                         <p:tgtEl>
-                                          <p:spTgt spid="295484740"/>
+                                          <p:spTgt spid="938124507"/>
                                         </p:tgtEl>
                                         <p:attrNameLst>
                                           <p:attrName>style.visibility</p:attrName>
@@ -7696,7 +6757,7 @@
       </p:pic>
       <p:sp>
         <p:nvSpPr>
-          <p:cNvPr id="1029824324" name="Text 0"/>
+          <p:cNvPr id="1292072186" name="Text 0"/>
           <p:cNvSpPr txBox="1"/>
           <p:nvPr/>
         </p:nvSpPr>
@@ -7748,7 +6809,7 @@
       </p:sp>
       <p:pic>
         <p:nvPicPr>
-          <p:cNvPr id="612340166" name="Image 0" descr="preencoded.png"/>
+          <p:cNvPr id="1660383303" name="Image 0" descr="preencoded.png"/>
           <p:cNvPicPr>
             <a:picLocks noChangeAspect="1"/>
           </p:cNvPicPr>
@@ -7770,7 +6831,7 @@
       </p:pic>
       <p:sp>
         <p:nvSpPr>
-          <p:cNvPr id="338298132" name="Text 1"/>
+          <p:cNvPr id="1340184249" name="Text 1"/>
           <p:cNvSpPr txBox="1"/>
           <p:nvPr/>
         </p:nvSpPr>
@@ -7815,7 +6876,7 @@
       </p:sp>
       <p:sp>
         <p:nvSpPr>
-          <p:cNvPr id="1739735229" name="Text 2"/>
+          <p:cNvPr id="1932624350" name="Text 2"/>
           <p:cNvSpPr txBox="1"/>
           <p:nvPr/>
         </p:nvSpPr>
@@ -7886,7 +6947,7 @@
       </p:sp>
       <p:pic>
         <p:nvPicPr>
-          <p:cNvPr id="1113387993" name="Image 1" descr="preencoded.png"/>
+          <p:cNvPr id="6240100" name="Image 1" descr="preencoded.png"/>
           <p:cNvPicPr>
             <a:picLocks noChangeAspect="1"/>
           </p:cNvPicPr>
@@ -7908,7 +6969,7 @@
       </p:pic>
       <p:sp>
         <p:nvSpPr>
-          <p:cNvPr id="1548801272" name="Text 3"/>
+          <p:cNvPr id="1102043735" name="Text 3"/>
           <p:cNvSpPr txBox="1"/>
           <p:nvPr/>
         </p:nvSpPr>
@@ -7953,7 +7014,7 @@
       </p:sp>
       <p:sp>
         <p:nvSpPr>
-          <p:cNvPr id="1794295737" name="Text 4"/>
+          <p:cNvPr id="1485169789" name="Text 4"/>
           <p:cNvSpPr txBox="1"/>
           <p:nvPr/>
         </p:nvSpPr>
@@ -8042,7 +7103,7 @@
       </p:sp>
       <p:pic>
         <p:nvPicPr>
-          <p:cNvPr id="1531479373" name="Image 2" descr="preencoded.png"/>
+          <p:cNvPr id="512956680" name="Image 2" descr="preencoded.png"/>
           <p:cNvPicPr>
             <a:picLocks noChangeAspect="1"/>
           </p:cNvPicPr>
@@ -8064,7 +7125,7 @@
       </p:pic>
       <p:sp>
         <p:nvSpPr>
-          <p:cNvPr id="213026106" name="Text 5"/>
+          <p:cNvPr id="1393968316" name="Text 5"/>
           <p:cNvSpPr txBox="1"/>
           <p:nvPr/>
         </p:nvSpPr>
@@ -8109,7 +7170,7 @@
       </p:sp>
       <p:sp>
         <p:nvSpPr>
-          <p:cNvPr id="777751175" name="Text 6"/>
+          <p:cNvPr id="815135437" name="Text 6"/>
           <p:cNvSpPr txBox="1"/>
           <p:nvPr/>
         </p:nvSpPr>
@@ -8219,7 +7280,7 @@
                                           </p:stCondLst>
                                         </p:cTn>
                                         <p:tgtEl>
-                                          <p:spTgt spid="612340166"/>
+                                          <p:spTgt spid="1660383303"/>
                                         </p:tgtEl>
                                         <p:attrNameLst>
                                           <p:attrName>style.visibility</p:attrName>
@@ -8246,7 +7307,7 @@
                                           </p:stCondLst>
                                         </p:cTn>
                                         <p:tgtEl>
-                                          <p:spTgt spid="338298132"/>
+                                          <p:spTgt spid="1340184249"/>
                                         </p:tgtEl>
                                         <p:attrNameLst>
                                           <p:attrName>style.visibility</p:attrName>
@@ -8273,7 +7334,7 @@
                                           </p:stCondLst>
                                         </p:cTn>
                                         <p:tgtEl>
-                                          <p:spTgt spid="1739735229"/>
+                                          <p:spTgt spid="1932624350"/>
                                         </p:tgtEl>
                                         <p:attrNameLst>
                                           <p:attrName>style.visibility</p:attrName>
@@ -8318,7 +7379,7 @@
                                           </p:stCondLst>
                                         </p:cTn>
                                         <p:tgtEl>
-                                          <p:spTgt spid="1531479373"/>
+                                          <p:spTgt spid="512956680"/>
                                         </p:tgtEl>
                                         <p:attrNameLst>
                                           <p:attrName>style.visibility</p:attrName>
@@ -8345,7 +7406,7 @@
                                           </p:stCondLst>
                                         </p:cTn>
                                         <p:tgtEl>
-                                          <p:spTgt spid="213026106"/>
+                                          <p:spTgt spid="1393968316"/>
                                         </p:tgtEl>
                                         <p:attrNameLst>
                                           <p:attrName>style.visibility</p:attrName>
@@ -8372,7 +7433,7 @@
                                           </p:stCondLst>
                                         </p:cTn>
                                         <p:tgtEl>
-                                          <p:spTgt spid="777751175"/>
+                                          <p:spTgt spid="815135437"/>
                                         </p:tgtEl>
                                         <p:attrNameLst>
                                           <p:attrName>style.visibility</p:attrName>
@@ -8417,7 +7478,7 @@
                                           </p:stCondLst>
                                         </p:cTn>
                                         <p:tgtEl>
-                                          <p:spTgt spid="1113387993"/>
+                                          <p:spTgt spid="6240100"/>
                                         </p:tgtEl>
                                         <p:attrNameLst>
                                           <p:attrName>style.visibility</p:attrName>
@@ -8444,7 +7505,7 @@
                                           </p:stCondLst>
                                         </p:cTn>
                                         <p:tgtEl>
-                                          <p:spTgt spid="1548801272"/>
+                                          <p:spTgt spid="1102043735"/>
                                         </p:tgtEl>
                                         <p:attrNameLst>
                                           <p:attrName>style.visibility</p:attrName>
@@ -8471,7 +7532,7 @@
                                           </p:stCondLst>
                                         </p:cTn>
                                         <p:tgtEl>
-                                          <p:spTgt spid="1794295737"/>
+                                          <p:spTgt spid="1485169789"/>
                                         </p:tgtEl>
                                         <p:attrNameLst>
                                           <p:attrName>style.visibility</p:attrName>
@@ -8586,7 +7647,7 @@
       </p:grpSpPr>
       <p:pic>
         <p:nvPicPr>
-          <p:cNvPr id="815547082" name=""/>
+          <p:cNvPr id="1011342833" name=""/>
           <p:cNvPicPr>
             <a:picLocks noChangeAspect="1"/>
           </p:cNvPicPr>
@@ -8608,7 +7669,7 @@
       </p:pic>
       <p:sp>
         <p:nvSpPr>
-          <p:cNvPr id="1549324895" name="TextBox 1"/>
+          <p:cNvPr id="1878310396" name="TextBox 1"/>
           <p:cNvSpPr txBox="1"/>
           <p:nvPr/>
         </p:nvSpPr>
@@ -8654,7 +7715,7 @@
       </p:sp>
       <p:sp>
         <p:nvSpPr>
-          <p:cNvPr id="1019842301" name="Rectangle 2"/>
+          <p:cNvPr id="1915507903" name="Rectangle 2"/>
           <p:cNvSpPr/>
           <p:nvPr/>
         </p:nvSpPr>
@@ -8779,7 +7840,7 @@
       </p:sp>
       <p:sp>
         <p:nvSpPr>
-          <p:cNvPr id="46437132" name="Rectangle 3"/>
+          <p:cNvPr id="2044621200" name="Rectangle 3"/>
           <p:cNvSpPr/>
           <p:nvPr/>
         </p:nvSpPr>
@@ -8870,7 +7931,7 @@
       </p:sp>
       <p:sp>
         <p:nvSpPr>
-          <p:cNvPr id="577491431" name="Rectangle 4"/>
+          <p:cNvPr id="1082043027" name="Rectangle 4"/>
           <p:cNvSpPr/>
           <p:nvPr/>
         </p:nvSpPr>
@@ -8969,7 +8030,7 @@
       </p:sp>
       <p:sp>
         <p:nvSpPr>
-          <p:cNvPr id="14511331" name="Rectangle 5"/>
+          <p:cNvPr id="1710600444" name="Rectangle 5"/>
           <p:cNvSpPr/>
           <p:nvPr/>
         </p:nvSpPr>
@@ -9060,7 +8121,7 @@
       </p:sp>
       <p:sp>
         <p:nvSpPr>
-          <p:cNvPr id="1192231185" name="Rectangle 6"/>
+          <p:cNvPr id="1345509667" name="Rectangle 6"/>
           <p:cNvSpPr/>
           <p:nvPr/>
         </p:nvSpPr>
@@ -9155,7 +8216,7 @@
       </p:sp>
       <p:sp>
         <p:nvSpPr>
-          <p:cNvPr id="2038147305" name="Rectangle 7"/>
+          <p:cNvPr id="1371897577" name="Rectangle 7"/>
           <p:cNvSpPr/>
           <p:nvPr/>
         </p:nvSpPr>
@@ -9270,7 +8331,7 @@
       </p:sp>
       <p:sp>
         <p:nvSpPr>
-          <p:cNvPr id="1798567717" name="Rectangle 8"/>
+          <p:cNvPr id="1584579881" name="Rectangle 8"/>
           <p:cNvSpPr/>
           <p:nvPr/>
         </p:nvSpPr>
@@ -9361,7 +8422,7 @@
       </p:sp>
       <p:sp>
         <p:nvSpPr>
-          <p:cNvPr id="1821483858" name="Rectangle 9"/>
+          <p:cNvPr id="1242827421" name="Rectangle 9"/>
           <p:cNvSpPr/>
           <p:nvPr/>
         </p:nvSpPr>
@@ -9452,7 +8513,7 @@
       </p:sp>
       <p:sp>
         <p:nvSpPr>
-          <p:cNvPr id="1021084818" name="Rectangle 9"/>
+          <p:cNvPr id="170005159" name="Rectangle 9"/>
           <p:cNvSpPr/>
           <p:nvPr/>
         </p:nvSpPr>
@@ -9678,7 +8739,7 @@
                                           </p:stCondLst>
                                         </p:cTn>
                                         <p:tgtEl>
-                                          <p:spTgt spid="1019842301"/>
+                                          <p:spTgt spid="1915507903"/>
                                         </p:tgtEl>
                                         <p:attrNameLst>
                                           <p:attrName>style.visibility</p:attrName>
@@ -9705,7 +8766,7 @@
                                           </p:stCondLst>
                                         </p:cTn>
                                         <p:tgtEl>
-                                          <p:spTgt spid="815547082"/>
+                                          <p:spTgt spid="1011342833"/>
                                         </p:tgtEl>
                                         <p:attrNameLst>
                                           <p:attrName>style.visibility</p:attrName>
@@ -9750,7 +8811,7 @@
                                           </p:stCondLst>
                                         </p:cTn>
                                         <p:tgtEl>
-                                          <p:spTgt spid="46437132"/>
+                                          <p:spTgt spid="2044621200"/>
                                         </p:tgtEl>
                                         <p:attrNameLst>
                                           <p:attrName>style.visibility</p:attrName>
@@ -9795,7 +8856,7 @@
                                           </p:stCondLst>
                                         </p:cTn>
                                         <p:tgtEl>
-                                          <p:spTgt spid="1192231185"/>
+                                          <p:spTgt spid="1345509667"/>
                                         </p:tgtEl>
                                         <p:attrNameLst>
                                           <p:attrName>style.visibility</p:attrName>
@@ -9840,7 +8901,7 @@
                                           </p:stCondLst>
                                         </p:cTn>
                                         <p:tgtEl>
-                                          <p:spTgt spid="1821483858"/>
+                                          <p:spTgt spid="1242827421"/>
                                         </p:tgtEl>
                                         <p:attrNameLst>
                                           <p:attrName>style.visibility</p:attrName>
@@ -9885,7 +8946,7 @@
                                           </p:stCondLst>
                                         </p:cTn>
                                         <p:tgtEl>
-                                          <p:spTgt spid="1798567717"/>
+                                          <p:spTgt spid="1584579881"/>
                                         </p:tgtEl>
                                         <p:attrNameLst>
                                           <p:attrName>style.visibility</p:attrName>
@@ -9930,7 +8991,7 @@
                                           </p:stCondLst>
                                         </p:cTn>
                                         <p:tgtEl>
-                                          <p:spTgt spid="577491431"/>
+                                          <p:spTgt spid="1082043027"/>
                                         </p:tgtEl>
                                         <p:attrNameLst>
                                           <p:attrName>style.visibility</p:attrName>
@@ -9975,7 +9036,7 @@
                                           </p:stCondLst>
                                         </p:cTn>
                                         <p:tgtEl>
-                                          <p:spTgt spid="2038147305"/>
+                                          <p:spTgt spid="1371897577"/>
                                         </p:tgtEl>
                                         <p:attrNameLst>
                                           <p:attrName>style.visibility</p:attrName>
@@ -10020,7 +9081,7 @@
                                           </p:stCondLst>
                                         </p:cTn>
                                         <p:tgtEl>
-                                          <p:spTgt spid="1021084818"/>
+                                          <p:spTgt spid="170005159"/>
                                         </p:tgtEl>
                                         <p:attrNameLst>
                                           <p:attrName>style.visibility</p:attrName>
@@ -10065,7 +9126,7 @@
                                           </p:stCondLst>
                                         </p:cTn>
                                         <p:tgtEl>
-                                          <p:spTgt spid="14511331"/>
+                                          <p:spTgt spid="1710600444"/>
                                         </p:tgtEl>
                                         <p:attrNameLst>
                                           <p:attrName>style.visibility</p:attrName>
@@ -10135,7 +9196,7 @@
       </p:grpSpPr>
       <p:sp>
         <p:nvSpPr>
-          <p:cNvPr id="1716906254" name="Text 0"/>
+          <p:cNvPr id="805222470" name="Text 0"/>
           <p:cNvSpPr txBox="1"/>
           <p:nvPr/>
         </p:nvSpPr>
@@ -10196,7 +9257,7 @@
       </p:sp>
       <p:pic>
         <p:nvPicPr>
-          <p:cNvPr id="1543916807" name="Image 0" descr="preencoded.png"/>
+          <p:cNvPr id="979381432" name="Image 0" descr="preencoded.png"/>
           <p:cNvPicPr>
             <a:picLocks noChangeAspect="1"/>
           </p:cNvPicPr>
@@ -10218,7 +9279,7 @@
       </p:pic>
       <p:sp>
         <p:nvSpPr>
-          <p:cNvPr id="858479948" name="Text 1"/>
+          <p:cNvPr id="326770957" name="Text 1"/>
           <p:cNvSpPr txBox="1"/>
           <p:nvPr/>
         </p:nvSpPr>
@@ -10260,7 +9321,7 @@
       </p:sp>
       <p:pic>
         <p:nvPicPr>
-          <p:cNvPr id="1891449163" name="Image 1" descr="preencoded.png"/>
+          <p:cNvPr id="596839610" name="Image 1" descr="preencoded.png"/>
           <p:cNvPicPr>
             <a:picLocks noChangeAspect="1"/>
           </p:cNvPicPr>
@@ -10282,7 +9343,7 @@
       </p:pic>
       <p:sp>
         <p:nvSpPr>
-          <p:cNvPr id="637304334" name="Text 2"/>
+          <p:cNvPr id="1363909735" name="Text 2"/>
           <p:cNvSpPr txBox="1"/>
           <p:nvPr/>
         </p:nvSpPr>
@@ -10310,7 +9371,7 @@
       </p:sp>
       <p:sp>
         <p:nvSpPr>
-          <p:cNvPr id="1792570015" name="Text 3"/>
+          <p:cNvPr id="368359771" name="Text 3"/>
           <p:cNvSpPr txBox="1"/>
           <p:nvPr/>
         </p:nvSpPr>
@@ -10352,7 +9413,7 @@
       </p:sp>
       <p:sp>
         <p:nvSpPr>
-          <p:cNvPr id="1240464779" name="Text 4"/>
+          <p:cNvPr id="919300530" name="Text 4"/>
           <p:cNvSpPr txBox="1"/>
           <p:nvPr/>
         </p:nvSpPr>
@@ -10396,7 +9457,7 @@
       </p:sp>
       <p:pic>
         <p:nvPicPr>
-          <p:cNvPr id="297698753" name="Image 2" descr="preencoded.png"/>
+          <p:cNvPr id="1316328044" name="Image 2" descr="preencoded.png"/>
           <p:cNvPicPr>
             <a:picLocks noChangeAspect="1"/>
           </p:cNvPicPr>
@@ -10418,7 +9479,7 @@
       </p:pic>
       <p:sp>
         <p:nvSpPr>
-          <p:cNvPr id="71383884" name="Text 5"/>
+          <p:cNvPr id="92407645" name="Text 5"/>
           <p:cNvSpPr txBox="1"/>
           <p:nvPr/>
         </p:nvSpPr>
@@ -10460,7 +9521,7 @@
       </p:sp>
       <p:pic>
         <p:nvPicPr>
-          <p:cNvPr id="1403642998" name="Image 3" descr="preencoded.png"/>
+          <p:cNvPr id="1420274482" name="Image 3" descr="preencoded.png"/>
           <p:cNvPicPr>
             <a:picLocks noChangeAspect="1"/>
           </p:cNvPicPr>
@@ -10482,7 +9543,7 @@
       </p:pic>
       <p:sp>
         <p:nvSpPr>
-          <p:cNvPr id="1183811142" name="Text 6"/>
+          <p:cNvPr id="1560666553" name="Text 6"/>
           <p:cNvSpPr txBox="1"/>
           <p:nvPr/>
         </p:nvSpPr>
@@ -10510,7 +9571,7 @@
       </p:sp>
       <p:sp>
         <p:nvSpPr>
-          <p:cNvPr id="1536834278" name="Text 7"/>
+          <p:cNvPr id="1263192709" name="Text 7"/>
           <p:cNvSpPr txBox="1"/>
           <p:nvPr/>
         </p:nvSpPr>
@@ -10552,7 +9613,7 @@
       </p:sp>
       <p:sp>
         <p:nvSpPr>
-          <p:cNvPr id="1945789804" name="Text 8"/>
+          <p:cNvPr id="1238906179" name="Text 8"/>
           <p:cNvSpPr txBox="1"/>
           <p:nvPr/>
         </p:nvSpPr>
@@ -10596,7 +9657,7 @@
       </p:sp>
       <p:pic>
         <p:nvPicPr>
-          <p:cNvPr id="1206772175" name="Image 4" descr="preencoded.png"/>
+          <p:cNvPr id="1913504932" name="Image 4" descr="preencoded.png"/>
           <p:cNvPicPr>
             <a:picLocks noChangeAspect="1"/>
           </p:cNvPicPr>
@@ -10618,7 +9679,7 @@
       </p:pic>
       <p:sp>
         <p:nvSpPr>
-          <p:cNvPr id="1433773012" name="Text 9"/>
+          <p:cNvPr id="807487019" name="Text 9"/>
           <p:cNvSpPr txBox="1"/>
           <p:nvPr/>
         </p:nvSpPr>
@@ -10660,7 +9721,7 @@
       </p:sp>
       <p:pic>
         <p:nvPicPr>
-          <p:cNvPr id="492283147" name="Image 5" descr="preencoded.png"/>
+          <p:cNvPr id="1624832017" name="Image 5" descr="preencoded.png"/>
           <p:cNvPicPr>
             <a:picLocks noChangeAspect="1"/>
           </p:cNvPicPr>
@@ -10682,7 +9743,7 @@
       </p:pic>
       <p:sp>
         <p:nvSpPr>
-          <p:cNvPr id="735499588" name="Text 10"/>
+          <p:cNvPr id="1972046748" name="Text 10"/>
           <p:cNvSpPr txBox="1"/>
           <p:nvPr/>
         </p:nvSpPr>
@@ -10710,7 +9771,7 @@
       </p:sp>
       <p:sp>
         <p:nvSpPr>
-          <p:cNvPr id="1719957357" name="Text 11"/>
+          <p:cNvPr id="1747709864" name="Text 11"/>
           <p:cNvSpPr txBox="1"/>
           <p:nvPr/>
         </p:nvSpPr>
@@ -10752,7 +9813,7 @@
       </p:sp>
       <p:sp>
         <p:nvSpPr>
-          <p:cNvPr id="884114807" name="Text 12"/>
+          <p:cNvPr id="1712235193" name="Text 12"/>
           <p:cNvSpPr txBox="1"/>
           <p:nvPr/>
         </p:nvSpPr>
@@ -10796,7 +9857,7 @@
       </p:sp>
       <p:pic>
         <p:nvPicPr>
-          <p:cNvPr id="23211872" name="Image 6" descr="preencoded.png"/>
+          <p:cNvPr id="1307058614" name="Image 6" descr="preencoded.png"/>
           <p:cNvPicPr>
             <a:picLocks noChangeAspect="1"/>
           </p:cNvPicPr>
@@ -10818,7 +9879,7 @@
       </p:pic>
       <p:sp>
         <p:nvSpPr>
-          <p:cNvPr id="1146773503" name="Text 13"/>
+          <p:cNvPr id="1719685414" name="Text 13"/>
           <p:cNvSpPr txBox="1"/>
           <p:nvPr/>
         </p:nvSpPr>
@@ -10860,7 +9921,7 @@
       </p:sp>
       <p:sp>
         <p:nvSpPr>
-          <p:cNvPr id="485182218" name="Text 14"/>
+          <p:cNvPr id="582225783" name="Text 14"/>
           <p:cNvSpPr txBox="1"/>
           <p:nvPr/>
         </p:nvSpPr>
@@ -10907,7 +9968,7 @@
       </p:sp>
       <p:sp>
         <p:nvSpPr>
-          <p:cNvPr id="1909728903" name="Text 15"/>
+          <p:cNvPr id="1590630269" name="Text 15"/>
           <p:cNvSpPr txBox="1"/>
           <p:nvPr/>
         </p:nvSpPr>
@@ -10949,7 +10010,7 @@
       </p:sp>
       <p:pic>
         <p:nvPicPr>
-          <p:cNvPr id="477022940" name="Image 7" descr="preencoded.png"/>
+          <p:cNvPr id="1764038894" name="Image 7" descr="preencoded.png"/>
           <p:cNvPicPr>
             <a:picLocks noChangeAspect="1"/>
           </p:cNvPicPr>
@@ -10971,7 +10032,7 @@
       </p:pic>
       <p:sp>
         <p:nvSpPr>
-          <p:cNvPr id="1986270140" name="Text 16"/>
+          <p:cNvPr id="1706779065" name="Text 16"/>
           <p:cNvSpPr txBox="1"/>
           <p:nvPr/>
         </p:nvSpPr>
@@ -11013,7 +10074,7 @@
       </p:sp>
       <p:sp>
         <p:nvSpPr>
-          <p:cNvPr id="141099905" name="Text 17"/>
+          <p:cNvPr id="2013936168" name="Text 17"/>
           <p:cNvSpPr txBox="1"/>
           <p:nvPr/>
         </p:nvSpPr>
@@ -11060,7 +10121,7 @@
       </p:sp>
       <p:sp>
         <p:nvSpPr>
-          <p:cNvPr id="1411995807" name="Text 18"/>
+          <p:cNvPr id="575578270" name="Text 18"/>
           <p:cNvSpPr txBox="1"/>
           <p:nvPr/>
         </p:nvSpPr>
@@ -11147,7 +10208,7 @@
                                           </p:stCondLst>
                                         </p:cTn>
                                         <p:tgtEl>
-                                          <p:spTgt spid="1543916807"/>
+                                          <p:spTgt spid="979381432"/>
                                         </p:tgtEl>
                                         <p:attrNameLst>
                                           <p:attrName>style.visibility</p:attrName>
@@ -11174,7 +10235,7 @@
                                           </p:stCondLst>
                                         </p:cTn>
                                         <p:tgtEl>
-                                          <p:spTgt spid="858479948"/>
+                                          <p:spTgt spid="326770957"/>
                                         </p:tgtEl>
                                         <p:attrNameLst>
                                           <p:attrName>style.visibility</p:attrName>
@@ -11201,7 +10262,7 @@
                                           </p:stCondLst>
                                         </p:cTn>
                                         <p:tgtEl>
-                                          <p:spTgt spid="1891449163"/>
+                                          <p:spTgt spid="596839610"/>
                                         </p:tgtEl>
                                         <p:attrNameLst>
                                           <p:attrName>style.visibility</p:attrName>
@@ -11228,7 +10289,7 @@
                                           </p:stCondLst>
                                         </p:cTn>
                                         <p:tgtEl>
-                                          <p:spTgt spid="637304334"/>
+                                          <p:spTgt spid="1363909735"/>
                                         </p:tgtEl>
                                         <p:attrNameLst>
                                           <p:attrName>style.visibility</p:attrName>
@@ -11255,7 +10316,7 @@
                                           </p:stCondLst>
                                         </p:cTn>
                                         <p:tgtEl>
-                                          <p:spTgt spid="1792570015"/>
+                                          <p:spTgt spid="368359771"/>
                                         </p:tgtEl>
                                         <p:attrNameLst>
                                           <p:attrName>style.visibility</p:attrName>
@@ -11282,7 +10343,7 @@
                                           </p:stCondLst>
                                         </p:cTn>
                                         <p:tgtEl>
-                                          <p:spTgt spid="1240464779"/>
+                                          <p:spTgt spid="919300530"/>
                                         </p:tgtEl>
                                         <p:attrNameLst>
                                           <p:attrName>style.visibility</p:attrName>
@@ -11327,7 +10388,7 @@
                                           </p:stCondLst>
                                         </p:cTn>
                                         <p:tgtEl>
-                                          <p:spTgt spid="297698753"/>
+                                          <p:spTgt spid="1316328044"/>
                                         </p:tgtEl>
                                         <p:attrNameLst>
                                           <p:attrName>style.visibility</p:attrName>
@@ -11354,7 +10415,7 @@
                                           </p:stCondLst>
                                         </p:cTn>
                                         <p:tgtEl>
-                                          <p:spTgt spid="71383884"/>
+                                          <p:spTgt spid="92407645"/>
                                         </p:tgtEl>
                                         <p:attrNameLst>
                                           <p:attrName>style.visibility</p:attrName>
@@ -11381,7 +10442,7 @@
                                           </p:stCondLst>
                                         </p:cTn>
                                         <p:tgtEl>
-                                          <p:spTgt spid="1403642998"/>
+                                          <p:spTgt spid="1420274482"/>
                                         </p:tgtEl>
                                         <p:attrNameLst>
                                           <p:attrName>style.visibility</p:attrName>
@@ -11408,7 +10469,7 @@
                                           </p:stCondLst>
                                         </p:cTn>
                                         <p:tgtEl>
-                                          <p:spTgt spid="1183811142"/>
+                                          <p:spTgt spid="1560666553"/>
                                         </p:tgtEl>
                                         <p:attrNameLst>
                                           <p:attrName>style.visibility</p:attrName>
@@ -11435,7 +10496,7 @@
                                           </p:stCondLst>
                                         </p:cTn>
                                         <p:tgtEl>
-                                          <p:spTgt spid="1536834278"/>
+                                          <p:spTgt spid="1263192709"/>
                                         </p:tgtEl>
                                         <p:attrNameLst>
                                           <p:attrName>style.visibility</p:attrName>
@@ -11462,7 +10523,7 @@
                                           </p:stCondLst>
                                         </p:cTn>
                                         <p:tgtEl>
-                                          <p:spTgt spid="1945789804"/>
+                                          <p:spTgt spid="1238906179"/>
                                         </p:tgtEl>
                                         <p:attrNameLst>
                                           <p:attrName>style.visibility</p:attrName>
@@ -11507,7 +10568,7 @@
                                           </p:stCondLst>
                                         </p:cTn>
                                         <p:tgtEl>
-                                          <p:spTgt spid="1206772175"/>
+                                          <p:spTgt spid="1913504932"/>
                                         </p:tgtEl>
                                         <p:attrNameLst>
                                           <p:attrName>style.visibility</p:attrName>
@@ -11534,7 +10595,7 @@
                                           </p:stCondLst>
                                         </p:cTn>
                                         <p:tgtEl>
-                                          <p:spTgt spid="1433773012"/>
+                                          <p:spTgt spid="807487019"/>
                                         </p:tgtEl>
                                         <p:attrNameLst>
                                           <p:attrName>style.visibility</p:attrName>
@@ -11561,7 +10622,7 @@
                                           </p:stCondLst>
                                         </p:cTn>
                                         <p:tgtEl>
-                                          <p:spTgt spid="492283147"/>
+                                          <p:spTgt spid="1624832017"/>
                                         </p:tgtEl>
                                         <p:attrNameLst>
                                           <p:attrName>style.visibility</p:attrName>
@@ -11588,7 +10649,7 @@
                                           </p:stCondLst>
                                         </p:cTn>
                                         <p:tgtEl>
-                                          <p:spTgt spid="735499588"/>
+                                          <p:spTgt spid="1972046748"/>
                                         </p:tgtEl>
                                         <p:attrNameLst>
                                           <p:attrName>style.visibility</p:attrName>
@@ -11615,7 +10676,7 @@
                                           </p:stCondLst>
                                         </p:cTn>
                                         <p:tgtEl>
-                                          <p:spTgt spid="1719957357"/>
+                                          <p:spTgt spid="1747709864"/>
                                         </p:tgtEl>
                                         <p:attrNameLst>
                                           <p:attrName>style.visibility</p:attrName>
@@ -11642,7 +10703,7 @@
                                           </p:stCondLst>
                                         </p:cTn>
                                         <p:tgtEl>
-                                          <p:spTgt spid="884114807"/>
+                                          <p:spTgt spid="1712235193"/>
                                         </p:tgtEl>
                                         <p:attrNameLst>
                                           <p:attrName>style.visibility</p:attrName>
@@ -11687,7 +10748,7 @@
                                           </p:stCondLst>
                                         </p:cTn>
                                         <p:tgtEl>
-                                          <p:spTgt spid="23211872"/>
+                                          <p:spTgt spid="1307058614"/>
                                         </p:tgtEl>
                                         <p:attrNameLst>
                                           <p:attrName>style.visibility</p:attrName>
@@ -11714,7 +10775,7 @@
                                           </p:stCondLst>
                                         </p:cTn>
                                         <p:tgtEl>
-                                          <p:spTgt spid="1146773503"/>
+                                          <p:spTgt spid="1719685414"/>
                                         </p:tgtEl>
                                         <p:attrNameLst>
                                           <p:attrName>style.visibility</p:attrName>
@@ -11741,7 +10802,7 @@
                                           </p:stCondLst>
                                         </p:cTn>
                                         <p:tgtEl>
-                                          <p:spTgt spid="485182218"/>
+                                          <p:spTgt spid="582225783"/>
                                         </p:tgtEl>
                                         <p:attrNameLst>
                                           <p:attrName>style.visibility</p:attrName>
@@ -11768,7 +10829,7 @@
                                           </p:stCondLst>
                                         </p:cTn>
                                         <p:tgtEl>
-                                          <p:spTgt spid="1909728903"/>
+                                          <p:spTgt spid="1590630269"/>
                                         </p:tgtEl>
                                         <p:attrNameLst>
                                           <p:attrName>style.visibility</p:attrName>
@@ -11795,7 +10856,7 @@
                                           </p:stCondLst>
                                         </p:cTn>
                                         <p:tgtEl>
-                                          <p:spTgt spid="477022940"/>
+                                          <p:spTgt spid="1764038894"/>
                                         </p:tgtEl>
                                         <p:attrNameLst>
                                           <p:attrName>style.visibility</p:attrName>
@@ -11822,7 +10883,7 @@
                                           </p:stCondLst>
                                         </p:cTn>
                                         <p:tgtEl>
-                                          <p:spTgt spid="1986270140"/>
+                                          <p:spTgt spid="1706779065"/>
                                         </p:tgtEl>
                                         <p:attrNameLst>
                                           <p:attrName>style.visibility</p:attrName>
@@ -11849,7 +10910,7 @@
                                           </p:stCondLst>
                                         </p:cTn>
                                         <p:tgtEl>
-                                          <p:spTgt spid="141099905"/>
+                                          <p:spTgt spid="2013936168"/>
                                         </p:tgtEl>
                                         <p:attrNameLst>
                                           <p:attrName>style.visibility</p:attrName>
@@ -11876,7 +10937,7 @@
                                           </p:stCondLst>
                                         </p:cTn>
                                         <p:tgtEl>
-                                          <p:spTgt spid="1411995807"/>
+                                          <p:spTgt spid="575578270"/>
                                         </p:tgtEl>
                                         <p:attrNameLst>
                                           <p:attrName>style.visibility</p:attrName>
@@ -11946,7 +11007,7 @@
       </p:grpSpPr>
       <p:sp>
         <p:nvSpPr>
-          <p:cNvPr id="445825198" name="Text 0"/>
+          <p:cNvPr id="2136871832" name="Text 0"/>
           <p:cNvSpPr txBox="1"/>
           <p:nvPr/>
         </p:nvSpPr>
@@ -12018,7 +11079,7 @@
       </p:sp>
       <p:pic>
         <p:nvPicPr>
-          <p:cNvPr id="361754413" name="Image 0" descr="preencoded.png"/>
+          <p:cNvPr id="1075474342" name="Image 0" descr="preencoded.png"/>
           <p:cNvPicPr>
             <a:picLocks noChangeAspect="1"/>
           </p:cNvPicPr>
@@ -12040,7 +11101,7 @@
       </p:pic>
       <p:sp>
         <p:nvSpPr>
-          <p:cNvPr id="1040412438" name="Text 2"/>
+          <p:cNvPr id="26526107" name="Text 2"/>
           <p:cNvSpPr txBox="1"/>
           <p:nvPr/>
         </p:nvSpPr>
@@ -12071,7 +11132,7 @@
       </p:sp>
       <p:sp>
         <p:nvSpPr>
-          <p:cNvPr id="649528534" name="Text 3"/>
+          <p:cNvPr id="816871329" name="Text 3"/>
           <p:cNvSpPr txBox="1"/>
           <p:nvPr/>
         </p:nvSpPr>
@@ -12113,7 +11174,7 @@
       </p:sp>
       <p:sp>
         <p:nvSpPr>
-          <p:cNvPr id="1194266509" name="Text 4"/>
+          <p:cNvPr id="977759669" name="Text 4"/>
           <p:cNvSpPr txBox="1"/>
           <p:nvPr/>
         </p:nvSpPr>
@@ -12155,7 +11216,7 @@
       </p:sp>
       <p:pic>
         <p:nvPicPr>
-          <p:cNvPr id="1817035683" name="Image 1" descr="preencoded.png"/>
+          <p:cNvPr id="936647056" name="Image 1" descr="preencoded.png"/>
           <p:cNvPicPr>
             <a:picLocks noChangeAspect="1"/>
           </p:cNvPicPr>
@@ -12177,7 +11238,7 @@
       </p:pic>
       <p:sp>
         <p:nvSpPr>
-          <p:cNvPr id="1397256461" name="Text 5"/>
+          <p:cNvPr id="478895840" name="Text 5"/>
           <p:cNvSpPr txBox="1"/>
           <p:nvPr/>
         </p:nvSpPr>
@@ -12222,7 +11283,7 @@
       </p:sp>
       <p:pic>
         <p:nvPicPr>
-          <p:cNvPr id="1520732368" name="Image 2" descr="preencoded.png"/>
+          <p:cNvPr id="1797532350" name="Image 2" descr="preencoded.png"/>
           <p:cNvPicPr>
             <a:picLocks noChangeAspect="1"/>
           </p:cNvPicPr>
@@ -12244,7 +11305,7 @@
       </p:pic>
       <p:sp>
         <p:nvSpPr>
-          <p:cNvPr id="500532001" name="Text 6"/>
+          <p:cNvPr id="580312074" name="Text 6"/>
           <p:cNvSpPr txBox="1"/>
           <p:nvPr/>
         </p:nvSpPr>
@@ -12291,7 +11352,7 @@
       </p:sp>
       <p:pic>
         <p:nvPicPr>
-          <p:cNvPr id="514711915" name="Image 3" descr="preencoded.png"/>
+          <p:cNvPr id="1807719784" name="Image 3" descr="preencoded.png"/>
           <p:cNvPicPr>
             <a:picLocks noChangeAspect="1"/>
           </p:cNvPicPr>
@@ -12313,7 +11374,7 @@
       </p:pic>
       <p:sp>
         <p:nvSpPr>
-          <p:cNvPr id="1425410041" name="Text 7"/>
+          <p:cNvPr id="1713899862" name="Text 7"/>
           <p:cNvSpPr txBox="1"/>
           <p:nvPr/>
         </p:nvSpPr>
@@ -12360,7 +11421,7 @@
       </p:sp>
       <p:pic>
         <p:nvPicPr>
-          <p:cNvPr id="722927030" name="Image 4" descr="preencoded.png"/>
+          <p:cNvPr id="1064893479" name="Image 4" descr="preencoded.png"/>
           <p:cNvPicPr>
             <a:picLocks noChangeAspect="1"/>
           </p:cNvPicPr>
@@ -12382,7 +11443,7 @@
       </p:pic>
       <p:sp>
         <p:nvSpPr>
-          <p:cNvPr id="1466490633" name="Text 9"/>
+          <p:cNvPr id="810308880" name="Text 9"/>
           <p:cNvSpPr txBox="1"/>
           <p:nvPr/>
         </p:nvSpPr>
@@ -12413,7 +11474,7 @@
       </p:sp>
       <p:sp>
         <p:nvSpPr>
-          <p:cNvPr id="2002263251" name="Text 10"/>
+          <p:cNvPr id="1914947146" name="Text 10"/>
           <p:cNvSpPr txBox="1"/>
           <p:nvPr/>
         </p:nvSpPr>
@@ -12455,7 +11516,7 @@
       </p:sp>
       <p:sp>
         <p:nvSpPr>
-          <p:cNvPr id="81171020" name="Text 11"/>
+          <p:cNvPr id="44036681" name="Text 11"/>
           <p:cNvSpPr txBox="1"/>
           <p:nvPr/>
         </p:nvSpPr>
@@ -12497,7 +11558,7 @@
       </p:sp>
       <p:pic>
         <p:nvPicPr>
-          <p:cNvPr id="151770486" name="Image 5" descr="preencoded.png"/>
+          <p:cNvPr id="1087769720" name="Image 5" descr="preencoded.png"/>
           <p:cNvPicPr>
             <a:picLocks noChangeAspect="1"/>
           </p:cNvPicPr>
@@ -12519,7 +11580,7 @@
       </p:pic>
       <p:sp>
         <p:nvSpPr>
-          <p:cNvPr id="2091585077" name="Text 12"/>
+          <p:cNvPr id="1657159946" name="Text 12"/>
           <p:cNvSpPr txBox="1"/>
           <p:nvPr/>
         </p:nvSpPr>
@@ -12564,7 +11625,7 @@
       </p:sp>
       <p:pic>
         <p:nvPicPr>
-          <p:cNvPr id="1919678969" name="Image 6" descr="preencoded.png"/>
+          <p:cNvPr id="113345228" name="Image 6" descr="preencoded.png"/>
           <p:cNvPicPr>
             <a:picLocks noChangeAspect="1"/>
           </p:cNvPicPr>
@@ -12586,7 +11647,7 @@
       </p:pic>
       <p:sp>
         <p:nvSpPr>
-          <p:cNvPr id="1987009862" name="Text 13"/>
+          <p:cNvPr id="1043235397" name="Text 13"/>
           <p:cNvSpPr txBox="1"/>
           <p:nvPr/>
         </p:nvSpPr>
@@ -12633,7 +11694,7 @@
       </p:sp>
       <p:pic>
         <p:nvPicPr>
-          <p:cNvPr id="1981103467" name="Image 7" descr="preencoded.png"/>
+          <p:cNvPr id="764771249" name="Image 7" descr="preencoded.png"/>
           <p:cNvPicPr>
             <a:picLocks noChangeAspect="1"/>
           </p:cNvPicPr>
@@ -12655,7 +11716,7 @@
       </p:pic>
       <p:sp>
         <p:nvSpPr>
-          <p:cNvPr id="1589094451" name="Text 14"/>
+          <p:cNvPr id="1712815698" name="Text 14"/>
           <p:cNvSpPr txBox="1"/>
           <p:nvPr/>
         </p:nvSpPr>
@@ -12702,7 +11763,7 @@
       </p:sp>
       <p:pic>
         <p:nvPicPr>
-          <p:cNvPr id="65055049" name="Image 8" descr="preencoded.png"/>
+          <p:cNvPr id="1198943088" name="Image 8" descr="preencoded.png"/>
           <p:cNvPicPr>
             <a:picLocks noChangeAspect="1"/>
           </p:cNvPicPr>
@@ -12724,7 +11785,7 @@
       </p:pic>
       <p:sp>
         <p:nvSpPr>
-          <p:cNvPr id="1749201060" name="Text 16"/>
+          <p:cNvPr id="115525602" name="Text 16"/>
           <p:cNvSpPr txBox="1"/>
           <p:nvPr/>
         </p:nvSpPr>
@@ -12755,7 +11816,7 @@
       </p:sp>
       <p:sp>
         <p:nvSpPr>
-          <p:cNvPr id="2053522613" name="Text 17"/>
+          <p:cNvPr id="695694169" name="Text 17"/>
           <p:cNvSpPr txBox="1"/>
           <p:nvPr/>
         </p:nvSpPr>
@@ -12797,7 +11858,7 @@
       </p:sp>
       <p:sp>
         <p:nvSpPr>
-          <p:cNvPr id="65159843" name="Text 18"/>
+          <p:cNvPr id="1969927187" name="Text 18"/>
           <p:cNvSpPr txBox="1"/>
           <p:nvPr/>
         </p:nvSpPr>
@@ -12839,7 +11900,7 @@
       </p:sp>
       <p:pic>
         <p:nvPicPr>
-          <p:cNvPr id="625828764" name="Image 9" descr="preencoded.png"/>
+          <p:cNvPr id="1306629936" name="Image 9" descr="preencoded.png"/>
           <p:cNvPicPr>
             <a:picLocks noChangeAspect="1"/>
           </p:cNvPicPr>
@@ -12861,7 +11922,7 @@
       </p:pic>
       <p:sp>
         <p:nvSpPr>
-          <p:cNvPr id="1647497232" name="Text 19"/>
+          <p:cNvPr id="1161040434" name="Text 19"/>
           <p:cNvSpPr txBox="1"/>
           <p:nvPr/>
         </p:nvSpPr>
@@ -12906,7 +11967,7 @@
       </p:sp>
       <p:pic>
         <p:nvPicPr>
-          <p:cNvPr id="955157546" name="Image 10" descr="preencoded.png"/>
+          <p:cNvPr id="105070194" name="Image 10" descr="preencoded.png"/>
           <p:cNvPicPr>
             <a:picLocks noChangeAspect="1"/>
           </p:cNvPicPr>
@@ -12928,7 +11989,7 @@
       </p:pic>
       <p:sp>
         <p:nvSpPr>
-          <p:cNvPr id="917561258" name="Text 20"/>
+          <p:cNvPr id="1320326366" name="Text 20"/>
           <p:cNvSpPr txBox="1"/>
           <p:nvPr/>
         </p:nvSpPr>
@@ -12975,7 +12036,7 @@
       </p:sp>
       <p:pic>
         <p:nvPicPr>
-          <p:cNvPr id="1463433352" name="Image 11" descr="preencoded.png"/>
+          <p:cNvPr id="455312871" name="Image 11" descr="preencoded.png"/>
           <p:cNvPicPr>
             <a:picLocks noChangeAspect="1"/>
           </p:cNvPicPr>
@@ -12997,7 +12058,7 @@
       </p:pic>
       <p:sp>
         <p:nvSpPr>
-          <p:cNvPr id="596875129" name="Text 21"/>
+          <p:cNvPr id="324735801" name="Text 21"/>
           <p:cNvSpPr txBox="1"/>
           <p:nvPr/>
         </p:nvSpPr>
@@ -13044,7 +12105,7 @@
       </p:sp>
       <p:pic>
         <p:nvPicPr>
-          <p:cNvPr id="1142490640" name="Image 12" descr="preencoded.png"/>
+          <p:cNvPr id="238481870" name="Image 12" descr="preencoded.png"/>
           <p:cNvPicPr>
             <a:picLocks noChangeAspect="1"/>
           </p:cNvPicPr>
@@ -13066,7 +12127,7 @@
       </p:pic>
       <p:sp>
         <p:nvSpPr>
-          <p:cNvPr id="628479833" name="Text 23"/>
+          <p:cNvPr id="1219969698" name="Text 23"/>
           <p:cNvSpPr txBox="1"/>
           <p:nvPr/>
         </p:nvSpPr>
@@ -13097,7 +12158,7 @@
       </p:sp>
       <p:sp>
         <p:nvSpPr>
-          <p:cNvPr id="413923493" name="Text 24"/>
+          <p:cNvPr id="11966363" name="Text 24"/>
           <p:cNvSpPr txBox="1"/>
           <p:nvPr/>
         </p:nvSpPr>
@@ -13139,7 +12200,7 @@
       </p:sp>
       <p:sp>
         <p:nvSpPr>
-          <p:cNvPr id="745095010" name="Text 25"/>
+          <p:cNvPr id="1630022752" name="Text 25"/>
           <p:cNvSpPr txBox="1"/>
           <p:nvPr/>
         </p:nvSpPr>
@@ -13192,7 +12253,7 @@
       </p:sp>
       <p:pic>
         <p:nvPicPr>
-          <p:cNvPr id="638261627" name="Image 13" descr="preencoded.png"/>
+          <p:cNvPr id="1891621727" name="Image 13" descr="preencoded.png"/>
           <p:cNvPicPr>
             <a:picLocks noChangeAspect="1"/>
           </p:cNvPicPr>
@@ -13214,7 +12275,7 @@
       </p:pic>
       <p:sp>
         <p:nvSpPr>
-          <p:cNvPr id="963069155" name="Text 26"/>
+          <p:cNvPr id="866054233" name="Text 26"/>
           <p:cNvSpPr txBox="1"/>
           <p:nvPr/>
         </p:nvSpPr>
@@ -13259,7 +12320,7 @@
       </p:sp>
       <p:pic>
         <p:nvPicPr>
-          <p:cNvPr id="1538295841" name="Image 14" descr="preencoded.png"/>
+          <p:cNvPr id="1078283848" name="Image 14" descr="preencoded.png"/>
           <p:cNvPicPr>
             <a:picLocks noChangeAspect="1"/>
           </p:cNvPicPr>
@@ -13281,7 +12342,7 @@
       </p:pic>
       <p:sp>
         <p:nvSpPr>
-          <p:cNvPr id="54239043" name="Text 27"/>
+          <p:cNvPr id="1367011934" name="Text 27"/>
           <p:cNvSpPr txBox="1"/>
           <p:nvPr/>
         </p:nvSpPr>
@@ -13328,7 +12389,7 @@
       </p:sp>
       <p:pic>
         <p:nvPicPr>
-          <p:cNvPr id="938457394" name="Image 15" descr="preencoded.png"/>
+          <p:cNvPr id="1932352018" name="Image 15" descr="preencoded.png"/>
           <p:cNvPicPr>
             <a:picLocks noChangeAspect="1"/>
           </p:cNvPicPr>
@@ -13350,7 +12411,7 @@
       </p:pic>
       <p:sp>
         <p:nvSpPr>
-          <p:cNvPr id="1761729143" name="Text 28"/>
+          <p:cNvPr id="1750599974" name="Text 28"/>
           <p:cNvSpPr txBox="1"/>
           <p:nvPr/>
         </p:nvSpPr>
@@ -13397,7 +12458,7 @@
       </p:sp>
       <p:pic>
         <p:nvPicPr>
-          <p:cNvPr id="834739752" name="Image 16" descr="preencoded.png"/>
+          <p:cNvPr id="1709940449" name="Image 16" descr="preencoded.png"/>
           <p:cNvPicPr>
             <a:picLocks noChangeAspect="1"/>
           </p:cNvPicPr>
@@ -13419,7 +12480,7 @@
       </p:pic>
       <p:sp>
         <p:nvSpPr>
-          <p:cNvPr id="1492409162" name="Shape 30"/>
+          <p:cNvPr id="1198387449" name="Shape 30"/>
           <p:cNvSpPr/>
           <p:nvPr/>
         </p:nvSpPr>
@@ -13441,7 +12502,7 @@
       </p:sp>
       <p:sp>
         <p:nvSpPr>
-          <p:cNvPr id="73635071" name="Text 31"/>
+          <p:cNvPr id="904108213" name="Text 31"/>
           <p:cNvSpPr txBox="1"/>
           <p:nvPr/>
         </p:nvSpPr>
@@ -13595,7 +12656,7 @@
         <p:spPr bwMode="auto">
           <a:xfrm>
             <a:off x="676869" y="4913863"/>
-            <a:ext cx="5133974" cy="147637"/>
+            <a:ext cx="1385748" cy="164197"/>
           </a:xfrm>
           <a:prstGeom prst="rect">
             <a:avLst/>
@@ -13614,7 +12675,7 @@
               <a:defRPr/>
             </a:pPr>
             <a:r>
-              <a:rPr lang="en-US" sz="850">
+              <a:rPr lang="de-DE" sz="850">
                 <a:solidFill>
                   <a:srgbClr val="67F4E2"/>
                 </a:solidFill>
@@ -13622,7 +12683,62 @@
                 <a:ea typeface="JetBrains Mono"/>
                 <a:cs typeface="JetBrains Mono"/>
               </a:rPr>
-              <a:t>request_count • Sum &lt;1 • 300s period • missing data BREACHING</a:t>
+              <a:t>threshold </a:t>
+            </a:r>
+            <a:r>
+              <a:rPr lang="de-DE" sz="850">
+                <a:solidFill>
+                  <a:srgbClr val="67F4E2"/>
+                </a:solidFill>
+                <a:latin typeface="JetBrains Mono"/>
+                <a:ea typeface="JetBrains Mono"/>
+                <a:cs typeface="JetBrains Mono"/>
+              </a:rPr>
+              <a:t>&gt;</a:t>
+            </a:r>
+            <a:r>
+              <a:rPr lang="de-DE" sz="850">
+                <a:solidFill>
+                  <a:srgbClr val="67F4E2"/>
+                </a:solidFill>
+                <a:latin typeface="JetBrains Mono"/>
+                <a:ea typeface="JetBrains Mono"/>
+                <a:cs typeface="JetBrains Mono"/>
+              </a:rPr>
+              <a:t> 40%</a:t>
+            </a:r>
+            <a:r>
+              <a:rPr lang="en-US" sz="850">
+                <a:solidFill>
+                  <a:srgbClr val="67F4E2"/>
+                </a:solidFill>
+                <a:latin typeface="JetBrains Mono"/>
+                <a:ea typeface="JetBrains Mono"/>
+                <a:cs typeface="JetBrains Mono"/>
+              </a:rPr>
+              <a:t> • </a:t>
+            </a:r>
+            <a:r>
+              <a:rPr lang="de-DE" sz="850">
+                <a:solidFill>
+                  <a:srgbClr val="67F4E2"/>
+                </a:solidFill>
+                <a:latin typeface="JetBrains Mono"/>
+                <a:ea typeface="JetBrains Mono"/>
+                <a:cs typeface="JetBrains Mono"/>
+              </a:rPr>
+              <a:t>6</a:t>
+            </a:r>
+            <a:r>
+              <a:rPr lang="en-US" sz="850">
+                <a:solidFill>
+                  <a:srgbClr val="67F4E2"/>
+                </a:solidFill>
+                <a:latin typeface="JetBrains Mono"/>
+                <a:ea typeface="JetBrains Mono"/>
+                <a:cs typeface="JetBrains Mono"/>
+              </a:rPr>
+              <a:t>0s period</a:t>
             </a:r>
             <a:endParaRPr lang="en-US" sz="850"/>
           </a:p>
@@ -14217,7 +13333,7 @@
       </p:grpSpPr>
       <p:sp>
         <p:nvSpPr>
-          <p:cNvPr id="1282114511" name="Text 0"/>
+          <p:cNvPr id="936807333" name="Text 0"/>
           <p:cNvSpPr txBox="1"/>
           <p:nvPr/>
         </p:nvSpPr>
@@ -14259,7 +13375,7 @@
       </p:sp>
       <p:sp>
         <p:nvSpPr>
-          <p:cNvPr id="1558648001" name="Text 3"/>
+          <p:cNvPr id="788617509" name="Text 3"/>
           <p:cNvSpPr txBox="1"/>
           <p:nvPr/>
         </p:nvSpPr>
@@ -14290,7 +13406,7 @@
       </p:sp>
       <p:sp>
         <p:nvSpPr>
-          <p:cNvPr id="784387038" name="Text 8"/>
+          <p:cNvPr id="1574410936" name="Text 8"/>
           <p:cNvSpPr txBox="1"/>
           <p:nvPr/>
         </p:nvSpPr>
@@ -14332,7 +13448,7 @@
       </p:sp>
       <p:pic>
         <p:nvPicPr>
-          <p:cNvPr id="1700652519" name="Image 1" descr="preencoded.png"/>
+          <p:cNvPr id="878281620" name="Image 1" descr="preencoded.png"/>
           <p:cNvPicPr>
             <a:picLocks noChangeAspect="1"/>
           </p:cNvPicPr>
@@ -14354,7 +13470,7 @@
       </p:pic>
       <p:sp>
         <p:nvSpPr>
-          <p:cNvPr id="677585808" name="Text 9"/>
+          <p:cNvPr id="2038570679" name="Text 9"/>
           <p:cNvSpPr txBox="1"/>
           <p:nvPr/>
         </p:nvSpPr>
@@ -14828,7 +13944,7 @@
                                           </p:stCondLst>
                                         </p:cTn>
                                         <p:tgtEl>
-                                          <p:spTgt spid="784387038"/>
+                                          <p:spTgt spid="1574410936"/>
                                         </p:tgtEl>
                                         <p:attrNameLst>
                                           <p:attrName>style.visibility</p:attrName>
@@ -14855,7 +13971,7 @@
                                           </p:stCondLst>
                                         </p:cTn>
                                         <p:tgtEl>
-                                          <p:spTgt spid="1700652519"/>
+                                          <p:spTgt spid="878281620"/>
                                         </p:tgtEl>
                                         <p:attrNameLst>
                                           <p:attrName>style.visibility</p:attrName>
@@ -14882,7 +13998,7 @@
                                           </p:stCondLst>
                                         </p:cTn>
                                         <p:tgtEl>
-                                          <p:spTgt spid="677585808"/>
+                                          <p:spTgt spid="2038570679"/>
                                         </p:tgtEl>
                                         <p:attrNameLst>
                                           <p:attrName>style.visibility</p:attrName>
@@ -14952,7 +14068,7 @@
       </p:grpSpPr>
       <p:sp>
         <p:nvSpPr>
-          <p:cNvPr id="244259589" name="Text 0"/>
+          <p:cNvPr id="1728232356" name="Text 0"/>
           <p:cNvSpPr txBox="1"/>
           <p:nvPr/>
         </p:nvSpPr>
@@ -15005,7 +14121,7 @@
       </p:sp>
       <p:pic>
         <p:nvPicPr>
-          <p:cNvPr id="951293022" name="Image 0" descr="preencoded.png"/>
+          <p:cNvPr id="836072507" name="Image 0" descr="preencoded.png"/>
           <p:cNvPicPr>
             <a:picLocks noChangeAspect="1"/>
           </p:cNvPicPr>
@@ -15027,7 +14143,7 @@
       </p:pic>
       <p:sp>
         <p:nvSpPr>
-          <p:cNvPr id="111297844" name="Text 1"/>
+          <p:cNvPr id="1112613856" name="Text 1"/>
           <p:cNvSpPr txBox="1"/>
           <p:nvPr/>
         </p:nvSpPr>
@@ -15069,7 +14185,7 @@
       </p:sp>
       <p:sp>
         <p:nvSpPr>
-          <p:cNvPr id="1234485164" name="Text 2"/>
+          <p:cNvPr id="1390678621" name="Text 2"/>
           <p:cNvSpPr txBox="1"/>
           <p:nvPr/>
         </p:nvSpPr>
@@ -15111,7 +14227,7 @@
       </p:sp>
       <p:pic>
         <p:nvPicPr>
-          <p:cNvPr id="252508751" name="Image 1" descr="preencoded.png"/>
+          <p:cNvPr id="105440149" name="Image 1" descr="preencoded.png"/>
           <p:cNvPicPr>
             <a:picLocks noChangeAspect="1"/>
           </p:cNvPicPr>
@@ -15133,7 +14249,7 @@
       </p:pic>
       <p:sp>
         <p:nvSpPr>
-          <p:cNvPr id="2142934935" name="Text 3"/>
+          <p:cNvPr id="752278344" name="Text 3"/>
           <p:cNvSpPr txBox="1"/>
           <p:nvPr/>
         </p:nvSpPr>
@@ -15175,7 +14291,7 @@
       </p:sp>
       <p:sp>
         <p:nvSpPr>
-          <p:cNvPr id="1653497091" name="Text 4"/>
+          <p:cNvPr id="2068228065" name="Text 4"/>
           <p:cNvSpPr txBox="1"/>
           <p:nvPr/>
         </p:nvSpPr>
@@ -15227,7 +14343,7 @@
       </p:sp>
       <p:pic>
         <p:nvPicPr>
-          <p:cNvPr id="1722882232" name="Image 2" descr="preencoded.png"/>
+          <p:cNvPr id="1768890528" name="Image 2" descr="preencoded.png"/>
           <p:cNvPicPr>
             <a:picLocks noChangeAspect="1"/>
           </p:cNvPicPr>
@@ -15249,7 +14365,7 @@
       </p:pic>
       <p:sp>
         <p:nvSpPr>
-          <p:cNvPr id="1322786675" name="Text 5"/>
+          <p:cNvPr id="1444717829" name="Text 5"/>
           <p:cNvSpPr txBox="1"/>
           <p:nvPr/>
         </p:nvSpPr>
@@ -15291,7 +14407,7 @@
       </p:sp>
       <p:sp>
         <p:nvSpPr>
-          <p:cNvPr id="2069784037" name="Text 6"/>
+          <p:cNvPr id="381750240" name="Text 6"/>
           <p:cNvSpPr txBox="1"/>
           <p:nvPr/>
         </p:nvSpPr>
@@ -15333,7 +14449,7 @@
       </p:sp>
       <p:pic>
         <p:nvPicPr>
-          <p:cNvPr id="404858032" name="Image 3" descr="preencoded.png"/>
+          <p:cNvPr id="1955084236" name="Image 3" descr="preencoded.png"/>
           <p:cNvPicPr>
             <a:picLocks noChangeAspect="1"/>
           </p:cNvPicPr>
@@ -15355,7 +14471,7 @@
       </p:pic>
       <p:sp>
         <p:nvSpPr>
-          <p:cNvPr id="835523337" name="Text 7"/>
+          <p:cNvPr id="1835174767" name="Text 7"/>
           <p:cNvSpPr txBox="1"/>
           <p:nvPr/>
         </p:nvSpPr>
@@ -15418,7 +14534,7 @@
       </p:sp>
       <p:sp>
         <p:nvSpPr>
-          <p:cNvPr id="559933635" name="Text 8"/>
+          <p:cNvPr id="1926333551" name="Text 8"/>
           <p:cNvSpPr txBox="1"/>
           <p:nvPr/>
         </p:nvSpPr>
@@ -15483,7 +14599,7 @@
       </p:sp>
       <p:pic>
         <p:nvPicPr>
-          <p:cNvPr id="92068741" name="Image 4" descr="preencoded.png"/>
+          <p:cNvPr id="769324132" name="Image 4" descr="preencoded.png"/>
           <p:cNvPicPr>
             <a:picLocks noChangeAspect="1"/>
           </p:cNvPicPr>
@@ -15505,7 +14621,7 @@
       </p:pic>
       <p:sp>
         <p:nvSpPr>
-          <p:cNvPr id="69683310" name="Text 9"/>
+          <p:cNvPr id="1156356201" name="Text 9"/>
           <p:cNvSpPr txBox="1"/>
           <p:nvPr/>
         </p:nvSpPr>
@@ -15547,7 +14663,7 @@
       </p:sp>
       <p:sp>
         <p:nvSpPr>
-          <p:cNvPr id="715887746" name="Text 10"/>
+          <p:cNvPr id="674644866" name="Text 10"/>
           <p:cNvSpPr txBox="1"/>
           <p:nvPr/>
         </p:nvSpPr>
@@ -15589,7 +14705,7 @@
       </p:sp>
       <p:pic>
         <p:nvPicPr>
-          <p:cNvPr id="1018417685" name="Image 5" descr="preencoded.png"/>
+          <p:cNvPr id="156902746" name="Image 5" descr="preencoded.png"/>
           <p:cNvPicPr>
             <a:picLocks noChangeAspect="1"/>
           </p:cNvPicPr>
@@ -15611,7 +14727,7 @@
       </p:pic>
       <p:sp>
         <p:nvSpPr>
-          <p:cNvPr id="1938532900" name="Text 11"/>
+          <p:cNvPr id="174499026" name="Text 11"/>
           <p:cNvSpPr txBox="1"/>
           <p:nvPr/>
         </p:nvSpPr>
@@ -15695,7 +14811,7 @@
       </p:sp>
       <p:sp>
         <p:nvSpPr>
-          <p:cNvPr id="1762646398" name="Text 12"/>
+          <p:cNvPr id="885986278" name="Text 12"/>
           <p:cNvSpPr txBox="1"/>
           <p:nvPr/>
         </p:nvSpPr>
@@ -15736,7 +14852,7 @@
       </p:sp>
       <p:pic>
         <p:nvPicPr>
-          <p:cNvPr id="1561852062" name="Image 6" descr="preencoded.png"/>
+          <p:cNvPr id="2143760685" name="Image 6" descr="preencoded.png"/>
           <p:cNvPicPr>
             <a:picLocks noChangeAspect="1"/>
           </p:cNvPicPr>
@@ -15758,7 +14874,7 @@
       </p:pic>
       <p:sp>
         <p:nvSpPr>
-          <p:cNvPr id="8299947" name="Text 13"/>
+          <p:cNvPr id="2010976889" name="Text 13"/>
           <p:cNvSpPr txBox="1"/>
           <p:nvPr/>
         </p:nvSpPr>
@@ -15800,7 +14916,7 @@
       </p:sp>
       <p:sp>
         <p:nvSpPr>
-          <p:cNvPr id="947004339" name="Text 14"/>
+          <p:cNvPr id="940956984" name="Text 14"/>
           <p:cNvSpPr txBox="1"/>
           <p:nvPr/>
         </p:nvSpPr>
@@ -15842,7 +14958,7 @@
       </p:sp>
       <p:sp>
         <p:nvSpPr>
-          <p:cNvPr id="457911166" name="Text 15"/>
+          <p:cNvPr id="447884114" name="Text 15"/>
           <p:cNvSpPr txBox="1"/>
           <p:nvPr/>
         </p:nvSpPr>
@@ -15928,7 +15044,7 @@
                                           </p:stCondLst>
                                         </p:cTn>
                                         <p:tgtEl>
-                                          <p:spTgt spid="951293022"/>
+                                          <p:spTgt spid="836072507"/>
                                         </p:tgtEl>
                                         <p:attrNameLst>
                                           <p:attrName>style.visibility</p:attrName>
@@ -15955,7 +15071,7 @@
                                           </p:stCondLst>
                                         </p:cTn>
                                         <p:tgtEl>
-                                          <p:spTgt spid="111297844"/>
+                                          <p:spTgt spid="1112613856"/>
                                         </p:tgtEl>
                                         <p:attrNameLst>
                                           <p:attrName>style.visibility</p:attrName>
@@ -15982,7 +15098,7 @@
                                           </p:stCondLst>
                                         </p:cTn>
                                         <p:tgtEl>
-                                          <p:spTgt spid="1234485164"/>
+                                          <p:spTgt spid="1390678621"/>
                                         </p:tgtEl>
                                         <p:attrNameLst>
                                           <p:attrName>style.visibility</p:attrName>
@@ -16009,7 +15125,7 @@
                                           </p:stCondLst>
                                         </p:cTn>
                                         <p:tgtEl>
-                                          <p:spTgt spid="252508751"/>
+                                          <p:spTgt spid="105440149"/>
                                         </p:tgtEl>
                                         <p:attrNameLst>
                                           <p:attrName>style.visibility</p:attrName>
@@ -16036,7 +15152,7 @@
                                           </p:stCondLst>
                                         </p:cTn>
                                         <p:tgtEl>
-                                          <p:spTgt spid="2142934935"/>
+                                          <p:spTgt spid="752278344"/>
                                         </p:tgtEl>
                                         <p:attrNameLst>
                                           <p:attrName>style.visibility</p:attrName>
@@ -16063,7 +15179,7 @@
                                           </p:stCondLst>
                                         </p:cTn>
                                         <p:tgtEl>
-                                          <p:spTgt spid="1653497091"/>
+                                          <p:spTgt spid="2068228065"/>
                                         </p:tgtEl>
                                         <p:attrNameLst>
                                           <p:attrName>style.visibility</p:attrName>
@@ -16108,7 +15224,7 @@
                                           </p:stCondLst>
                                         </p:cTn>
                                         <p:tgtEl>
-                                          <p:spTgt spid="1722882232"/>
+                                          <p:spTgt spid="1768890528"/>
                                         </p:tgtEl>
                                         <p:attrNameLst>
                                           <p:attrName>style.visibility</p:attrName>
@@ -16135,7 +15251,7 @@
                                           </p:stCondLst>
                                         </p:cTn>
                                         <p:tgtEl>
-                                          <p:spTgt spid="1322786675"/>
+                                          <p:spTgt spid="1444717829"/>
                                         </p:tgtEl>
                                         <p:attrNameLst>
                                           <p:attrName>style.visibility</p:attrName>
@@ -16162,7 +15278,7 @@
                                           </p:stCondLst>
                                         </p:cTn>
                                         <p:tgtEl>
-                                          <p:spTgt spid="2069784037"/>
+                                          <p:spTgt spid="381750240"/>
                                         </p:tgtEl>
                                         <p:attrNameLst>
                                           <p:attrName>style.visibility</p:attrName>
@@ -16189,7 +15305,7 @@
                                           </p:stCondLst>
                                         </p:cTn>
                                         <p:tgtEl>
-                                          <p:spTgt spid="404858032"/>
+                                          <p:spTgt spid="1955084236"/>
                                         </p:tgtEl>
                                         <p:attrNameLst>
                                           <p:attrName>style.visibility</p:attrName>
@@ -16216,7 +15332,7 @@
                                           </p:stCondLst>
                                         </p:cTn>
                                         <p:tgtEl>
-                                          <p:spTgt spid="835523337"/>
+                                          <p:spTgt spid="1835174767"/>
                                         </p:tgtEl>
                                         <p:attrNameLst>
                                           <p:attrName>style.visibility</p:attrName>
@@ -16243,7 +15359,7 @@
                                           </p:stCondLst>
                                         </p:cTn>
                                         <p:tgtEl>
-                                          <p:spTgt spid="559933635"/>
+                                          <p:spTgt spid="1926333551"/>
                                         </p:tgtEl>
                                         <p:attrNameLst>
                                           <p:attrName>style.visibility</p:attrName>
@@ -16288,7 +15404,7 @@
                                           </p:stCondLst>
                                         </p:cTn>
                                         <p:tgtEl>
-                                          <p:spTgt spid="92068741"/>
+                                          <p:spTgt spid="769324132"/>
                                         </p:tgtEl>
                                         <p:attrNameLst>
                                           <p:attrName>style.visibility</p:attrName>
@@ -16315,7 +15431,7 @@
                                           </p:stCondLst>
                                         </p:cTn>
                                         <p:tgtEl>
-                                          <p:spTgt spid="69683310"/>
+                                          <p:spTgt spid="1156356201"/>
                                         </p:tgtEl>
                                         <p:attrNameLst>
                                           <p:attrName>style.visibility</p:attrName>
@@ -16342,7 +15458,7 @@
                                           </p:stCondLst>
                                         </p:cTn>
                                         <p:tgtEl>
-                                          <p:spTgt spid="715887746"/>
+                                          <p:spTgt spid="674644866"/>
                                         </p:tgtEl>
                                         <p:attrNameLst>
                                           <p:attrName>style.visibility</p:attrName>
@@ -16369,7 +15485,7 @@
                                           </p:stCondLst>
                                         </p:cTn>
                                         <p:tgtEl>
-                                          <p:spTgt spid="1018417685"/>
+                                          <p:spTgt spid="156902746"/>
                                         </p:tgtEl>
                                         <p:attrNameLst>
                                           <p:attrName>style.visibility</p:attrName>
@@ -16396,7 +15512,7 @@
                                           </p:stCondLst>
                                         </p:cTn>
                                         <p:tgtEl>
-                                          <p:spTgt spid="1938532900"/>
+                                          <p:spTgt spid="174499026"/>
                                         </p:tgtEl>
                                         <p:attrNameLst>
                                           <p:attrName>style.visibility</p:attrName>
@@ -16423,7 +15539,7 @@
                                           </p:stCondLst>
                                         </p:cTn>
                                         <p:tgtEl>
-                                          <p:spTgt spid="1762646398"/>
+                                          <p:spTgt spid="885986278"/>
                                         </p:tgtEl>
                                         <p:attrNameLst>
                                           <p:attrName>style.visibility</p:attrName>
@@ -16468,7 +15584,7 @@
                                           </p:stCondLst>
                                         </p:cTn>
                                         <p:tgtEl>
-                                          <p:spTgt spid="1561852062"/>
+                                          <p:spTgt spid="2143760685"/>
                                         </p:tgtEl>
                                         <p:attrNameLst>
                                           <p:attrName>style.visibility</p:attrName>
@@ -16495,7 +15611,7 @@
                                           </p:stCondLst>
                                         </p:cTn>
                                         <p:tgtEl>
-                                          <p:spTgt spid="8299947"/>
+                                          <p:spTgt spid="2010976889"/>
                                         </p:tgtEl>
                                         <p:attrNameLst>
                                           <p:attrName>style.visibility</p:attrName>
@@ -16522,7 +15638,7 @@
                                           </p:stCondLst>
                                         </p:cTn>
                                         <p:tgtEl>
-                                          <p:spTgt spid="947004339"/>
+                                          <p:spTgt spid="940956984"/>
                                         </p:tgtEl>
                                         <p:attrNameLst>
                                           <p:attrName>style.visibility</p:attrName>
@@ -16549,7 +15665,7 @@
                                           </p:stCondLst>
                                         </p:cTn>
                                         <p:tgtEl>
-                                          <p:spTgt spid="457911166"/>
+                                          <p:spTgt spid="447884114"/>
                                         </p:tgtEl>
                                         <p:attrNameLst>
                                           <p:attrName>style.visibility</p:attrName>
@@ -16619,7 +15735,7 @@
       </p:grpSpPr>
       <p:sp>
         <p:nvSpPr>
-          <p:cNvPr id="8621146" name="Text 0"/>
+          <p:cNvPr id="1716556361" name="Text 0"/>
           <p:cNvSpPr txBox="1"/>
           <p:nvPr/>
         </p:nvSpPr>
@@ -16669,7 +15785,7 @@
       </p:sp>
       <p:pic>
         <p:nvPicPr>
-          <p:cNvPr id="312695101" name="Image 0" descr="preencoded.png"/>
+          <p:cNvPr id="131087661" name="Image 0" descr="preencoded.png"/>
           <p:cNvPicPr>
             <a:picLocks noChangeAspect="1"/>
           </p:cNvPicPr>
@@ -16691,7 +15807,7 @@
       </p:pic>
       <p:sp>
         <p:nvSpPr>
-          <p:cNvPr id="1470488259" name="Text 1"/>
+          <p:cNvPr id="1686558748" name="Text 1"/>
           <p:cNvSpPr txBox="1"/>
           <p:nvPr/>
         </p:nvSpPr>
@@ -16735,7 +15851,7 @@
       </p:sp>
       <p:pic>
         <p:nvPicPr>
-          <p:cNvPr id="971982053" name="Image 2" descr="preencoded.png"/>
+          <p:cNvPr id="1963738726" name="Image 2" descr="preencoded.png"/>
           <p:cNvPicPr>
             <a:picLocks noChangeAspect="1"/>
           </p:cNvPicPr>
@@ -16757,7 +15873,7 @@
       </p:pic>
       <p:sp>
         <p:nvSpPr>
-          <p:cNvPr id="574501505" name="Text 2"/>
+          <p:cNvPr id="1081529949" name="Text 2"/>
           <p:cNvSpPr txBox="1"/>
           <p:nvPr/>
         </p:nvSpPr>
@@ -16802,7 +15918,7 @@
       </p:sp>
       <p:sp>
         <p:nvSpPr>
-          <p:cNvPr id="369544874" name="Text 3"/>
+          <p:cNvPr id="1762103586" name="Text 3"/>
           <p:cNvSpPr txBox="1"/>
           <p:nvPr/>
         </p:nvSpPr>
@@ -16844,7 +15960,7 @@
       </p:sp>
       <p:sp>
         <p:nvSpPr>
-          <p:cNvPr id="635701228" name="Text 4"/>
+          <p:cNvPr id="1830365342" name="Text 4"/>
           <p:cNvSpPr txBox="1"/>
           <p:nvPr/>
         </p:nvSpPr>
@@ -16888,7 +16004,7 @@
       </p:sp>
       <p:sp>
         <p:nvSpPr>
-          <p:cNvPr id="689246356" name="Text 5"/>
+          <p:cNvPr id="1437384791" name="Text 5"/>
           <p:cNvSpPr txBox="1"/>
           <p:nvPr/>
         </p:nvSpPr>
@@ -16930,7 +16046,7 @@
       </p:sp>
       <p:sp>
         <p:nvSpPr>
-          <p:cNvPr id="1315037875" name="Text 6"/>
+          <p:cNvPr id="571177989" name="Text 6"/>
           <p:cNvSpPr txBox="1"/>
           <p:nvPr/>
         </p:nvSpPr>
@@ -16974,7 +16090,7 @@
       </p:sp>
       <p:sp>
         <p:nvSpPr>
-          <p:cNvPr id="2112656944" name="Text 7"/>
+          <p:cNvPr id="875987204" name="Text 7"/>
           <p:cNvSpPr txBox="1"/>
           <p:nvPr/>
         </p:nvSpPr>
@@ -17016,7 +16132,7 @@
       </p:sp>
       <p:sp>
         <p:nvSpPr>
-          <p:cNvPr id="2135220451" name="Text 8"/>
+          <p:cNvPr id="2004627145" name="Text 8"/>
           <p:cNvSpPr txBox="1"/>
           <p:nvPr/>
         </p:nvSpPr>
@@ -17060,7 +16176,7 @@
       </p:sp>
       <p:pic>
         <p:nvPicPr>
-          <p:cNvPr id="268858643" name="Image 3" descr="preencoded.png"/>
+          <p:cNvPr id="1168177822" name="Image 3" descr="preencoded.png"/>
           <p:cNvPicPr>
             <a:picLocks noChangeAspect="1"/>
           </p:cNvPicPr>
@@ -17082,7 +16198,7 @@
       </p:pic>
       <p:sp>
         <p:nvSpPr>
-          <p:cNvPr id="1835634612" name="Text 9"/>
+          <p:cNvPr id="2139150615" name="Text 9"/>
           <p:cNvSpPr txBox="1"/>
           <p:nvPr/>
         </p:nvSpPr>
@@ -17127,7 +16243,7 @@
       </p:sp>
       <p:sp>
         <p:nvSpPr>
-          <p:cNvPr id="1947607598" name="Text 10"/>
+          <p:cNvPr id="2104935781" name="Text 10"/>
           <p:cNvSpPr txBox="1"/>
           <p:nvPr/>
         </p:nvSpPr>
@@ -17169,7 +16285,7 @@
       </p:sp>
       <p:sp>
         <p:nvSpPr>
-          <p:cNvPr id="742192842" name="Text 11"/>
+          <p:cNvPr id="841477213" name="Text 11"/>
           <p:cNvSpPr txBox="1"/>
           <p:nvPr/>
         </p:nvSpPr>
@@ -17213,7 +16329,7 @@
       </p:sp>
       <p:sp>
         <p:nvSpPr>
-          <p:cNvPr id="1966939335" name="Text 12"/>
+          <p:cNvPr id="1032513146" name="Text 12"/>
           <p:cNvSpPr txBox="1"/>
           <p:nvPr/>
         </p:nvSpPr>
@@ -17255,7 +16371,7 @@
       </p:sp>
       <p:sp>
         <p:nvSpPr>
-          <p:cNvPr id="1866619050" name="Text 13"/>
+          <p:cNvPr id="647274467" name="Text 13"/>
           <p:cNvSpPr txBox="1"/>
           <p:nvPr/>
         </p:nvSpPr>
@@ -17299,7 +16415,7 @@
       </p:sp>
       <p:sp>
         <p:nvSpPr>
-          <p:cNvPr id="851211810" name="Text 14"/>
+          <p:cNvPr id="1730441812" name="Text 14"/>
           <p:cNvSpPr txBox="1"/>
           <p:nvPr/>
         </p:nvSpPr>
@@ -17341,7 +16457,7 @@
       </p:sp>
       <p:sp>
         <p:nvSpPr>
-          <p:cNvPr id="1189482535" name="Text 15"/>
+          <p:cNvPr id="431294458" name="Text 15"/>
           <p:cNvSpPr txBox="1"/>
           <p:nvPr/>
         </p:nvSpPr>
@@ -17385,7 +16501,7 @@
       </p:sp>
       <p:pic>
         <p:nvPicPr>
-          <p:cNvPr id="1223170632" name="Image 4" descr="preencoded.png"/>
+          <p:cNvPr id="599228191" name="Image 4" descr="preencoded.png"/>
           <p:cNvPicPr>
             <a:picLocks noChangeAspect="1"/>
           </p:cNvPicPr>
@@ -17407,7 +16523,7 @@
       </p:pic>
       <p:sp>
         <p:nvSpPr>
-          <p:cNvPr id="673993549" name="Text 16"/>
+          <p:cNvPr id="1934513886" name="Text 16"/>
           <p:cNvSpPr txBox="1"/>
           <p:nvPr/>
         </p:nvSpPr>
@@ -17567,7 +16683,7 @@
                                           </p:stCondLst>
                                         </p:cTn>
                                         <p:tgtEl>
-                                          <p:spTgt spid="312695101"/>
+                                          <p:spTgt spid="131087661"/>
                                         </p:tgtEl>
                                         <p:attrNameLst>
                                           <p:attrName>style.visibility</p:attrName>
@@ -17594,7 +16710,7 @@
                                           </p:stCondLst>
                                         </p:cTn>
                                         <p:tgtEl>
-                                          <p:spTgt spid="1470488259"/>
+                                          <p:spTgt spid="1686558748"/>
                                         </p:tgtEl>
                                         <p:attrNameLst>
                                           <p:attrName>style.visibility</p:attrName>
@@ -17621,7 +16737,7 @@
                                           </p:stCondLst>
                                         </p:cTn>
                                         <p:tgtEl>
-                                          <p:spTgt spid="971982053"/>
+                                          <p:spTgt spid="1963738726"/>
                                         </p:tgtEl>
                                         <p:attrNameLst>
                                           <p:attrName>style.visibility</p:attrName>
@@ -17648,7 +16764,7 @@
                                           </p:stCondLst>
                                         </p:cTn>
                                         <p:tgtEl>
-                                          <p:spTgt spid="574501505"/>
+                                          <p:spTgt spid="1081529949"/>
                                         </p:tgtEl>
                                         <p:attrNameLst>
                                           <p:attrName>style.visibility</p:attrName>
@@ -17675,7 +16791,7 @@
                                           </p:stCondLst>
                                         </p:cTn>
                                         <p:tgtEl>
-                                          <p:spTgt spid="369544874"/>
+                                          <p:spTgt spid="1762103586"/>
                                         </p:tgtEl>
                                         <p:attrNameLst>
                                           <p:attrName>style.visibility</p:attrName>
@@ -17702,7 +16818,7 @@
                                           </p:stCondLst>
                                         </p:cTn>
                                         <p:tgtEl>
-                                          <p:spTgt spid="635701228"/>
+                                          <p:spTgt spid="1830365342"/>
                                         </p:tgtEl>
                                         <p:attrNameLst>
                                           <p:attrName>style.visibility</p:attrName>
@@ -17729,7 +16845,7 @@
                                           </p:stCondLst>
                                         </p:cTn>
                                         <p:tgtEl>
-                                          <p:spTgt spid="689246356"/>
+                                          <p:spTgt spid="1437384791"/>
                                         </p:tgtEl>
                                         <p:attrNameLst>
                                           <p:attrName>style.visibility</p:attrName>
@@ -17756,7 +16872,7 @@
                                           </p:stCondLst>
                                         </p:cTn>
                                         <p:tgtEl>
-                                          <p:spTgt spid="1315037875"/>
+                                          <p:spTgt spid="571177989"/>
                                         </p:tgtEl>
                                         <p:attrNameLst>
                                           <p:attrName>style.visibility</p:attrName>
@@ -17783,7 +16899,7 @@
                                           </p:stCondLst>
                                         </p:cTn>
                                         <p:tgtEl>
-                                          <p:spTgt spid="2112656944"/>
+                                          <p:spTgt spid="875987204"/>
                                         </p:tgtEl>
                                         <p:attrNameLst>
                                           <p:attrName>style.visibility</p:attrName>
@@ -17810,7 +16926,7 @@
                                           </p:stCondLst>
                                         </p:cTn>
                                         <p:tgtEl>
-                                          <p:spTgt spid="2135220451"/>
+                                          <p:spTgt spid="2004627145"/>
                                         </p:tgtEl>
                                         <p:attrNameLst>
                                           <p:attrName>style.visibility</p:attrName>
@@ -17837,7 +16953,7 @@
                                           </p:stCondLst>
                                         </p:cTn>
                                         <p:tgtEl>
-                                          <p:spTgt spid="268858643"/>
+                                          <p:spTgt spid="1168177822"/>
                                         </p:tgtEl>
                                         <p:attrNameLst>
                                           <p:attrName>style.visibility</p:attrName>
@@ -17864,7 +16980,7 @@
                                           </p:stCondLst>
                                         </p:cTn>
                                         <p:tgtEl>
-                                          <p:spTgt spid="1835634612"/>
+                                          <p:spTgt spid="2139150615"/>
                                         </p:tgtEl>
                                         <p:attrNameLst>
                                           <p:attrName>style.visibility</p:attrName>
@@ -17891,7 +17007,7 @@
                                           </p:stCondLst>
                                         </p:cTn>
                                         <p:tgtEl>
-                                          <p:spTgt spid="1947607598"/>
+                                          <p:spTgt spid="2104935781"/>
                                         </p:tgtEl>
                                         <p:attrNameLst>
                                           <p:attrName>style.visibility</p:attrName>
@@ -17918,7 +17034,7 @@
                                           </p:stCondLst>
                                         </p:cTn>
                                         <p:tgtEl>
-                                          <p:spTgt spid="742192842"/>
+                                          <p:spTgt spid="841477213"/>
                                         </p:tgtEl>
                                         <p:attrNameLst>
                                           <p:attrName>style.visibility</p:attrName>
@@ -17945,7 +17061,7 @@
                                           </p:stCondLst>
                                         </p:cTn>
                                         <p:tgtEl>
-                                          <p:spTgt spid="1966939335"/>
+                                          <p:spTgt spid="1032513146"/>
                                         </p:tgtEl>
                                         <p:attrNameLst>
                                           <p:attrName>style.visibility</p:attrName>
@@ -17972,7 +17088,7 @@
                                           </p:stCondLst>
                                         </p:cTn>
                                         <p:tgtEl>
-                                          <p:spTgt spid="1866619050"/>
+                                          <p:spTgt spid="647274467"/>
                                         </p:tgtEl>
                                         <p:attrNameLst>
                                           <p:attrName>style.visibility</p:attrName>
@@ -17999,7 +17115,7 @@
                                           </p:stCondLst>
                                         </p:cTn>
                                         <p:tgtEl>
-                                          <p:spTgt spid="851211810"/>
+                                          <p:spTgt spid="1730441812"/>
                                         </p:tgtEl>
                                         <p:attrNameLst>
                                           <p:attrName>style.visibility</p:attrName>
@@ -18026,7 +17142,7 @@
                                           </p:stCondLst>
                                         </p:cTn>
                                         <p:tgtEl>
-                                          <p:spTgt spid="1189482535"/>
+                                          <p:spTgt spid="431294458"/>
                                         </p:tgtEl>
                                         <p:attrNameLst>
                                           <p:attrName>style.visibility</p:attrName>
@@ -18053,7 +17169,7 @@
                                           </p:stCondLst>
                                         </p:cTn>
                                         <p:tgtEl>
-                                          <p:spTgt spid="1223170632"/>
+                                          <p:spTgt spid="599228191"/>
                                         </p:tgtEl>
                                         <p:attrNameLst>
                                           <p:attrName>style.visibility</p:attrName>
@@ -18080,7 +17196,7 @@
                                           </p:stCondLst>
                                         </p:cTn>
                                         <p:tgtEl>
-                                          <p:spTgt spid="673993549"/>
+                                          <p:spTgt spid="1934513886"/>
                                         </p:tgtEl>
                                         <p:attrNameLst>
                                           <p:attrName>style.visibility</p:attrName>

</xml_diff>